<commit_message>
Finalize verified presentation, demo links and submission material
</commit_message>
<xml_diff>
--- a/deliverables/ascension-smartwalk-presentation.pptx
+++ b/deliverables/ascension-smartwalk-presentation.pptx
@@ -2,21 +2,21 @@
 <file path=ppt/presentation.xml><?xml version="1.0" encoding="utf-8"?>
 <p:presentation xmlns:p="http://schemas.openxmlformats.org/presentationml/2006/main">
   <p:sldMasterIdLst>
-    <p:sldMasterId xmlns:r="http://schemas.openxmlformats.org/officeDocument/2006/relationships" id="2147483648" r:id="Re7c4dc1228954d87"/>
+    <p:sldMasterId xmlns:r="http://schemas.openxmlformats.org/officeDocument/2006/relationships" id="2147483648" r:id="R14d6b2441496423d"/>
   </p:sldMasterIdLst>
   <p:notesMasterIdLst>
-    <p:notesMasterId xmlns:r="http://schemas.openxmlformats.org/officeDocument/2006/relationships" r:id="R554ee31b57794843"/>
+    <p:notesMasterId xmlns:r="http://schemas.openxmlformats.org/officeDocument/2006/relationships" r:id="R78750bb827e44482"/>
   </p:notesMasterIdLst>
   <p:sldIdLst>
-    <p:sldId xmlns:r="http://schemas.openxmlformats.org/officeDocument/2006/relationships" id="256" r:id="Re096f1b18d5f44a0"/>
-    <p:sldId xmlns:r="http://schemas.openxmlformats.org/officeDocument/2006/relationships" id="257" r:id="Ra4713967da78424f"/>
-    <p:sldId xmlns:r="http://schemas.openxmlformats.org/officeDocument/2006/relationships" id="258" r:id="R1a4ea1990c5745b8"/>
-    <p:sldId xmlns:r="http://schemas.openxmlformats.org/officeDocument/2006/relationships" id="259" r:id="Rd2285ee99276410d"/>
-    <p:sldId xmlns:r="http://schemas.openxmlformats.org/officeDocument/2006/relationships" id="260" r:id="R4fa5003d36624cac"/>
-    <p:sldId xmlns:r="http://schemas.openxmlformats.org/officeDocument/2006/relationships" id="261" r:id="Rfe2e79cbfa0c4b83"/>
-    <p:sldId xmlns:r="http://schemas.openxmlformats.org/officeDocument/2006/relationships" id="262" r:id="R46e7b5eeeee647ea"/>
-    <p:sldId xmlns:r="http://schemas.openxmlformats.org/officeDocument/2006/relationships" id="263" r:id="Rc6ffb30aa8ba4979"/>
-    <p:sldId xmlns:r="http://schemas.openxmlformats.org/officeDocument/2006/relationships" id="264" r:id="Rf7937118845a4cfc"/>
+    <p:sldId xmlns:r="http://schemas.openxmlformats.org/officeDocument/2006/relationships" id="256" r:id="R4dbb6e5de8dd4ec9"/>
+    <p:sldId xmlns:r="http://schemas.openxmlformats.org/officeDocument/2006/relationships" id="257" r:id="R28884a0682a649aa"/>
+    <p:sldId xmlns:r="http://schemas.openxmlformats.org/officeDocument/2006/relationships" id="258" r:id="Rffc2f8b3b85a4990"/>
+    <p:sldId xmlns:r="http://schemas.openxmlformats.org/officeDocument/2006/relationships" id="259" r:id="Rc27e0b21ec3d4ba2"/>
+    <p:sldId xmlns:r="http://schemas.openxmlformats.org/officeDocument/2006/relationships" id="260" r:id="R5dfda73df4f44101"/>
+    <p:sldId xmlns:r="http://schemas.openxmlformats.org/officeDocument/2006/relationships" id="261" r:id="R84c79e3088014bb7"/>
+    <p:sldId xmlns:r="http://schemas.openxmlformats.org/officeDocument/2006/relationships" id="262" r:id="Ra5ee2e7d267748e1"/>
+    <p:sldId xmlns:r="http://schemas.openxmlformats.org/officeDocument/2006/relationships" id="263" r:id="Re85455043cdf4750"/>
+    <p:sldId xmlns:r="http://schemas.openxmlformats.org/officeDocument/2006/relationships" id="264" r:id="R5a88a626144e444f"/>
   </p:sldIdLst>
   <p:sldSz cx="12192000" cy="6858000"/>
   <p:notesSz cx="6858000" cy="9144000"/>
@@ -660,7 +660,7 @@
           <a:lstStyle xmlns:a="http://schemas.openxmlformats.org/drawingml/2006/main"/>
           <a:p xmlns:a="http://schemas.openxmlformats.org/drawingml/2006/main">
             <a:r>
-              <a:t>1:55-2:45. RAG означает получение подходящих записей из базы и использование этих записей при формировании ответа. Архитектурный замысел, пока интеграция продолжается: автоматический OSM-сбор, поиск кандидатов, проверка ограничений, объяснение с помощью OpenAI API. Не заявлять embeddings, reranker, размер базы или успешный API-вызов без подтверждения команды. Источник данных по плану: https://www.openstreetmap.org/copyright. Правила атрибуции: https://osmfoundation.org/wiki/Attribution_Guidelines.</a:t>
+              <a:t>1:55-2:45. Итог data-чата: 930 канонических POI, 933 исходных OSM-объекта полностью сохранены в sourceRecords/osmIds/provenance, raw 1480. Из пяти кандидатных пар три подтверждены и объединены: MEGA, CoffeeStories, Ататюрк. CoffeeLike подтверждён как две разные точки по прямому комментарию OSM-маппера. ШашлычОк неоднозначен, объекты разных зданий оставлены раздельно. Абсолютное отсутствие дублей не заявляется. Категории: 318 кафе, 176 ресторанов, 34 парка, 8 музеев, 1 именованная площадка. Покрытие: EXPO/Mega 52, левый центр 226, исторический центр 256. Снимок данных 19.10.2026 11:22 UTC. Поиск лексический, без embeddings. Vanilla JS, Node API, Cloudflare Worker/OpenAI Responses/gpt-4.1-mini. Основная команда подтвердила реальный облачный POST 200 с generation.mode=llm, моделью gpt-4.1-mini и корпусом 930 POI. Это подтверждает проверенный вызов, а не безошибочность всех будущих ответов. Источник данных https://www.openstreetmap.org/copyright. Правила атрибуции https://osmfoundation.org/wiki/Attribution_Guidelines.</a:t>
             </a:r>
           </a:p>
         </p:txBody>
@@ -730,7 +730,7 @@
           <a:lstStyle xmlns:a="http://schemas.openxmlformats.org/drawingml/2006/main"/>
           <a:p xmlns:a="http://schemas.openxmlformats.org/drawingml/2006/main">
             <a:r>
-              <a:t>2:45-3:30. На живом демо выбрать точку Mega и 45 минут, затем показать конкретную карточку, ссылку на POI и бюджет. Этот слайд содержит вход и критерии, а не снимок работающего продукта. Если сайт недоступен, показать запись фактического прогона. Не выдавать иллюстрацию за runtime.</a:t>
+              <a:t>2:45-3:30. Финальный подлинный coffee-results.png предоставлен основной командой после уточнения входа D MEGA. Gasteria и Starbucks около 31 минуты, Лепим и варим около 33 минут с возвращением и резервом. Одно разложение времени нельзя фиксировать для всех кафе. Полный снимок сохранён в deliverables/screenshots, на слайде увеличен верх карточек для читаемости. Время оценено по расстоянию, без построения пешеходного маршрута. Удалённый generation.mode=llm фактически подтверждён на coffee и child.</a:t>
             </a:r>
           </a:p>
         </p:txBody>
@@ -800,7 +800,7 @@
           <a:lstStyle xmlns:a="http://schemas.openxmlformats.org/drawingml/2006/main"/>
           <a:p xmlns:a="http://schemas.openxmlformats.org/drawingml/2006/main">
             <a:r>
-              <a:t>3:30-4:10. Условие не более 10 минут относится к пути до места и применяется до генерации объяснения. Полный бюджет остаётся ограничен доступным окном. Категория площадки или музея не подтверждает возрастную пригодность, наличие пандуса или состояние оборудования. Это следует показывать как неизвестное, если нет источника.</a:t>
+              <a:t>3:30-4:10. Финальный детский сценарий дал один реальный Сквер, OSM way230358854: 10 минут туда, 15 визит, 10 обратно, 5 резерв, всего 40 минут в бюджете 60. Источник подтверждён полным evidence.png, категория park. Generation.mode=llm подтверждён основной командой на child. Условие не более 10 минут относится к пути до места. Возрастная пригодность, безопасность, пандусы и оборудование не подтверждены и остаются неизвестными. Снимки child.png и evidence.png сохранены в deliverables/screenshots.</a:t>
             </a:r>
           </a:p>
         </p:txBody>
@@ -940,7 +940,7 @@
           <a:lstStyle xmlns:a="http://schemas.openxmlformats.org/drawingml/2006/main"/>
           <a:p xmlns:a="http://schemas.openxmlformats.org/drawingml/2006/main">
             <a:r>
-              <a:t>4:50-5:35. Это обязательства проекта и предмет приёмки, не аудиторское подтверждение реализованной privacy-политики. Не обещать отсутствие логирования или передачу только округлённых координат без проверки. Точные запросы к модели и политика хранения должны соответствовать реализации. В приложенном документе описаны проверки источников, пустой выдачи, географии, пропусков данных, ограничений и приватности.</a:t>
+              <a:t>4:50-5:35. По подтверждению основной команды пройдены 23 из 23 автотестов: поиск и API, а также проверки privacy, лимитов и отбрасывания неподтверждённых утверждений модели. Это не полный прогон 12 сценариев приёмки T01-T12: mapping ещё не передан. Реальный облачный POST 200 с generation.mode=llm подтверждён. Три колонки показывают ограничения и проектные меры, не аудиторское подтверждение privacy-политики. Не обещать отсутствие логирования без проверки.</a:t>
             </a:r>
           </a:p>
         </p:txBody>
@@ -1010,7 +1010,7 @@
           <a:lstStyle xmlns:a="http://schemas.openxmlformats.org/drawingml/2006/main"/>
           <a:p xmlns:a="http://schemas.openxmlformats.org/drawingml/2006/main">
             <a:r>
-              <a:t>5:35-6:20. Бизнес-гипотеза: полезный сервис для жителей и гостей с коротким свободным окном. Возможные партнёры для будущей проверки спроса: кампусы и места размещения гостей, а не заключённые партнёрства. Последовательность: завершить демо и проверки, улучшить качество полей и времени пути, провести пилот. Не заявлять выручку, пользователей, экономию или доказанное соответствие реальной длительности маршрута. Финал: человек получает место, понятный план и время на возвращение.</a:t>
+              <a:t>5:35-6:20. Бизнес-гипотеза: полезный сервис для жителей и гостей с коротким свободным окном. Возможные партнёры: кампусы и места размещения гостей, договорённости не заявляются. Улучшить качество полей и времени пути, провести пилот. Не заявлять выручку, пользователей или измеренную длительность маршрутов. URL работает без логина по подтверждению основной команды: https://ascension-smartwalk-astana.azamatbreach.chatgpt.site . Облачный POST 200 с generation.mode=llm подтверждён. Исходный код опубликован: https://github.com/Azalytical/ascension-smartwalk, публичная структура с src/tests/data/docs/deliverables и README проверена через GitHub 19.10.2026. На защите использовать фактический прогон или его подлинную запись.</a:t>
             </a:r>
           </a:p>
         </p:txBody>
@@ -1057,7 +1057,7 @@
           <p:cNvPr id="3" name="Title">
             <a:extLst xmlns:a="http://schemas.openxmlformats.org/drawingml/2006/main">
               <a:ext uri="{FF2B5EF4-FFF2-40B4-BE49-F238E27FC236}">
-                <a16:creationId xmlns:a16="http://schemas.microsoft.com/office/drawing/2014/main" id="{9042F226-7D7E-49BB-9C3E-35C6092966FA}"/>
+                <a16:creationId xmlns:a16="http://schemas.microsoft.com/office/drawing/2014/main" id="{BE8D9381-1289-409F-9D72-21B0B902161D}"/>
               </a:ext>
             </a:extLst>
           </p:cNvPr>
@@ -1286,7 +1286,7 @@
           <p:cNvPr id="2" name="Subtitle">
             <a:extLst xmlns:a="http://schemas.openxmlformats.org/drawingml/2006/main">
               <a:ext uri="{FF2B5EF4-FFF2-40B4-BE49-F238E27FC236}">
-                <a16:creationId xmlns:a16="http://schemas.microsoft.com/office/drawing/2014/main" id="{0EB39605-D711-4D68-8D45-93087CA13B25}"/>
+                <a16:creationId xmlns:a16="http://schemas.microsoft.com/office/drawing/2014/main" id="{8B2AC4CF-FEB6-4375-8D3F-C0EF5D195A70}"/>
               </a:ext>
             </a:extLst>
           </p:cNvPr>
@@ -1532,7 +1532,7 @@
           <p:cNvPr id="2" name="Section title">
             <a:extLst xmlns:a="http://schemas.openxmlformats.org/drawingml/2006/main">
               <a:ext uri="{FF2B5EF4-FFF2-40B4-BE49-F238E27FC236}">
-                <a16:creationId xmlns:a16="http://schemas.microsoft.com/office/drawing/2014/main" id="{402B5E25-504F-486F-AFD4-94EB3CB9FDB1}"/>
+                <a16:creationId xmlns:a16="http://schemas.microsoft.com/office/drawing/2014/main" id="{8EC2FB76-7657-42E8-A049-123F127AB53E}"/>
               </a:ext>
             </a:extLst>
           </p:cNvPr>
@@ -1778,7 +1778,7 @@
           <p:cNvPr id="3" name="Title">
             <a:extLst xmlns:a="http://schemas.openxmlformats.org/drawingml/2006/main">
               <a:ext uri="{FF2B5EF4-FFF2-40B4-BE49-F238E27FC236}">
-                <a16:creationId xmlns:a16="http://schemas.microsoft.com/office/drawing/2014/main" id="{E5640F95-8D4C-4F57-A3BB-DDF881C46810}"/>
+                <a16:creationId xmlns:a16="http://schemas.microsoft.com/office/drawing/2014/main" id="{4583288B-8B94-4CAC-9523-9BFBBBDA7150}"/>
               </a:ext>
             </a:extLst>
           </p:cNvPr>
@@ -2007,7 +2007,7 @@
           <p:cNvPr id="2" name="Body">
             <a:extLst xmlns:a="http://schemas.openxmlformats.org/drawingml/2006/main">
               <a:ext uri="{FF2B5EF4-FFF2-40B4-BE49-F238E27FC236}">
-                <a16:creationId xmlns:a16="http://schemas.microsoft.com/office/drawing/2014/main" id="{F1C6C5FB-4E08-4F71-BF75-F9E1F253F9AE}"/>
+                <a16:creationId xmlns:a16="http://schemas.microsoft.com/office/drawing/2014/main" id="{DED6D4F2-A898-4A4A-AE04-0BAADB70CC8E}"/>
               </a:ext>
             </a:extLst>
           </p:cNvPr>
@@ -2253,7 +2253,7 @@
           <p:cNvPr id="4" name="Title">
             <a:extLst xmlns:a="http://schemas.openxmlformats.org/drawingml/2006/main">
               <a:ext uri="{FF2B5EF4-FFF2-40B4-BE49-F238E27FC236}">
-                <a16:creationId xmlns:a16="http://schemas.microsoft.com/office/drawing/2014/main" id="{6C728D32-1473-4B33-B89D-A5DC17633A81}"/>
+                <a16:creationId xmlns:a16="http://schemas.microsoft.com/office/drawing/2014/main" id="{6C00E77F-6C47-4D1C-97E2-B851D1DF1FBB}"/>
               </a:ext>
             </a:extLst>
           </p:cNvPr>
@@ -2482,7 +2482,7 @@
           <p:cNvPr id="2" name="Left column">
             <a:extLst xmlns:a="http://schemas.openxmlformats.org/drawingml/2006/main">
               <a:ext uri="{FF2B5EF4-FFF2-40B4-BE49-F238E27FC236}">
-                <a16:creationId xmlns:a16="http://schemas.microsoft.com/office/drawing/2014/main" id="{84AF3DC5-F1B0-4803-A0D1-F058467E0269}"/>
+                <a16:creationId xmlns:a16="http://schemas.microsoft.com/office/drawing/2014/main" id="{6F93DED1-4FB3-449F-AC61-8E1BE8D7466B}"/>
               </a:ext>
             </a:extLst>
           </p:cNvPr>
@@ -2711,7 +2711,7 @@
           <p:cNvPr id="3" name="Right column">
             <a:extLst xmlns:a="http://schemas.openxmlformats.org/drawingml/2006/main">
               <a:ext uri="{FF2B5EF4-FFF2-40B4-BE49-F238E27FC236}">
-                <a16:creationId xmlns:a16="http://schemas.microsoft.com/office/drawing/2014/main" id="{3B9C10E3-CAEE-4911-9B53-F9925D88ED64}"/>
+                <a16:creationId xmlns:a16="http://schemas.microsoft.com/office/drawing/2014/main" id="{D3D1A264-C998-4604-A6DC-24F315F5AE7C}"/>
               </a:ext>
             </a:extLst>
           </p:cNvPr>
@@ -2957,7 +2957,7 @@
           <p:cNvPr id="3" name="Title">
             <a:extLst xmlns:a="http://schemas.openxmlformats.org/drawingml/2006/main">
               <a:ext uri="{FF2B5EF4-FFF2-40B4-BE49-F238E27FC236}">
-                <a16:creationId xmlns:a16="http://schemas.microsoft.com/office/drawing/2014/main" id="{115BF6A8-EE01-4246-B861-256D4BBA4450}"/>
+                <a16:creationId xmlns:a16="http://schemas.microsoft.com/office/drawing/2014/main" id="{8AD97052-9ECD-413E-AEB3-59BBCED1228C}"/>
               </a:ext>
             </a:extLst>
           </p:cNvPr>
@@ -3186,7 +3186,7 @@
           <p:cNvPr id="2" name="Left column">
             <a:extLst xmlns:a="http://schemas.openxmlformats.org/drawingml/2006/main">
               <a:ext uri="{FF2B5EF4-FFF2-40B4-BE49-F238E27FC236}">
-                <a16:creationId xmlns:a16="http://schemas.microsoft.com/office/drawing/2014/main" id="{9D5B6B9E-C242-4440-ABA2-DC39FF4EF535}"/>
+                <a16:creationId xmlns:a16="http://schemas.microsoft.com/office/drawing/2014/main" id="{9929EB89-48C9-414D-A1E9-463B2F0C4FE1}"/>
               </a:ext>
             </a:extLst>
           </p:cNvPr>
@@ -3453,12 +3453,12 @@
   </p:cSld>
   <p:clrMap bg1="lt1" tx1="dk1" bg2="lt2" tx2="dk2" accent1="accent1" accent2="accent2" accent3="accent3" accent4="accent4" accent5="accent5" accent6="accent6" hlink="hlink" folHlink="folHlink"/>
   <p:sldLayoutIdLst>
-    <p:sldLayoutId xmlns:r="http://schemas.openxmlformats.org/officeDocument/2006/relationships" id="2147483649" r:id="R99eb950d97ef4333"/>
-    <p:sldLayoutId xmlns:r="http://schemas.openxmlformats.org/officeDocument/2006/relationships" id="2147483650" r:id="R6cf61a47f4874275"/>
-    <p:sldLayoutId xmlns:r="http://schemas.openxmlformats.org/officeDocument/2006/relationships" id="2147483651" r:id="Rd0290a3e063a4bf6"/>
-    <p:sldLayoutId xmlns:r="http://schemas.openxmlformats.org/officeDocument/2006/relationships" id="2147483652" r:id="Redc40100b53f4ba0"/>
-    <p:sldLayoutId xmlns:r="http://schemas.openxmlformats.org/officeDocument/2006/relationships" id="2147483653" r:id="R66a23354f0054083"/>
-    <p:sldLayoutId xmlns:r="http://schemas.openxmlformats.org/officeDocument/2006/relationships" id="2147483654" r:id="R21f278fcf0994739"/>
+    <p:sldLayoutId xmlns:r="http://schemas.openxmlformats.org/officeDocument/2006/relationships" id="2147483649" r:id="R81effb2b59604486"/>
+    <p:sldLayoutId xmlns:r="http://schemas.openxmlformats.org/officeDocument/2006/relationships" id="2147483650" r:id="R346ea8932e534d0d"/>
+    <p:sldLayoutId xmlns:r="http://schemas.openxmlformats.org/officeDocument/2006/relationships" id="2147483651" r:id="R93fd18dcfad64aa1"/>
+    <p:sldLayoutId xmlns:r="http://schemas.openxmlformats.org/officeDocument/2006/relationships" id="2147483652" r:id="Rc10d399169bf4332"/>
+    <p:sldLayoutId xmlns:r="http://schemas.openxmlformats.org/officeDocument/2006/relationships" id="2147483653" r:id="R8e3fc74ccd4f40ea"/>
+    <p:sldLayoutId xmlns:r="http://schemas.openxmlformats.org/officeDocument/2006/relationships" id="2147483654" r:id="R2c3554f4e9c14865"/>
   </p:sldLayoutIdLst>
   <p:txStyles>
     <p:titleStyle>
@@ -4009,7 +4009,7 @@
           <p:cNvPr id="44" name="">
             <a:extLst xmlns:a="http://schemas.openxmlformats.org/drawingml/2006/main">
               <a:ext uri="{FF2B5EF4-FFF2-40B4-BE49-F238E27FC236}">
-                <a16:creationId xmlns:a16="http://schemas.microsoft.com/office/drawing/2014/main" id="{399CED90-E55B-47C1-928C-6F60C487D8B9}"/>
+                <a16:creationId xmlns:a16="http://schemas.microsoft.com/office/drawing/2014/main" id="{4A499D3A-F63C-4D39-A4EF-558D2AC834AA}"/>
               </a:ext>
             </a:extLst>
           </p:cNvPr>
@@ -4049,7 +4049,7 @@
           <p:cNvPr id="2" name="ASCENSION">
             <a:extLst xmlns:a="http://schemas.openxmlformats.org/drawingml/2006/main">
               <a:ext uri="{FF2B5EF4-FFF2-40B4-BE49-F238E27FC236}">
-                <a16:creationId xmlns:a16="http://schemas.microsoft.com/office/drawing/2014/main" id="{998D99A1-E235-4B46-A39F-CE349A9B9F76}"/>
+                <a16:creationId xmlns:a16="http://schemas.microsoft.com/office/drawing/2014/main" id="{81573065-6B41-47FC-B6ED-13BCF161EF7B}"/>
               </a:ext>
             </a:extLst>
           </p:cNvPr>
@@ -4212,7 +4212,7 @@
           <p:cNvPr id="3" name="01">
             <a:extLst xmlns:a="http://schemas.openxmlformats.org/drawingml/2006/main">
               <a:ext uri="{FF2B5EF4-FFF2-40B4-BE49-F238E27FC236}">
-                <a16:creationId xmlns:a16="http://schemas.microsoft.com/office/drawing/2014/main" id="{7D4FF2E9-D68B-4627-B773-849CB31BAD69}"/>
+                <a16:creationId xmlns:a16="http://schemas.microsoft.com/office/drawing/2014/main" id="{594C8BEF-1A81-44B1-BF04-EA8D68D7C819}"/>
               </a:ext>
             </a:extLst>
           </p:cNvPr>
@@ -4375,7 +4375,7 @@
           <p:cNvPr id="4" name="">
             <a:extLst xmlns:a="http://schemas.openxmlformats.org/drawingml/2006/main">
               <a:ext uri="{FF2B5EF4-FFF2-40B4-BE49-F238E27FC236}">
-                <a16:creationId xmlns:a16="http://schemas.microsoft.com/office/drawing/2014/main" id="{C4297621-CB58-4B04-9C36-BE7C1E0E5381}"/>
+                <a16:creationId xmlns:a16="http://schemas.microsoft.com/office/drawing/2014/main" id="{10BE21D4-9433-484E-8FCC-C799AC3E295F}"/>
               </a:ext>
             </a:extLst>
           </p:cNvPr>
@@ -4415,7 +4415,7 @@
           <p:cNvPr id="5" name="">
             <a:extLst xmlns:a="http://schemas.openxmlformats.org/drawingml/2006/main">
               <a:ext uri="{FF2B5EF4-FFF2-40B4-BE49-F238E27FC236}">
-                <a16:creationId xmlns:a16="http://schemas.microsoft.com/office/drawing/2014/main" id="{7BA86ECD-712A-4093-83F0-FF7F45423D65}"/>
+                <a16:creationId xmlns:a16="http://schemas.microsoft.com/office/drawing/2014/main" id="{90CC129B-5508-4D54-AE1A-A75633594303}"/>
               </a:ext>
             </a:extLst>
           </p:cNvPr>
@@ -4455,7 +4455,7 @@
           <p:cNvPr id="6" name="">
             <a:extLst xmlns:a="http://schemas.openxmlformats.org/drawingml/2006/main">
               <a:ext uri="{FF2B5EF4-FFF2-40B4-BE49-F238E27FC236}">
-                <a16:creationId xmlns:a16="http://schemas.microsoft.com/office/drawing/2014/main" id="{B3317D0E-133F-4592-AA8A-1950CDC4223E}"/>
+                <a16:creationId xmlns:a16="http://schemas.microsoft.com/office/drawing/2014/main" id="{B9145251-6F3D-4A82-B39B-7C3CE328BFCF}"/>
               </a:ext>
             </a:extLst>
           </p:cNvPr>
@@ -4495,7 +4495,7 @@
           <p:cNvPr id="7" name="">
             <a:extLst xmlns:a="http://schemas.openxmlformats.org/drawingml/2006/main">
               <a:ext uri="{FF2B5EF4-FFF2-40B4-BE49-F238E27FC236}">
-                <a16:creationId xmlns:a16="http://schemas.microsoft.com/office/drawing/2014/main" id="{D69CD82E-E827-49E2-B96B-2CB87FB0453A}"/>
+                <a16:creationId xmlns:a16="http://schemas.microsoft.com/office/drawing/2014/main" id="{8F77CEB2-F674-45A8-9CAD-EBE73368DD57}"/>
               </a:ext>
             </a:extLst>
           </p:cNvPr>
@@ -4535,7 +4535,7 @@
           <p:cNvPr id="8" name="">
             <a:extLst xmlns:a="http://schemas.openxmlformats.org/drawingml/2006/main">
               <a:ext uri="{FF2B5EF4-FFF2-40B4-BE49-F238E27FC236}">
-                <a16:creationId xmlns:a16="http://schemas.microsoft.com/office/drawing/2014/main" id="{0A7B6BBF-7973-4898-B59E-05EE0957E6B9}"/>
+                <a16:creationId xmlns:a16="http://schemas.microsoft.com/office/drawing/2014/main" id="{312A646B-C7AB-4ECF-A547-6482A3E62828}"/>
               </a:ext>
             </a:extLst>
           </p:cNvPr>
@@ -4575,7 +4575,7 @@
           <p:cNvPr id="9" name="">
             <a:extLst xmlns:a="http://schemas.openxmlformats.org/drawingml/2006/main">
               <a:ext uri="{FF2B5EF4-FFF2-40B4-BE49-F238E27FC236}">
-                <a16:creationId xmlns:a16="http://schemas.microsoft.com/office/drawing/2014/main" id="{32044AA1-9C9E-40C3-A0BB-D99164997656}"/>
+                <a16:creationId xmlns:a16="http://schemas.microsoft.com/office/drawing/2014/main" id="{AA1C7F11-2BDE-4CEA-9940-D50D75A9984A}"/>
               </a:ext>
             </a:extLst>
           </p:cNvPr>
@@ -4615,7 +4615,7 @@
           <p:cNvPr id="10" name="">
             <a:extLst xmlns:a="http://schemas.openxmlformats.org/drawingml/2006/main">
               <a:ext uri="{FF2B5EF4-FFF2-40B4-BE49-F238E27FC236}">
-                <a16:creationId xmlns:a16="http://schemas.microsoft.com/office/drawing/2014/main" id="{BD249CAC-1EAC-4CF0-BF35-E49458B4EC09}"/>
+                <a16:creationId xmlns:a16="http://schemas.microsoft.com/office/drawing/2014/main" id="{8C9B457B-25E2-4550-9047-49F7AB3D80AD}"/>
               </a:ext>
             </a:extLst>
           </p:cNvPr>
@@ -4655,7 +4655,7 @@
           <p:cNvPr id="11" name="">
             <a:extLst xmlns:a="http://schemas.openxmlformats.org/drawingml/2006/main">
               <a:ext uri="{FF2B5EF4-FFF2-40B4-BE49-F238E27FC236}">
-                <a16:creationId xmlns:a16="http://schemas.microsoft.com/office/drawing/2014/main" id="{A149C3F9-2F7F-42D2-BBD3-211D0C94125F}"/>
+                <a16:creationId xmlns:a16="http://schemas.microsoft.com/office/drawing/2014/main" id="{34714C3D-A39C-4E17-94E3-593DB6A2517A}"/>
               </a:ext>
             </a:extLst>
           </p:cNvPr>
@@ -4695,7 +4695,7 @@
           <p:cNvPr id="12" name="">
             <a:extLst xmlns:a="http://schemas.openxmlformats.org/drawingml/2006/main">
               <a:ext uri="{FF2B5EF4-FFF2-40B4-BE49-F238E27FC236}">
-                <a16:creationId xmlns:a16="http://schemas.microsoft.com/office/drawing/2014/main" id="{21C2F98B-3C01-4AAF-8802-B563F2E01A06}"/>
+                <a16:creationId xmlns:a16="http://schemas.microsoft.com/office/drawing/2014/main" id="{A911A89D-E90B-41D7-A1CF-324DA0F5E818}"/>
               </a:ext>
             </a:extLst>
           </p:cNvPr>
@@ -4735,7 +4735,7 @@
           <p:cNvPr id="13" name="">
             <a:extLst xmlns:a="http://schemas.openxmlformats.org/drawingml/2006/main">
               <a:ext uri="{FF2B5EF4-FFF2-40B4-BE49-F238E27FC236}">
-                <a16:creationId xmlns:a16="http://schemas.microsoft.com/office/drawing/2014/main" id="{61A12356-2E92-4E9E-BB8E-8ACAC242C9A3}"/>
+                <a16:creationId xmlns:a16="http://schemas.microsoft.com/office/drawing/2014/main" id="{0F28D6F1-6C7F-4C70-BD2B-839FE1913220}"/>
               </a:ext>
             </a:extLst>
           </p:cNvPr>
@@ -4775,7 +4775,7 @@
           <p:cNvPr id="14" name="">
             <a:extLst xmlns:a="http://schemas.openxmlformats.org/drawingml/2006/main">
               <a:ext uri="{FF2B5EF4-FFF2-40B4-BE49-F238E27FC236}">
-                <a16:creationId xmlns:a16="http://schemas.microsoft.com/office/drawing/2014/main" id="{34D27E3E-23DD-4111-824B-6D9AB51F2059}"/>
+                <a16:creationId xmlns:a16="http://schemas.microsoft.com/office/drawing/2014/main" id="{4A48C219-36B2-48ED-8589-1B813B07B1E3}"/>
               </a:ext>
             </a:extLst>
           </p:cNvPr>
@@ -4815,7 +4815,7 @@
           <p:cNvPr id="15" name="">
             <a:extLst xmlns:a="http://schemas.openxmlformats.org/drawingml/2006/main">
               <a:ext uri="{FF2B5EF4-FFF2-40B4-BE49-F238E27FC236}">
-                <a16:creationId xmlns:a16="http://schemas.microsoft.com/office/drawing/2014/main" id="{7E8B1C24-A8BA-4BD1-9E35-B5A3BDB69155}"/>
+                <a16:creationId xmlns:a16="http://schemas.microsoft.com/office/drawing/2014/main" id="{12A186D5-3DE6-4493-B938-6554A2E8BA10}"/>
               </a:ext>
             </a:extLst>
           </p:cNvPr>
@@ -4855,7 +4855,7 @@
           <p:cNvPr id="16" name="">
             <a:extLst xmlns:a="http://schemas.openxmlformats.org/drawingml/2006/main">
               <a:ext uri="{FF2B5EF4-FFF2-40B4-BE49-F238E27FC236}">
-                <a16:creationId xmlns:a16="http://schemas.microsoft.com/office/drawing/2014/main" id="{4AF56B60-FE4F-43BF-A711-EB40742AA0D5}"/>
+                <a16:creationId xmlns:a16="http://schemas.microsoft.com/office/drawing/2014/main" id="{2055487D-7FD5-4816-B066-2B00D50F2503}"/>
               </a:ext>
             </a:extLst>
           </p:cNvPr>
@@ -4895,7 +4895,7 @@
           <p:cNvPr id="17" name="">
             <a:extLst xmlns:a="http://schemas.openxmlformats.org/drawingml/2006/main">
               <a:ext uri="{FF2B5EF4-FFF2-40B4-BE49-F238E27FC236}">
-                <a16:creationId xmlns:a16="http://schemas.microsoft.com/office/drawing/2014/main" id="{CA706E2B-F230-422A-B23B-2DB28C4A4135}"/>
+                <a16:creationId xmlns:a16="http://schemas.microsoft.com/office/drawing/2014/main" id="{C3FD079B-535C-43EF-AF65-2902071F5DB6}"/>
               </a:ext>
             </a:extLst>
           </p:cNvPr>
@@ -4935,7 +4935,7 @@
           <p:cNvPr id="18" name="">
             <a:extLst xmlns:a="http://schemas.openxmlformats.org/drawingml/2006/main">
               <a:ext uri="{FF2B5EF4-FFF2-40B4-BE49-F238E27FC236}">
-                <a16:creationId xmlns:a16="http://schemas.microsoft.com/office/drawing/2014/main" id="{F7EFFDCF-FD6D-4DE8-A8FD-C427D3E04552}"/>
+                <a16:creationId xmlns:a16="http://schemas.microsoft.com/office/drawing/2014/main" id="{B3BAB236-93D0-4534-8CA2-9EB6006519F5}"/>
               </a:ext>
             </a:extLst>
           </p:cNvPr>
@@ -4975,7 +4975,7 @@
           <p:cNvPr id="19" name="">
             <a:extLst xmlns:a="http://schemas.openxmlformats.org/drawingml/2006/main">
               <a:ext uri="{FF2B5EF4-FFF2-40B4-BE49-F238E27FC236}">
-                <a16:creationId xmlns:a16="http://schemas.microsoft.com/office/drawing/2014/main" id="{4651F47C-FDC6-44DF-9DB1-F9EC610CA6D1}"/>
+                <a16:creationId xmlns:a16="http://schemas.microsoft.com/office/drawing/2014/main" id="{408C787C-59D9-414C-A32E-64881FF04A23}"/>
               </a:ext>
             </a:extLst>
           </p:cNvPr>
@@ -5015,7 +5015,7 @@
           <p:cNvPr id="20" name="">
             <a:extLst xmlns:a="http://schemas.openxmlformats.org/drawingml/2006/main">
               <a:ext uri="{FF2B5EF4-FFF2-40B4-BE49-F238E27FC236}">
-                <a16:creationId xmlns:a16="http://schemas.microsoft.com/office/drawing/2014/main" id="{D1723153-030C-4DCF-B32F-00A819E613D9}"/>
+                <a16:creationId xmlns:a16="http://schemas.microsoft.com/office/drawing/2014/main" id="{95091CA0-2E29-4B26-B178-2EA334962CAC}"/>
               </a:ext>
             </a:extLst>
           </p:cNvPr>
@@ -5055,7 +5055,7 @@
           <p:cNvPr id="21" name="">
             <a:extLst xmlns:a="http://schemas.openxmlformats.org/drawingml/2006/main">
               <a:ext uri="{FF2B5EF4-FFF2-40B4-BE49-F238E27FC236}">
-                <a16:creationId xmlns:a16="http://schemas.microsoft.com/office/drawing/2014/main" id="{E8573C6F-27AE-43C5-A34F-B91D1F510292}"/>
+                <a16:creationId xmlns:a16="http://schemas.microsoft.com/office/drawing/2014/main" id="{82B97657-AFC5-41A4-800D-F69A1009FCFC}"/>
               </a:ext>
             </a:extLst>
           </p:cNvPr>
@@ -5086,7 +5086,7 @@
           <p:cNvPr id="22" name="Build with AI 2026">
             <a:extLst xmlns:a="http://schemas.openxmlformats.org/drawingml/2006/main">
               <a:ext uri="{FF2B5EF4-FFF2-40B4-BE49-F238E27FC236}">
-                <a16:creationId xmlns:a16="http://schemas.microsoft.com/office/drawing/2014/main" id="{6941FF3B-8E21-41D9-AF48-43591D3EFE2C}"/>
+                <a16:creationId xmlns:a16="http://schemas.microsoft.com/office/drawing/2014/main" id="{809642C3-4B5C-459E-8BB7-92FFB2558D84}"/>
               </a:ext>
             </a:extLst>
           </p:cNvPr>
@@ -5249,7 +5249,7 @@
           <p:cNvPr id="23" name="Успею&#10;вернуться">
             <a:extLst xmlns:a="http://schemas.openxmlformats.org/drawingml/2006/main">
               <a:ext uri="{FF2B5EF4-FFF2-40B4-BE49-F238E27FC236}">
-                <a16:creationId xmlns:a16="http://schemas.microsoft.com/office/drawing/2014/main" id="{A30C995A-748C-4375-A2C8-C576E33ECECB}"/>
+                <a16:creationId xmlns:a16="http://schemas.microsoft.com/office/drawing/2014/main" id="{EAFFE8F2-158E-4917-84E0-18C33831B2B0}"/>
               </a:ext>
             </a:extLst>
           </p:cNvPr>
@@ -5439,7 +5439,7 @@
           <p:cNvPr id="24" name="Городская прогулка&#10;в вашем окне вре">
             <a:extLst xmlns:a="http://schemas.openxmlformats.org/drawingml/2006/main">
               <a:ext uri="{FF2B5EF4-FFF2-40B4-BE49-F238E27FC236}">
-                <a16:creationId xmlns:a16="http://schemas.microsoft.com/office/drawing/2014/main" id="{3D7B4D89-8720-42BD-BA0D-DA59723C16F0}"/>
+                <a16:creationId xmlns:a16="http://schemas.microsoft.com/office/drawing/2014/main" id="{39924B4E-9386-406D-8EDD-28F964BC0791}"/>
               </a:ext>
             </a:extLst>
           </p:cNvPr>
@@ -5626,10 +5626,10 @@
       </p:sp>
       <p:sp>
         <p:nvSpPr>
-          <p:cNvPr id="25" name="Астана   /   Smart City">
+          <p:cNvPr id="25" name="Астана   /   Smart City   /   22.10">
             <a:extLst xmlns:a="http://schemas.openxmlformats.org/drawingml/2006/main">
               <a:ext uri="{FF2B5EF4-FFF2-40B4-BE49-F238E27FC236}">
-                <a16:creationId xmlns:a16="http://schemas.microsoft.com/office/drawing/2014/main" id="{87D23560-2962-4BCF-B601-0761E968E1D1}"/>
+                <a16:creationId xmlns:a16="http://schemas.microsoft.com/office/drawing/2014/main" id="{8CB65BCD-5978-4F5E-A011-09BB464D6016}"/>
               </a:ext>
             </a:extLst>
           </p:cNvPr>
@@ -5641,7 +5641,7 @@
         <p:spPr>
           <a:xfrm xmlns:a="http://schemas.openxmlformats.org/drawingml/2006/main">
             <a:off x="609600" y="5495925"/>
-            <a:ext cx="5524500" cy="333375"/>
+            <a:ext cx="5715000" cy="333375"/>
           </a:xfrm>
           <a:prstGeom xmlns:a="http://schemas.openxmlformats.org/drawingml/2006/main" prst="rect">
             <a:avLst/>
@@ -5782,7 +5782,7 @@
                 <a:ea typeface="Segoe UI"/>
                 <a:cs typeface="Segoe UI"/>
               </a:rPr>
-              <a:t>Астана   /   Smart City</a:t>
+              <a:t>Астана   /   Smart City   /   22.10.2026</a:t>
             </a:r>
           </a:p>
         </p:txBody>
@@ -5792,7 +5792,7 @@
           <p:cNvPr id="26" name="">
             <a:extLst xmlns:a="http://schemas.openxmlformats.org/drawingml/2006/main">
               <a:ext uri="{FF2B5EF4-FFF2-40B4-BE49-F238E27FC236}">
-                <a16:creationId xmlns:a16="http://schemas.microsoft.com/office/drawing/2014/main" id="{74B09A34-4FA3-4C6A-8126-F0E46FC50014}"/>
+                <a16:creationId xmlns:a16="http://schemas.microsoft.com/office/drawing/2014/main" id="{28B7D17A-BF83-4B5E-A2A8-3E8A9F2D18AA}"/>
               </a:ext>
             </a:extLst>
           </p:cNvPr>
@@ -5832,7 +5832,7 @@
           <p:cNvPr id="27" name="">
             <a:extLst xmlns:a="http://schemas.openxmlformats.org/drawingml/2006/main">
               <a:ext uri="{FF2B5EF4-FFF2-40B4-BE49-F238E27FC236}">
-                <a16:creationId xmlns:a16="http://schemas.microsoft.com/office/drawing/2014/main" id="{26392D79-235E-41DA-84B7-30AEF82763A9}"/>
+                <a16:creationId xmlns:a16="http://schemas.microsoft.com/office/drawing/2014/main" id="{B218C6E0-6789-4DFD-B2B1-02CB4B62B30E}"/>
               </a:ext>
             </a:extLst>
           </p:cNvPr>
@@ -5872,7 +5872,7 @@
           <p:cNvPr id="28" name="">
             <a:extLst xmlns:a="http://schemas.openxmlformats.org/drawingml/2006/main">
               <a:ext uri="{FF2B5EF4-FFF2-40B4-BE49-F238E27FC236}">
-                <a16:creationId xmlns:a16="http://schemas.microsoft.com/office/drawing/2014/main" id="{DC6B2167-351E-44CD-80D5-5518083BE339}"/>
+                <a16:creationId xmlns:a16="http://schemas.microsoft.com/office/drawing/2014/main" id="{2BFB519C-DF7F-44BE-878A-48B1756A972C}"/>
               </a:ext>
             </a:extLst>
           </p:cNvPr>
@@ -5912,7 +5912,7 @@
           <p:cNvPr id="29" name="">
             <a:extLst xmlns:a="http://schemas.openxmlformats.org/drawingml/2006/main">
               <a:ext uri="{FF2B5EF4-FFF2-40B4-BE49-F238E27FC236}">
-                <a16:creationId xmlns:a16="http://schemas.microsoft.com/office/drawing/2014/main" id="{98898D7B-E2BC-48EE-BDCA-3799603BFB6E}"/>
+                <a16:creationId xmlns:a16="http://schemas.microsoft.com/office/drawing/2014/main" id="{42103CA4-9978-48AC-A638-C7DA9DCEF7C4}"/>
               </a:ext>
             </a:extLst>
           </p:cNvPr>
@@ -5952,7 +5952,7 @@
           <p:cNvPr id="30" name="">
             <a:extLst xmlns:a="http://schemas.openxmlformats.org/drawingml/2006/main">
               <a:ext uri="{FF2B5EF4-FFF2-40B4-BE49-F238E27FC236}">
-                <a16:creationId xmlns:a16="http://schemas.microsoft.com/office/drawing/2014/main" id="{BC491333-AE39-480A-8FAF-EA5A1F5E15E0}"/>
+                <a16:creationId xmlns:a16="http://schemas.microsoft.com/office/drawing/2014/main" id="{9D402B85-D51F-4104-9E5F-18B12A362DD0}"/>
               </a:ext>
             </a:extLst>
           </p:cNvPr>
@@ -5992,7 +5992,7 @@
           <p:cNvPr id="31" name="">
             <a:extLst xmlns:a="http://schemas.openxmlformats.org/drawingml/2006/main">
               <a:ext uri="{FF2B5EF4-FFF2-40B4-BE49-F238E27FC236}">
-                <a16:creationId xmlns:a16="http://schemas.microsoft.com/office/drawing/2014/main" id="{F4A27049-88E6-4323-ADFB-27D5861884A0}"/>
+                <a16:creationId xmlns:a16="http://schemas.microsoft.com/office/drawing/2014/main" id="{12523387-26A0-4C68-A39D-BCFC5895608A}"/>
               </a:ext>
             </a:extLst>
           </p:cNvPr>
@@ -6032,7 +6032,7 @@
           <p:cNvPr id="32" name="">
             <a:extLst xmlns:a="http://schemas.openxmlformats.org/drawingml/2006/main">
               <a:ext uri="{FF2B5EF4-FFF2-40B4-BE49-F238E27FC236}">
-                <a16:creationId xmlns:a16="http://schemas.microsoft.com/office/drawing/2014/main" id="{B2FDF32C-CD49-4B1C-BECE-7AB79CDE887F}"/>
+                <a16:creationId xmlns:a16="http://schemas.microsoft.com/office/drawing/2014/main" id="{344BDA01-9566-4CD6-911F-AEFEDC6312E1}"/>
               </a:ext>
             </a:extLst>
           </p:cNvPr>
@@ -6072,7 +6072,7 @@
           <p:cNvPr id="33" name="">
             <a:extLst xmlns:a="http://schemas.openxmlformats.org/drawingml/2006/main">
               <a:ext uri="{FF2B5EF4-FFF2-40B4-BE49-F238E27FC236}">
-                <a16:creationId xmlns:a16="http://schemas.microsoft.com/office/drawing/2014/main" id="{1FB70513-8CA8-4B99-B26E-744856CD727C}"/>
+                <a16:creationId xmlns:a16="http://schemas.microsoft.com/office/drawing/2014/main" id="{F6755AF1-939B-41B6-A24A-59C5D9B62796}"/>
               </a:ext>
             </a:extLst>
           </p:cNvPr>
@@ -6103,7 +6103,7 @@
           <p:cNvPr id="34" name="">
             <a:extLst xmlns:a="http://schemas.openxmlformats.org/drawingml/2006/main">
               <a:ext uri="{FF2B5EF4-FFF2-40B4-BE49-F238E27FC236}">
-                <a16:creationId xmlns:a16="http://schemas.microsoft.com/office/drawing/2014/main" id="{F00C4F41-2157-4982-A345-9D59620A248E}"/>
+                <a16:creationId xmlns:a16="http://schemas.microsoft.com/office/drawing/2014/main" id="{AAF785C7-BB8D-4D92-ACF8-1E402B90A248}"/>
               </a:ext>
             </a:extLst>
           </p:cNvPr>
@@ -6134,7 +6134,7 @@
           <p:cNvPr id="35" name="">
             <a:extLst xmlns:a="http://schemas.openxmlformats.org/drawingml/2006/main">
               <a:ext uri="{FF2B5EF4-FFF2-40B4-BE49-F238E27FC236}">
-                <a16:creationId xmlns:a16="http://schemas.microsoft.com/office/drawing/2014/main" id="{5B8398E9-A33A-4D41-9250-E4B34D62513E}"/>
+                <a16:creationId xmlns:a16="http://schemas.microsoft.com/office/drawing/2014/main" id="{BA4BCC77-F233-40FB-B863-E4E69DA15191}"/>
               </a:ext>
             </a:extLst>
           </p:cNvPr>
@@ -6165,7 +6165,7 @@
           <p:cNvPr id="36" name="">
             <a:extLst xmlns:a="http://schemas.openxmlformats.org/drawingml/2006/main">
               <a:ext uri="{FF2B5EF4-FFF2-40B4-BE49-F238E27FC236}">
-                <a16:creationId xmlns:a16="http://schemas.microsoft.com/office/drawing/2014/main" id="{2A685BFA-1CDF-4BFE-B1EC-3E2FF26ED615}"/>
+                <a16:creationId xmlns:a16="http://schemas.microsoft.com/office/drawing/2014/main" id="{A766CD48-1311-4404-A0C1-8A82D9054581}"/>
               </a:ext>
             </a:extLst>
           </p:cNvPr>
@@ -6196,7 +6196,7 @@
           <p:cNvPr id="37" name="">
             <a:extLst xmlns:a="http://schemas.openxmlformats.org/drawingml/2006/main">
               <a:ext uri="{FF2B5EF4-FFF2-40B4-BE49-F238E27FC236}">
-                <a16:creationId xmlns:a16="http://schemas.microsoft.com/office/drawing/2014/main" id="{C54A11FB-DEE9-44F0-8F90-1F46FAEF4016}"/>
+                <a16:creationId xmlns:a16="http://schemas.microsoft.com/office/drawing/2014/main" id="{D5C1B090-58D1-4EF7-B8A6-E5AF7B8EB9EA}"/>
               </a:ext>
             </a:extLst>
           </p:cNvPr>
@@ -6236,7 +6236,7 @@
           <p:cNvPr id="38" name="">
             <a:extLst xmlns:a="http://schemas.openxmlformats.org/drawingml/2006/main">
               <a:ext uri="{FF2B5EF4-FFF2-40B4-BE49-F238E27FC236}">
-                <a16:creationId xmlns:a16="http://schemas.microsoft.com/office/drawing/2014/main" id="{F50C75BB-46F4-4DB4-ADAA-70FF9A6930EE}"/>
+                <a16:creationId xmlns:a16="http://schemas.microsoft.com/office/drawing/2014/main" id="{ECFB6DFB-C95C-4F21-BDDC-566440762D6D}"/>
               </a:ext>
             </a:extLst>
           </p:cNvPr>
@@ -6276,7 +6276,7 @@
           <p:cNvPr id="39" name="">
             <a:extLst xmlns:a="http://schemas.openxmlformats.org/drawingml/2006/main">
               <a:ext uri="{FF2B5EF4-FFF2-40B4-BE49-F238E27FC236}">
-                <a16:creationId xmlns:a16="http://schemas.microsoft.com/office/drawing/2014/main" id="{DCDD0409-2D79-4BF7-AAF0-FEDB1A6E195C}"/>
+                <a16:creationId xmlns:a16="http://schemas.microsoft.com/office/drawing/2014/main" id="{DE634A17-1BA9-4FBB-8E9B-C829E60BD3B1}"/>
               </a:ext>
             </a:extLst>
           </p:cNvPr>
@@ -6316,7 +6316,7 @@
           <p:cNvPr id="40" name="">
             <a:extLst xmlns:a="http://schemas.openxmlformats.org/drawingml/2006/main">
               <a:ext uri="{FF2B5EF4-FFF2-40B4-BE49-F238E27FC236}">
-                <a16:creationId xmlns:a16="http://schemas.microsoft.com/office/drawing/2014/main" id="{E459EDA8-B8E4-476A-9CBC-5C3A8F4ABFB4}"/>
+                <a16:creationId xmlns:a16="http://schemas.microsoft.com/office/drawing/2014/main" id="{BCA7022B-74CC-4711-9283-ACCB73C6F4BF}"/>
               </a:ext>
             </a:extLst>
           </p:cNvPr>
@@ -6356,7 +6356,7 @@
           <p:cNvPr id="41" name="">
             <a:extLst xmlns:a="http://schemas.openxmlformats.org/drawingml/2006/main">
               <a:ext uri="{FF2B5EF4-FFF2-40B4-BE49-F238E27FC236}">
-                <a16:creationId xmlns:a16="http://schemas.microsoft.com/office/drawing/2014/main" id="{1EC6B1CA-14FD-4851-8398-2260F9211C2C}"/>
+                <a16:creationId xmlns:a16="http://schemas.microsoft.com/office/drawing/2014/main" id="{C9CA6E9A-171C-41EB-9416-FC7FCFD1DA01}"/>
               </a:ext>
             </a:extLst>
           </p:cNvPr>
@@ -6396,7 +6396,7 @@
           <p:cNvPr id="42" name="Место. Визит. Возвращение.">
             <a:extLst xmlns:a="http://schemas.openxmlformats.org/drawingml/2006/main">
               <a:ext uri="{FF2B5EF4-FFF2-40B4-BE49-F238E27FC236}">
-                <a16:creationId xmlns:a16="http://schemas.microsoft.com/office/drawing/2014/main" id="{D0463113-C803-4A23-9AD4-1950DBFDB24A}"/>
+                <a16:creationId xmlns:a16="http://schemas.microsoft.com/office/drawing/2014/main" id="{8C375CF9-9874-4E61-8A99-605E8ED19FB0}"/>
               </a:ext>
             </a:extLst>
           </p:cNvPr>
@@ -6559,7 +6559,7 @@
           <p:cNvPr id="43" name="Схематическая иллюстрация">
             <a:extLst xmlns:a="http://schemas.openxmlformats.org/drawingml/2006/main">
               <a:ext uri="{FF2B5EF4-FFF2-40B4-BE49-F238E27FC236}">
-                <a16:creationId xmlns:a16="http://schemas.microsoft.com/office/drawing/2014/main" id="{D44E8910-E75C-4EFF-A51B-A47F6011D378}"/>
+                <a16:creationId xmlns:a16="http://schemas.microsoft.com/office/drawing/2014/main" id="{5AE115F6-4A61-4543-9BBB-5D9AB43256BD}"/>
               </a:ext>
             </a:extLst>
           </p:cNvPr>
@@ -6720,7 +6720,7 @@
     </p:spTree>
     <p:extLst>
       <p:ext uri="{BB962C8B-B14F-4D97-AF65-F5344CB8AC3E}">
-        <p14:creationId xmlns:p14="http://schemas.microsoft.com/office/powerpoint/2010/main" val="662534419"/>
+        <p14:creationId xmlns:p14="http://schemas.microsoft.com/office/powerpoint/2010/main" val="1420448471"/>
       </p:ext>
     </p:extLst>
   </p:cSld>
@@ -6751,7 +6751,7 @@
           <p:cNvPr id="17" name="Прогулка между делами">
             <a:extLst xmlns:a="http://schemas.openxmlformats.org/drawingml/2006/main">
               <a:ext uri="{FF2B5EF4-FFF2-40B4-BE49-F238E27FC236}">
-                <a16:creationId xmlns:a16="http://schemas.microsoft.com/office/drawing/2014/main" id="{944A9E18-68ED-429D-9745-34A6CB37103E}"/>
+                <a16:creationId xmlns:a16="http://schemas.microsoft.com/office/drawing/2014/main" id="{D6A97B20-C62D-4CFC-83F7-77680F279065}"/>
               </a:ext>
             </a:extLst>
           </p:cNvPr>
@@ -6914,7 +6914,7 @@
           <p:cNvPr id="2" name="Человек выбирает место и одновремен">
             <a:extLst xmlns:a="http://schemas.openxmlformats.org/drawingml/2006/main">
               <a:ext uri="{FF2B5EF4-FFF2-40B4-BE49-F238E27FC236}">
-                <a16:creationId xmlns:a16="http://schemas.microsoft.com/office/drawing/2014/main" id="{CE761798-17C4-426F-BCC8-CB06E7E47D27}"/>
+                <a16:creationId xmlns:a16="http://schemas.microsoft.com/office/drawing/2014/main" id="{B3832453-9222-415D-BAE4-B4D7638E3C7E}"/>
               </a:ext>
             </a:extLst>
           </p:cNvPr>
@@ -7077,7 +7077,7 @@
           <p:cNvPr id="3" name="">
             <a:extLst xmlns:a="http://schemas.openxmlformats.org/drawingml/2006/main">
               <a:ext uri="{FF2B5EF4-FFF2-40B4-BE49-F238E27FC236}">
-                <a16:creationId xmlns:a16="http://schemas.microsoft.com/office/drawing/2014/main" id="{BC91B28F-2D65-4C50-8252-80E95EFE9A8D}"/>
+                <a16:creationId xmlns:a16="http://schemas.microsoft.com/office/drawing/2014/main" id="{EB0DC91C-9EC3-4678-AD56-75D38422F8F6}"/>
               </a:ext>
             </a:extLst>
           </p:cNvPr>
@@ -7117,7 +7117,7 @@
           <p:cNvPr id="4" name="ASCENSION">
             <a:extLst xmlns:a="http://schemas.openxmlformats.org/drawingml/2006/main">
               <a:ext uri="{FF2B5EF4-FFF2-40B4-BE49-F238E27FC236}">
-                <a16:creationId xmlns:a16="http://schemas.microsoft.com/office/drawing/2014/main" id="{1EA1984C-249A-472E-BA2F-643E02159F86}"/>
+                <a16:creationId xmlns:a16="http://schemas.microsoft.com/office/drawing/2014/main" id="{7260D3F0-D49C-443F-95E3-CA89BB4C5C12}"/>
               </a:ext>
             </a:extLst>
           </p:cNvPr>
@@ -7280,7 +7280,7 @@
           <p:cNvPr id="5" name="02">
             <a:extLst xmlns:a="http://schemas.openxmlformats.org/drawingml/2006/main">
               <a:ext uri="{FF2B5EF4-FFF2-40B4-BE49-F238E27FC236}">
-                <a16:creationId xmlns:a16="http://schemas.microsoft.com/office/drawing/2014/main" id="{0E72CFA6-27A2-40C3-9C16-1220B3A2370D}"/>
+                <a16:creationId xmlns:a16="http://schemas.microsoft.com/office/drawing/2014/main" id="{27CFEF41-3FD9-432A-A0C8-C1349E7DA501}"/>
               </a:ext>
             </a:extLst>
           </p:cNvPr>
@@ -7443,7 +7443,7 @@
           <p:cNvPr id="6" name="45">
             <a:extLst xmlns:a="http://schemas.openxmlformats.org/drawingml/2006/main">
               <a:ext uri="{FF2B5EF4-FFF2-40B4-BE49-F238E27FC236}">
-                <a16:creationId xmlns:a16="http://schemas.microsoft.com/office/drawing/2014/main" id="{372D2EA6-0909-4AF0-A2F4-2410456206DC}"/>
+                <a16:creationId xmlns:a16="http://schemas.microsoft.com/office/drawing/2014/main" id="{EAC29A6F-450A-4C57-BFFD-079FC6D6E4C2}"/>
               </a:ext>
             </a:extLst>
           </p:cNvPr>
@@ -7606,7 +7606,7 @@
           <p:cNvPr id="7" name="минут до следующего дела">
             <a:extLst xmlns:a="http://schemas.openxmlformats.org/drawingml/2006/main">
               <a:ext uri="{FF2B5EF4-FFF2-40B4-BE49-F238E27FC236}">
-                <a16:creationId xmlns:a16="http://schemas.microsoft.com/office/drawing/2014/main" id="{68A6AE9C-1A06-4AB0-B28F-1F94AB69097C}"/>
+                <a16:creationId xmlns:a16="http://schemas.microsoft.com/office/drawing/2014/main" id="{CFEC8689-6598-4D75-AA92-50DB7EE92F17}"/>
               </a:ext>
             </a:extLst>
           </p:cNvPr>
@@ -7769,7 +7769,7 @@
           <p:cNvPr id="8" name="Где я">
             <a:extLst xmlns:a="http://schemas.openxmlformats.org/drawingml/2006/main">
               <a:ext uri="{FF2B5EF4-FFF2-40B4-BE49-F238E27FC236}">
-                <a16:creationId xmlns:a16="http://schemas.microsoft.com/office/drawing/2014/main" id="{4C7DE6A9-DAF1-41E0-9244-6D77BD35151B}"/>
+                <a16:creationId xmlns:a16="http://schemas.microsoft.com/office/drawing/2014/main" id="{C1A98ADB-F202-4179-B77A-FE504B6FB7A7}"/>
               </a:ext>
             </a:extLst>
           </p:cNvPr>
@@ -7932,7 +7932,7 @@
           <p:cNvPr id="9" name="У Mega Silk Way">
             <a:extLst xmlns:a="http://schemas.openxmlformats.org/drawingml/2006/main">
               <a:ext uri="{FF2B5EF4-FFF2-40B4-BE49-F238E27FC236}">
-                <a16:creationId xmlns:a16="http://schemas.microsoft.com/office/drawing/2014/main" id="{30A16188-01C1-4956-AEA9-5342EE56849C}"/>
+                <a16:creationId xmlns:a16="http://schemas.microsoft.com/office/drawing/2014/main" id="{1C2BA805-81B1-49B6-8994-23D5A846AA22}"/>
               </a:ext>
             </a:extLst>
           </p:cNvPr>
@@ -8095,7 +8095,7 @@
           <p:cNvPr id="10" name="">
             <a:extLst xmlns:a="http://schemas.openxmlformats.org/drawingml/2006/main">
               <a:ext uri="{FF2B5EF4-FFF2-40B4-BE49-F238E27FC236}">
-                <a16:creationId xmlns:a16="http://schemas.microsoft.com/office/drawing/2014/main" id="{A5B6B945-DC7A-428C-98D3-F16432D4CE03}"/>
+                <a16:creationId xmlns:a16="http://schemas.microsoft.com/office/drawing/2014/main" id="{7F99A173-C0A8-4995-8BB1-711F0181BD33}"/>
               </a:ext>
             </a:extLst>
           </p:cNvPr>
@@ -8135,7 +8135,7 @@
           <p:cNvPr id="11" name="Чего хочу">
             <a:extLst xmlns:a="http://schemas.openxmlformats.org/drawingml/2006/main">
               <a:ext uri="{FF2B5EF4-FFF2-40B4-BE49-F238E27FC236}">
-                <a16:creationId xmlns:a16="http://schemas.microsoft.com/office/drawing/2014/main" id="{CDEB0B01-AEE5-43A9-B045-5EF239B597DE}"/>
+                <a16:creationId xmlns:a16="http://schemas.microsoft.com/office/drawing/2014/main" id="{0F2ABBC0-B85C-41D3-9598-FC557A38AC31}"/>
               </a:ext>
             </a:extLst>
           </p:cNvPr>
@@ -8295,10 +8295,10 @@
       </p:sp>
       <p:sp>
         <p:nvSpPr>
-          <p:cNvPr id="12" name="Прогуляться рядом">
+          <p:cNvPr id="12" name="Выпить кофе рядом">
             <a:extLst xmlns:a="http://schemas.openxmlformats.org/drawingml/2006/main">
               <a:ext uri="{FF2B5EF4-FFF2-40B4-BE49-F238E27FC236}">
-                <a16:creationId xmlns:a16="http://schemas.microsoft.com/office/drawing/2014/main" id="{437A7D4B-4DB9-4DA8-A59F-9209CAF2E763}"/>
+                <a16:creationId xmlns:a16="http://schemas.microsoft.com/office/drawing/2014/main" id="{EE0CC8ED-92B2-4CA3-8834-4F1D2E40554A}"/>
               </a:ext>
             </a:extLst>
           </p:cNvPr>
@@ -8451,7 +8451,7 @@
                 <a:ea typeface="Segoe UI"/>
                 <a:cs typeface="Segoe UI"/>
               </a:rPr>
-              <a:t>Прогуляться рядом</a:t>
+              <a:t>Выпить кофе рядом</a:t>
             </a:r>
           </a:p>
         </p:txBody>
@@ -8461,7 +8461,7 @@
           <p:cNvPr id="13" name="">
             <a:extLst xmlns:a="http://schemas.openxmlformats.org/drawingml/2006/main">
               <a:ext uri="{FF2B5EF4-FFF2-40B4-BE49-F238E27FC236}">
-                <a16:creationId xmlns:a16="http://schemas.microsoft.com/office/drawing/2014/main" id="{F70034CC-9CAA-4A82-B86E-6F52E09FA161}"/>
+                <a16:creationId xmlns:a16="http://schemas.microsoft.com/office/drawing/2014/main" id="{313D17E8-C489-4133-8777-CB42EDC3CCC0}"/>
               </a:ext>
             </a:extLst>
           </p:cNvPr>
@@ -8501,7 +8501,7 @@
           <p:cNvPr id="14" name="Что ограничивает">
             <a:extLst xmlns:a="http://schemas.openxmlformats.org/drawingml/2006/main">
               <a:ext uri="{FF2B5EF4-FFF2-40B4-BE49-F238E27FC236}">
-                <a16:creationId xmlns:a16="http://schemas.microsoft.com/office/drawing/2014/main" id="{FC69BB7F-543C-49E8-B887-C329E581920B}"/>
+                <a16:creationId xmlns:a16="http://schemas.microsoft.com/office/drawing/2014/main" id="{73251484-5877-4954-A119-34C374160064}"/>
               </a:ext>
             </a:extLst>
           </p:cNvPr>
@@ -8664,7 +8664,7 @@
           <p:cNvPr id="15" name="Вернуться к исходной точке">
             <a:extLst xmlns:a="http://schemas.openxmlformats.org/drawingml/2006/main">
               <a:ext uri="{FF2B5EF4-FFF2-40B4-BE49-F238E27FC236}">
-                <a16:creationId xmlns:a16="http://schemas.microsoft.com/office/drawing/2014/main" id="{6A477800-4109-426B-A6FD-9873E45DEF40}"/>
+                <a16:creationId xmlns:a16="http://schemas.microsoft.com/office/drawing/2014/main" id="{56F81C02-8DB2-4296-9BC9-4A6E02A66F3B}"/>
               </a:ext>
             </a:extLst>
           </p:cNvPr>
@@ -8827,7 +8827,7 @@
           <p:cNvPr id="16" name="Сценарий, заданный командой. Это не">
             <a:extLst xmlns:a="http://schemas.openxmlformats.org/drawingml/2006/main">
               <a:ext uri="{FF2B5EF4-FFF2-40B4-BE49-F238E27FC236}">
-                <a16:creationId xmlns:a16="http://schemas.microsoft.com/office/drawing/2014/main" id="{B63049CE-3A6B-4CF1-B5EE-4BB4D1AC359F}"/>
+                <a16:creationId xmlns:a16="http://schemas.microsoft.com/office/drawing/2014/main" id="{FEB8DBF9-ACC7-4BD8-9E00-00FDA3FB9C24}"/>
               </a:ext>
             </a:extLst>
           </p:cNvPr>
@@ -8988,7 +8988,7 @@
     </p:spTree>
     <p:extLst>
       <p:ext uri="{BB962C8B-B14F-4D97-AF65-F5344CB8AC3E}">
-        <p14:creationId xmlns:p14="http://schemas.microsoft.com/office/powerpoint/2010/main" val="752409156"/>
+        <p14:creationId xmlns:p14="http://schemas.microsoft.com/office/powerpoint/2010/main" val="1814960839"/>
       </p:ext>
     </p:extLst>
   </p:cSld>
@@ -9019,7 +9019,7 @@
           <p:cNvPr id="16" name="Весь маршрут в одном бюджете">
             <a:extLst xmlns:a="http://schemas.openxmlformats.org/drawingml/2006/main">
               <a:ext uri="{FF2B5EF4-FFF2-40B4-BE49-F238E27FC236}">
-                <a16:creationId xmlns:a16="http://schemas.microsoft.com/office/drawing/2014/main" id="{F79DF41F-4D76-49E7-832D-349C9FC9B858}"/>
+                <a16:creationId xmlns:a16="http://schemas.microsoft.com/office/drawing/2014/main" id="{A839D15D-8457-4D41-98A8-3A3B2A5F24FF}"/>
               </a:ext>
             </a:extLst>
           </p:cNvPr>
@@ -9182,7 +9182,7 @@
           <p:cNvPr id="2" name="Правило продукта: время на возвраще">
             <a:extLst xmlns:a="http://schemas.openxmlformats.org/drawingml/2006/main">
               <a:ext uri="{FF2B5EF4-FFF2-40B4-BE49-F238E27FC236}">
-                <a16:creationId xmlns:a16="http://schemas.microsoft.com/office/drawing/2014/main" id="{BAB543D4-1EFA-4788-B0CD-188C59A0D22D}"/>
+                <a16:creationId xmlns:a16="http://schemas.microsoft.com/office/drawing/2014/main" id="{7F1CAC00-41D7-4878-8616-8A2E6C66869A}"/>
               </a:ext>
             </a:extLst>
           </p:cNvPr>
@@ -9345,7 +9345,7 @@
           <p:cNvPr id="3" name="">
             <a:extLst xmlns:a="http://schemas.openxmlformats.org/drawingml/2006/main">
               <a:ext uri="{FF2B5EF4-FFF2-40B4-BE49-F238E27FC236}">
-                <a16:creationId xmlns:a16="http://schemas.microsoft.com/office/drawing/2014/main" id="{0455F635-8B19-48C3-9C25-869B0AB349F3}"/>
+                <a16:creationId xmlns:a16="http://schemas.microsoft.com/office/drawing/2014/main" id="{21671717-19F5-4348-BC93-BBF3AA0F5D22}"/>
               </a:ext>
             </a:extLst>
           </p:cNvPr>
@@ -9385,7 +9385,7 @@
           <p:cNvPr id="4" name="ASCENSION">
             <a:extLst xmlns:a="http://schemas.openxmlformats.org/drawingml/2006/main">
               <a:ext uri="{FF2B5EF4-FFF2-40B4-BE49-F238E27FC236}">
-                <a16:creationId xmlns:a16="http://schemas.microsoft.com/office/drawing/2014/main" id="{7ADF1742-B7DF-4C21-B32C-2FEE9F43DE56}"/>
+                <a16:creationId xmlns:a16="http://schemas.microsoft.com/office/drawing/2014/main" id="{8F5D601E-4714-4227-93D1-A2C4E2C12C08}"/>
               </a:ext>
             </a:extLst>
           </p:cNvPr>
@@ -9548,7 +9548,7 @@
           <p:cNvPr id="5" name="03">
             <a:extLst xmlns:a="http://schemas.openxmlformats.org/drawingml/2006/main">
               <a:ext uri="{FF2B5EF4-FFF2-40B4-BE49-F238E27FC236}">
-                <a16:creationId xmlns:a16="http://schemas.microsoft.com/office/drawing/2014/main" id="{AB4E5384-E54D-4CD1-8038-861027FF82C4}"/>
+                <a16:creationId xmlns:a16="http://schemas.microsoft.com/office/drawing/2014/main" id="{8742624F-619E-4C6B-A6E0-23B4BC1CA2BA}"/>
               </a:ext>
             </a:extLst>
           </p:cNvPr>
@@ -9711,7 +9711,7 @@
           <p:cNvPr id="6" name="">
             <a:extLst xmlns:a="http://schemas.openxmlformats.org/drawingml/2006/main">
               <a:ext uri="{FF2B5EF4-FFF2-40B4-BE49-F238E27FC236}">
-                <a16:creationId xmlns:a16="http://schemas.microsoft.com/office/drawing/2014/main" id="{8DDEA52D-E32F-42CD-AAF2-AC1CAC14E389}"/>
+                <a16:creationId xmlns:a16="http://schemas.microsoft.com/office/drawing/2014/main" id="{7D63B207-DECA-4DDC-95B9-82EF97743D26}"/>
               </a:ext>
             </a:extLst>
           </p:cNvPr>
@@ -9742,7 +9742,7 @@
           <p:cNvPr id="7" name="Дорога туда">
             <a:extLst xmlns:a="http://schemas.openxmlformats.org/drawingml/2006/main">
               <a:ext uri="{FF2B5EF4-FFF2-40B4-BE49-F238E27FC236}">
-                <a16:creationId xmlns:a16="http://schemas.microsoft.com/office/drawing/2014/main" id="{724A9779-1C3E-414A-A248-771BED913D1D}"/>
+                <a16:creationId xmlns:a16="http://schemas.microsoft.com/office/drawing/2014/main" id="{330B7DE3-C903-464C-B971-391E1490FB99}"/>
               </a:ext>
             </a:extLst>
           </p:cNvPr>
@@ -9905,7 +9905,7 @@
           <p:cNvPr id="8" name="">
             <a:extLst xmlns:a="http://schemas.openxmlformats.org/drawingml/2006/main">
               <a:ext uri="{FF2B5EF4-FFF2-40B4-BE49-F238E27FC236}">
-                <a16:creationId xmlns:a16="http://schemas.microsoft.com/office/drawing/2014/main" id="{1B94AC5A-DD06-4F61-8A7E-67A38718F837}"/>
+                <a16:creationId xmlns:a16="http://schemas.microsoft.com/office/drawing/2014/main" id="{7CCE2661-FA3A-4C25-B623-8E91BA8C0032}"/>
               </a:ext>
             </a:extLst>
           </p:cNvPr>
@@ -9936,7 +9936,7 @@
           <p:cNvPr id="9" name="Визит">
             <a:extLst xmlns:a="http://schemas.openxmlformats.org/drawingml/2006/main">
               <a:ext uri="{FF2B5EF4-FFF2-40B4-BE49-F238E27FC236}">
-                <a16:creationId xmlns:a16="http://schemas.microsoft.com/office/drawing/2014/main" id="{45931962-B57E-4E60-9431-0792DD1AD7C3}"/>
+                <a16:creationId xmlns:a16="http://schemas.microsoft.com/office/drawing/2014/main" id="{B7167058-D83E-4EB6-9BB3-246B6D959DCF}"/>
               </a:ext>
             </a:extLst>
           </p:cNvPr>
@@ -10099,7 +10099,7 @@
           <p:cNvPr id="10" name="">
             <a:extLst xmlns:a="http://schemas.openxmlformats.org/drawingml/2006/main">
               <a:ext uri="{FF2B5EF4-FFF2-40B4-BE49-F238E27FC236}">
-                <a16:creationId xmlns:a16="http://schemas.microsoft.com/office/drawing/2014/main" id="{1D370362-1A68-4339-B4A6-B7FCDF64B4D6}"/>
+                <a16:creationId xmlns:a16="http://schemas.microsoft.com/office/drawing/2014/main" id="{4A05C6CF-7284-41BF-9564-5AA917EF7C08}"/>
               </a:ext>
             </a:extLst>
           </p:cNvPr>
@@ -10130,7 +10130,7 @@
           <p:cNvPr id="11" name="Обратный путь">
             <a:extLst xmlns:a="http://schemas.openxmlformats.org/drawingml/2006/main">
               <a:ext uri="{FF2B5EF4-FFF2-40B4-BE49-F238E27FC236}">
-                <a16:creationId xmlns:a16="http://schemas.microsoft.com/office/drawing/2014/main" id="{AE3D73E8-6BEB-4098-BD54-7FE783EF5C42}"/>
+                <a16:creationId xmlns:a16="http://schemas.microsoft.com/office/drawing/2014/main" id="{3FB0EFC6-43C9-4F41-9186-EC9F4338077F}"/>
               </a:ext>
             </a:extLst>
           </p:cNvPr>
@@ -10293,7 +10293,7 @@
           <p:cNvPr id="12" name="">
             <a:extLst xmlns:a="http://schemas.openxmlformats.org/drawingml/2006/main">
               <a:ext uri="{FF2B5EF4-FFF2-40B4-BE49-F238E27FC236}">
-                <a16:creationId xmlns:a16="http://schemas.microsoft.com/office/drawing/2014/main" id="{28A6B7EC-1D82-4580-A68D-8ED41EBD4385}"/>
+                <a16:creationId xmlns:a16="http://schemas.microsoft.com/office/drawing/2014/main" id="{17364B1C-BE18-45C9-9929-346284233502}"/>
               </a:ext>
             </a:extLst>
           </p:cNvPr>
@@ -10324,7 +10324,7 @@
           <p:cNvPr id="13" name="Резерв">
             <a:extLst xmlns:a="http://schemas.openxmlformats.org/drawingml/2006/main">
               <a:ext uri="{FF2B5EF4-FFF2-40B4-BE49-F238E27FC236}">
-                <a16:creationId xmlns:a16="http://schemas.microsoft.com/office/drawing/2014/main" id="{7F0D241E-D1CD-4B28-AB76-A94B73A938A6}"/>
+                <a16:creationId xmlns:a16="http://schemas.microsoft.com/office/drawing/2014/main" id="{0BF1E062-8FA7-44F3-8105-AC65E8E0E252}"/>
               </a:ext>
             </a:extLst>
           </p:cNvPr>
@@ -10487,7 +10487,7 @@
           <p:cNvPr id="14" name="Сумма ≤ доступное время">
             <a:extLst xmlns:a="http://schemas.openxmlformats.org/drawingml/2006/main">
               <a:ext uri="{FF2B5EF4-FFF2-40B4-BE49-F238E27FC236}">
-                <a16:creationId xmlns:a16="http://schemas.microsoft.com/office/drawing/2014/main" id="{E8304BBC-4606-47BC-AE0E-F412D06867C7}"/>
+                <a16:creationId xmlns:a16="http://schemas.microsoft.com/office/drawing/2014/main" id="{ED935391-0D81-4302-83C7-672826D4A99A}"/>
               </a:ext>
             </a:extLst>
           </p:cNvPr>
@@ -10650,7 +10650,7 @@
           <p:cNvPr id="15" name="1–3 альтернативы с объяснением, дей">
             <a:extLst xmlns:a="http://schemas.openxmlformats.org/drawingml/2006/main">
               <a:ext uri="{FF2B5EF4-FFF2-40B4-BE49-F238E27FC236}">
-                <a16:creationId xmlns:a16="http://schemas.microsoft.com/office/drawing/2014/main" id="{44195F4A-5F9F-4162-870F-C0AB0FD4E117}"/>
+                <a16:creationId xmlns:a16="http://schemas.microsoft.com/office/drawing/2014/main" id="{9A604D51-C258-46F3-8340-A323AC8689B7}"/>
               </a:ext>
             </a:extLst>
           </p:cNvPr>
@@ -10838,7 +10838,7 @@
     </p:spTree>
     <p:extLst>
       <p:ext uri="{BB962C8B-B14F-4D97-AF65-F5344CB8AC3E}">
-        <p14:creationId xmlns:p14="http://schemas.microsoft.com/office/powerpoint/2010/main" val="2001088248"/>
+        <p14:creationId xmlns:p14="http://schemas.microsoft.com/office/powerpoint/2010/main" val="1927793043"/>
       </p:ext>
     </p:extLst>
   </p:cSld>
@@ -10866,10 +10866,10 @@
       </p:grpSpPr>
       <p:sp>
         <p:nvSpPr>
-          <p:cNvPr id="23" name="Совет из городских данных">
+          <p:cNvPr id="23" name="Реальные места и поиск по запросу">
             <a:extLst xmlns:a="http://schemas.openxmlformats.org/drawingml/2006/main">
               <a:ext uri="{FF2B5EF4-FFF2-40B4-BE49-F238E27FC236}">
-                <a16:creationId xmlns:a16="http://schemas.microsoft.com/office/drawing/2014/main" id="{E13E088B-56F6-47F9-A4DD-BF8096A4D314}"/>
+                <a16:creationId xmlns:a16="http://schemas.microsoft.com/office/drawing/2014/main" id="{0A1B1800-063E-40C8-9F13-3922C490E432}"/>
               </a:ext>
             </a:extLst>
           </p:cNvPr>
@@ -11022,17 +11022,17 @@
                 <a:ea typeface="Segoe UI"/>
                 <a:cs typeface="Segoe UI"/>
               </a:rPr>
-              <a:t>Совет из городских данных</a:t>
+              <a:t>Реальные места и поиск по запросу</a:t>
             </a:r>
           </a:p>
         </p:txBody>
       </p:sp>
       <p:sp>
         <p:nvSpPr>
-          <p:cNvPr id="2" name="Проектная схема RAG: поиск, проверк">
+          <p:cNvPr id="2" name="930 канонических POI после проверки">
             <a:extLst xmlns:a="http://schemas.openxmlformats.org/drawingml/2006/main">
               <a:ext uri="{FF2B5EF4-FFF2-40B4-BE49-F238E27FC236}">
-                <a16:creationId xmlns:a16="http://schemas.microsoft.com/office/drawing/2014/main" id="{61659056-C7C0-46B6-8F99-C53851B498B7}"/>
+                <a16:creationId xmlns:a16="http://schemas.microsoft.com/office/drawing/2014/main" id="{0A9C4D32-D141-4DFD-8C50-9BA3DC66EFF2}"/>
               </a:ext>
             </a:extLst>
           </p:cNvPr>
@@ -11185,7 +11185,7 @@
                 <a:ea typeface="Segoe UI"/>
                 <a:cs typeface="Segoe UI"/>
               </a:rPr>
-              <a:t>Проектная схема RAG: поиск, проверка ограничений, объяснение</a:t>
+              <a:t>930 канонических POI после проверки дублей</a:t>
             </a:r>
           </a:p>
         </p:txBody>
@@ -11195,7 +11195,7 @@
           <p:cNvPr id="3" name="">
             <a:extLst xmlns:a="http://schemas.openxmlformats.org/drawingml/2006/main">
               <a:ext uri="{FF2B5EF4-FFF2-40B4-BE49-F238E27FC236}">
-                <a16:creationId xmlns:a16="http://schemas.microsoft.com/office/drawing/2014/main" id="{4D742334-FFBA-4F26-9B2D-7A4757747FD7}"/>
+                <a16:creationId xmlns:a16="http://schemas.microsoft.com/office/drawing/2014/main" id="{52E19B3E-9C95-4763-BF46-A5AAE45BCD61}"/>
               </a:ext>
             </a:extLst>
           </p:cNvPr>
@@ -11235,7 +11235,7 @@
           <p:cNvPr id="4" name="ASCENSION">
             <a:extLst xmlns:a="http://schemas.openxmlformats.org/drawingml/2006/main">
               <a:ext uri="{FF2B5EF4-FFF2-40B4-BE49-F238E27FC236}">
-                <a16:creationId xmlns:a16="http://schemas.microsoft.com/office/drawing/2014/main" id="{5F1B5962-4CBC-4A6B-B580-15DBFB8861EF}"/>
+                <a16:creationId xmlns:a16="http://schemas.microsoft.com/office/drawing/2014/main" id="{24017F4E-07D8-4269-B62A-1902CA25BF8A}"/>
               </a:ext>
             </a:extLst>
           </p:cNvPr>
@@ -11398,7 +11398,7 @@
           <p:cNvPr id="5" name="04">
             <a:extLst xmlns:a="http://schemas.openxmlformats.org/drawingml/2006/main">
               <a:ext uri="{FF2B5EF4-FFF2-40B4-BE49-F238E27FC236}">
-                <a16:creationId xmlns:a16="http://schemas.microsoft.com/office/drawing/2014/main" id="{C9EC8B24-C39B-452A-9214-B5FC26C249F6}"/>
+                <a16:creationId xmlns:a16="http://schemas.microsoft.com/office/drawing/2014/main" id="{0AC3E551-4E87-4A85-B197-714AAD300A3E}"/>
               </a:ext>
             </a:extLst>
           </p:cNvPr>
@@ -11561,7 +11561,7 @@
           <p:cNvPr id="6" name="01">
             <a:extLst xmlns:a="http://schemas.openxmlformats.org/drawingml/2006/main">
               <a:ext uri="{FF2B5EF4-FFF2-40B4-BE49-F238E27FC236}">
-                <a16:creationId xmlns:a16="http://schemas.microsoft.com/office/drawing/2014/main" id="{691C53F1-8EAF-40B8-8877-C77DACC591A1}"/>
+                <a16:creationId xmlns:a16="http://schemas.microsoft.com/office/drawing/2014/main" id="{AF6B8284-DCB9-4432-B2CC-07D7A69F0386}"/>
               </a:ext>
             </a:extLst>
           </p:cNvPr>
@@ -11724,7 +11724,7 @@
           <p:cNvPr id="7" name="">
             <a:extLst xmlns:a="http://schemas.openxmlformats.org/drawingml/2006/main">
               <a:ext uri="{FF2B5EF4-FFF2-40B4-BE49-F238E27FC236}">
-                <a16:creationId xmlns:a16="http://schemas.microsoft.com/office/drawing/2014/main" id="{E214576E-0FF0-451C-B113-996068BEE42C}"/>
+                <a16:creationId xmlns:a16="http://schemas.microsoft.com/office/drawing/2014/main" id="{0EABB465-381F-4601-BD1B-6100F23F4950}"/>
               </a:ext>
             </a:extLst>
           </p:cNvPr>
@@ -11764,7 +11764,7 @@
           <p:cNvPr id="8" name="OSM">
             <a:extLst xmlns:a="http://schemas.openxmlformats.org/drawingml/2006/main">
               <a:ext uri="{FF2B5EF4-FFF2-40B4-BE49-F238E27FC236}">
-                <a16:creationId xmlns:a16="http://schemas.microsoft.com/office/drawing/2014/main" id="{4CCB6D05-E081-42C4-90D1-ADC685B1E75D}"/>
+                <a16:creationId xmlns:a16="http://schemas.microsoft.com/office/drawing/2014/main" id="{67B5D4B2-9647-4E11-A7A4-758941A32364}"/>
               </a:ext>
             </a:extLst>
           </p:cNvPr>
@@ -11927,7 +11927,7 @@
           <p:cNvPr id="9" name="Автоматический сбор&#10;точек интереса ">
             <a:extLst xmlns:a="http://schemas.openxmlformats.org/drawingml/2006/main">
               <a:ext uri="{FF2B5EF4-FFF2-40B4-BE49-F238E27FC236}">
-                <a16:creationId xmlns:a16="http://schemas.microsoft.com/office/drawing/2014/main" id="{A436BED6-F0F6-472C-A067-BD2942A5E4B3}"/>
+                <a16:creationId xmlns:a16="http://schemas.microsoft.com/office/drawing/2014/main" id="{0BFC2C2C-682A-44D3-8BC6-EFC7432E19E9}"/>
               </a:ext>
             </a:extLst>
           </p:cNvPr>
@@ -12117,7 +12117,7 @@
           <p:cNvPr id="10" name="02">
             <a:extLst xmlns:a="http://schemas.openxmlformats.org/drawingml/2006/main">
               <a:ext uri="{FF2B5EF4-FFF2-40B4-BE49-F238E27FC236}">
-                <a16:creationId xmlns:a16="http://schemas.microsoft.com/office/drawing/2014/main" id="{03193D8B-565C-435D-A16F-6665B69E61F4}"/>
+                <a16:creationId xmlns:a16="http://schemas.microsoft.com/office/drawing/2014/main" id="{65502936-7A48-4E8C-9BDB-3BC1C414DA21}"/>
               </a:ext>
             </a:extLst>
           </p:cNvPr>
@@ -12280,7 +12280,7 @@
           <p:cNvPr id="11" name="">
             <a:extLst xmlns:a="http://schemas.openxmlformats.org/drawingml/2006/main">
               <a:ext uri="{FF2B5EF4-FFF2-40B4-BE49-F238E27FC236}">
-                <a16:creationId xmlns:a16="http://schemas.microsoft.com/office/drawing/2014/main" id="{CD201286-5703-4CB8-B75D-F4BDEA88F73F}"/>
+                <a16:creationId xmlns:a16="http://schemas.microsoft.com/office/drawing/2014/main" id="{63B1F608-AFA2-4990-B8FB-8A6097FAE945}"/>
               </a:ext>
             </a:extLst>
           </p:cNvPr>
@@ -12320,7 +12320,7 @@
           <p:cNvPr id="12" name="Поиск">
             <a:extLst xmlns:a="http://schemas.openxmlformats.org/drawingml/2006/main">
               <a:ext uri="{FF2B5EF4-FFF2-40B4-BE49-F238E27FC236}">
-                <a16:creationId xmlns:a16="http://schemas.microsoft.com/office/drawing/2014/main" id="{A066E090-10D0-4BBF-A49E-9054AA2A874F}"/>
+                <a16:creationId xmlns:a16="http://schemas.microsoft.com/office/drawing/2014/main" id="{360DAE15-1C3B-4FA5-8A2D-E6ECAEB87B2D}"/>
               </a:ext>
             </a:extLst>
           </p:cNvPr>
@@ -12480,10 +12480,10 @@
       </p:sp>
       <p:sp>
         <p:nvSpPr>
-          <p:cNvPr id="13" name="Релевантные места&#10;по запросу и лока">
+          <p:cNvPr id="13" name="Лексический поиск&#10;по запросу и лока">
             <a:extLst xmlns:a="http://schemas.openxmlformats.org/drawingml/2006/main">
               <a:ext uri="{FF2B5EF4-FFF2-40B4-BE49-F238E27FC236}">
-                <a16:creationId xmlns:a16="http://schemas.microsoft.com/office/drawing/2014/main" id="{FD0F2656-52F2-402E-9174-9B5A24259F50}"/>
+                <a16:creationId xmlns:a16="http://schemas.microsoft.com/office/drawing/2014/main" id="{22B842AE-8983-4D5B-BBD2-15EC1229DD7C}"/>
               </a:ext>
             </a:extLst>
           </p:cNvPr>
@@ -12636,7 +12636,7 @@
                 <a:ea typeface="Segoe UI"/>
                 <a:cs typeface="Segoe UI"/>
               </a:rPr>
-              <a:t>Релевантные места</a:t>
+              <a:t>Лексический поиск</a:t>
             </a:r>
           </a:p>
           <a:p xmlns:a="http://schemas.openxmlformats.org/drawingml/2006/main">
@@ -12673,7 +12673,7 @@
           <p:cNvPr id="14" name="03">
             <a:extLst xmlns:a="http://schemas.openxmlformats.org/drawingml/2006/main">
               <a:ext uri="{FF2B5EF4-FFF2-40B4-BE49-F238E27FC236}">
-                <a16:creationId xmlns:a16="http://schemas.microsoft.com/office/drawing/2014/main" id="{24F3B9B8-685A-400D-8996-573827801186}"/>
+                <a16:creationId xmlns:a16="http://schemas.microsoft.com/office/drawing/2014/main" id="{980E2A20-09C6-4BED-84F7-68243ABB64EC}"/>
               </a:ext>
             </a:extLst>
           </p:cNvPr>
@@ -12836,7 +12836,7 @@
           <p:cNvPr id="15" name="">
             <a:extLst xmlns:a="http://schemas.openxmlformats.org/drawingml/2006/main">
               <a:ext uri="{FF2B5EF4-FFF2-40B4-BE49-F238E27FC236}">
-                <a16:creationId xmlns:a16="http://schemas.microsoft.com/office/drawing/2014/main" id="{BB16C940-17D4-4565-A073-85B35D853F59}"/>
+                <a16:creationId xmlns:a16="http://schemas.microsoft.com/office/drawing/2014/main" id="{BF6A6287-ADB5-4781-8577-D50121E190A9}"/>
               </a:ext>
             </a:extLst>
           </p:cNvPr>
@@ -12876,7 +12876,7 @@
           <p:cNvPr id="16" name="Ограничения">
             <a:extLst xmlns:a="http://schemas.openxmlformats.org/drawingml/2006/main">
               <a:ext uri="{FF2B5EF4-FFF2-40B4-BE49-F238E27FC236}">
-                <a16:creationId xmlns:a16="http://schemas.microsoft.com/office/drawing/2014/main" id="{F5CF9DDA-CF2B-4D71-8CED-3EAAA9DB35FA}"/>
+                <a16:creationId xmlns:a16="http://schemas.microsoft.com/office/drawing/2014/main" id="{62FBCEAF-32E2-4853-9E59-7B9864F612F5}"/>
               </a:ext>
             </a:extLst>
           </p:cNvPr>
@@ -13039,7 +13039,7 @@
           <p:cNvPr id="17" name="Время, возврат,&#10;категории и часы">
             <a:extLst xmlns:a="http://schemas.openxmlformats.org/drawingml/2006/main">
               <a:ext uri="{FF2B5EF4-FFF2-40B4-BE49-F238E27FC236}">
-                <a16:creationId xmlns:a16="http://schemas.microsoft.com/office/drawing/2014/main" id="{D357A1B8-0A4B-4267-8895-849A20B8A03B}"/>
+                <a16:creationId xmlns:a16="http://schemas.microsoft.com/office/drawing/2014/main" id="{4F6E77E8-0552-4875-A74A-2356358A5DF0}"/>
               </a:ext>
             </a:extLst>
           </p:cNvPr>
@@ -13229,7 +13229,7 @@
           <p:cNvPr id="18" name="04">
             <a:extLst xmlns:a="http://schemas.openxmlformats.org/drawingml/2006/main">
               <a:ext uri="{FF2B5EF4-FFF2-40B4-BE49-F238E27FC236}">
-                <a16:creationId xmlns:a16="http://schemas.microsoft.com/office/drawing/2014/main" id="{4C91474F-F8E5-414E-A2A5-AD71FDDBDFDE}"/>
+                <a16:creationId xmlns:a16="http://schemas.microsoft.com/office/drawing/2014/main" id="{B51A69F6-05C0-4CE1-B045-F52965C90D5D}"/>
               </a:ext>
             </a:extLst>
           </p:cNvPr>
@@ -13392,7 +13392,7 @@
           <p:cNvPr id="19" name="">
             <a:extLst xmlns:a="http://schemas.openxmlformats.org/drawingml/2006/main">
               <a:ext uri="{FF2B5EF4-FFF2-40B4-BE49-F238E27FC236}">
-                <a16:creationId xmlns:a16="http://schemas.microsoft.com/office/drawing/2014/main" id="{A49FE790-ABFF-40D4-9B45-C9412AC319EA}"/>
+                <a16:creationId xmlns:a16="http://schemas.microsoft.com/office/drawing/2014/main" id="{C94247AC-86C8-4A78-8122-9C96E4E25259}"/>
               </a:ext>
             </a:extLst>
           </p:cNvPr>
@@ -13432,7 +13432,7 @@
           <p:cNvPr id="20" name="Ответ">
             <a:extLst xmlns:a="http://schemas.openxmlformats.org/drawingml/2006/main">
               <a:ext uri="{FF2B5EF4-FFF2-40B4-BE49-F238E27FC236}">
-                <a16:creationId xmlns:a16="http://schemas.microsoft.com/office/drawing/2014/main" id="{368FA088-2C5D-483B-B6CC-CD9E0EE33D7B}"/>
+                <a16:creationId xmlns:a16="http://schemas.microsoft.com/office/drawing/2014/main" id="{4D68A49E-F49F-4C30-ADB8-0EE65979E9AF}"/>
               </a:ext>
             </a:extLst>
           </p:cNvPr>
@@ -13592,10 +13592,10 @@
       </p:sp>
       <p:sp>
         <p:nvSpPr>
-          <p:cNvPr id="21" name="1–3 варианта&#10;с источниками">
+          <p:cNvPr id="21" name="Модель объясняет&#10;найденные варианты">
             <a:extLst xmlns:a="http://schemas.openxmlformats.org/drawingml/2006/main">
               <a:ext uri="{FF2B5EF4-FFF2-40B4-BE49-F238E27FC236}">
-                <a16:creationId xmlns:a16="http://schemas.microsoft.com/office/drawing/2014/main" id="{9C0B9F92-384E-4A17-84D6-6C3D032B087F}"/>
+                <a16:creationId xmlns:a16="http://schemas.microsoft.com/office/drawing/2014/main" id="{64D4C6F7-D563-46A8-82A5-E730080982D2}"/>
               </a:ext>
             </a:extLst>
           </p:cNvPr>
@@ -13748,7 +13748,7 @@
                 <a:ea typeface="Segoe UI"/>
                 <a:cs typeface="Segoe UI"/>
               </a:rPr>
-              <a:t>1–3 варианта</a:t>
+              <a:t>Модель объясняет</a:t>
             </a:r>
           </a:p>
           <a:p xmlns:a="http://schemas.openxmlformats.org/drawingml/2006/main">
@@ -13775,17 +13775,17 @@
                 <a:ea typeface="Segoe UI"/>
                 <a:cs typeface="Segoe UI"/>
               </a:rPr>
-              <a:t>с источниками</a:t>
+              <a:t>найденные варианты</a:t>
             </a:r>
           </a:p>
         </p:txBody>
       </p:sp>
       <p:sp>
         <p:nvSpPr>
-          <p:cNvPr id="22" name="Факты POI сохраняют источник. Модел">
+          <p:cNvPr id="22" name="OSM, снимок 19.10.2026 11:22 UTC. В">
             <a:extLst xmlns:a="http://schemas.openxmlformats.org/drawingml/2006/main">
               <a:ext uri="{FF2B5EF4-FFF2-40B4-BE49-F238E27FC236}">
-                <a16:creationId xmlns:a16="http://schemas.microsoft.com/office/drawing/2014/main" id="{7A7F12A4-A2F4-4E78-BF0C-A5393AD67D8A}"/>
+                <a16:creationId xmlns:a16="http://schemas.microsoft.com/office/drawing/2014/main" id="{A005631C-C3E3-42DC-9AA7-E2EB08D21DD4}"/>
               </a:ext>
             </a:extLst>
           </p:cNvPr>
@@ -13796,8 +13796,8 @@
         </p:nvSpPr>
         <p:spPr>
           <a:xfrm xmlns:a="http://schemas.openxmlformats.org/drawingml/2006/main">
-            <a:off x="609600" y="5353050"/>
-            <a:ext cx="10763250" cy="704850"/>
+            <a:off x="609600" y="5391150"/>
+            <a:ext cx="10763250" cy="666750"/>
           </a:xfrm>
           <a:prstGeom xmlns:a="http://schemas.openxmlformats.org/drawingml/2006/main" prst="rect">
             <a:avLst/>
@@ -13814,9 +13814,9 @@
           </a:bodyPr>
           <a:lstStyle xmlns:a="http://schemas.openxmlformats.org/drawingml/2006/main">
             <a:defPPr algn="l">
-              <a:defRPr sz="1875" b="0" i="0">
-                <a:solidFill>
-                  <a:srgbClr val="153D3B"/>
+              <a:defRPr sz="1725" b="0" i="0">
+                <a:solidFill>
+                  <a:srgbClr val="52716B"/>
                 </a:solidFill>
                 <a:latin typeface="Segoe UI"/>
                 <a:ea typeface="Segoe UI"/>
@@ -13824,9 +13824,9 @@
               </a:defRPr>
             </a:defPPr>
             <a:lvl1pPr algn="l">
-              <a:defRPr sz="1875" b="0" i="0">
-                <a:solidFill>
-                  <a:srgbClr val="153D3B"/>
+              <a:defRPr sz="1725" b="0" i="0">
+                <a:solidFill>
+                  <a:srgbClr val="52716B"/>
                 </a:solidFill>
                 <a:latin typeface="Segoe UI"/>
                 <a:ea typeface="Segoe UI"/>
@@ -13834,9 +13834,9 @@
               </a:defRPr>
             </a:lvl1pPr>
             <a:lvl2pPr algn="l">
-              <a:defRPr sz="1875" b="0" i="0">
-                <a:solidFill>
-                  <a:srgbClr val="153D3B"/>
+              <a:defRPr sz="1725" b="0" i="0">
+                <a:solidFill>
+                  <a:srgbClr val="52716B"/>
                 </a:solidFill>
                 <a:latin typeface="Segoe UI"/>
                 <a:ea typeface="Segoe UI"/>
@@ -13844,9 +13844,9 @@
               </a:defRPr>
             </a:lvl2pPr>
             <a:lvl3pPr algn="l">
-              <a:defRPr sz="1875" b="0" i="0">
-                <a:solidFill>
-                  <a:srgbClr val="153D3B"/>
+              <a:defRPr sz="1725" b="0" i="0">
+                <a:solidFill>
+                  <a:srgbClr val="52716B"/>
                 </a:solidFill>
                 <a:latin typeface="Segoe UI"/>
                 <a:ea typeface="Segoe UI"/>
@@ -13854,9 +13854,9 @@
               </a:defRPr>
             </a:lvl3pPr>
             <a:lvl4pPr algn="l">
-              <a:defRPr sz="1875" b="0" i="0">
-                <a:solidFill>
-                  <a:srgbClr val="153D3B"/>
+              <a:defRPr sz="1725" b="0" i="0">
+                <a:solidFill>
+                  <a:srgbClr val="52716B"/>
                 </a:solidFill>
                 <a:latin typeface="Segoe UI"/>
                 <a:ea typeface="Segoe UI"/>
@@ -13864,9 +13864,9 @@
               </a:defRPr>
             </a:lvl4pPr>
             <a:lvl5pPr algn="l">
-              <a:defRPr sz="1875" b="0" i="0">
-                <a:solidFill>
-                  <a:srgbClr val="153D3B"/>
+              <a:defRPr sz="1725" b="0" i="0">
+                <a:solidFill>
+                  <a:srgbClr val="52716B"/>
                 </a:solidFill>
                 <a:latin typeface="Segoe UI"/>
                 <a:ea typeface="Segoe UI"/>
@@ -13874,9 +13874,9 @@
               </a:defRPr>
             </a:lvl5pPr>
             <a:lvl6pPr algn="l">
-              <a:defRPr sz="1875" b="0" i="0">
-                <a:solidFill>
-                  <a:srgbClr val="153D3B"/>
+              <a:defRPr sz="1725" b="0" i="0">
+                <a:solidFill>
+                  <a:srgbClr val="52716B"/>
                 </a:solidFill>
                 <a:latin typeface="Segoe UI"/>
                 <a:ea typeface="Segoe UI"/>
@@ -13884,9 +13884,9 @@
               </a:defRPr>
             </a:lvl6pPr>
             <a:lvl7pPr algn="l">
-              <a:defRPr sz="1875" b="0" i="0">
-                <a:solidFill>
-                  <a:srgbClr val="153D3B"/>
+              <a:defRPr sz="1725" b="0" i="0">
+                <a:solidFill>
+                  <a:srgbClr val="52716B"/>
                 </a:solidFill>
                 <a:latin typeface="Segoe UI"/>
                 <a:ea typeface="Segoe UI"/>
@@ -13894,9 +13894,9 @@
               </a:defRPr>
             </a:lvl7pPr>
             <a:lvl8pPr algn="l">
-              <a:defRPr sz="1875" b="0" i="0">
-                <a:solidFill>
-                  <a:srgbClr val="153D3B"/>
+              <a:defRPr sz="1725" b="0" i="0">
+                <a:solidFill>
+                  <a:srgbClr val="52716B"/>
                 </a:solidFill>
                 <a:latin typeface="Segoe UI"/>
                 <a:ea typeface="Segoe UI"/>
@@ -13904,9 +13904,9 @@
               </a:defRPr>
             </a:lvl8pPr>
             <a:lvl9pPr algn="l">
-              <a:defRPr sz="1875" b="0" i="0">
-                <a:solidFill>
-                  <a:srgbClr val="153D3B"/>
+              <a:defRPr sz="1725" b="0" i="0">
+                <a:solidFill>
+                  <a:srgbClr val="52716B"/>
                 </a:solidFill>
                 <a:latin typeface="Segoe UI"/>
                 <a:ea typeface="Segoe UI"/>
@@ -13920,9 +13920,9 @@
                 <a:spcPct val="105000"/>
               </a:lnSpc>
               <a:buNone/>
-              <a:defRPr sz="1875" b="0" i="0">
-                <a:solidFill>
-                  <a:srgbClr val="153D3B"/>
+              <a:defRPr sz="1725" b="0" i="0">
+                <a:solidFill>
+                  <a:srgbClr val="52716B"/>
                 </a:solidFill>
                 <a:latin typeface="Segoe UI"/>
                 <a:ea typeface="Segoe UI"/>
@@ -13930,15 +13930,15 @@
               </a:defRPr>
             </a:pPr>
             <a:r>
-              <a:rPr sz="1875" b="0" i="0">
-                <a:solidFill>
-                  <a:srgbClr val="153D3B"/>
+              <a:rPr sz="1725" b="0" i="0">
+                <a:solidFill>
+                  <a:srgbClr val="52716B"/>
                 </a:solidFill>
                 <a:latin typeface="Segoe UI"/>
                 <a:ea typeface="Segoe UI"/>
                 <a:cs typeface="Segoe UI"/>
               </a:rPr>
-              <a:t>Факты POI сохраняют источник. Модель объясняет найденные варианты.</a:t>
+              <a:t>OSM, снимок 19.10.2026 11:22 UTC. Все исходные источники сохранены.</a:t>
             </a:r>
           </a:p>
           <a:p xmlns:a="http://schemas.openxmlformats.org/drawingml/2006/main">
@@ -13947,9 +13947,9 @@
                 <a:spcPct val="105000"/>
               </a:lnSpc>
               <a:buNone/>
-              <a:defRPr sz="1875" b="0" i="0">
-                <a:solidFill>
-                  <a:srgbClr val="153D3B"/>
+              <a:defRPr sz="1725" b="0" i="0">
+                <a:solidFill>
+                  <a:srgbClr val="52716B"/>
                 </a:solidFill>
                 <a:latin typeface="Segoe UI"/>
                 <a:ea typeface="Segoe UI"/>
@@ -13957,15 +13957,15 @@
               </a:defRPr>
             </a:pPr>
             <a:r>
-              <a:rPr sz="1875" b="0" i="0">
-                <a:solidFill>
-                  <a:srgbClr val="153D3B"/>
+              <a:rPr sz="1725" b="0" i="0">
+                <a:solidFill>
+                  <a:srgbClr val="52716B"/>
                 </a:solidFill>
                 <a:latin typeface="Segoe UI"/>
                 <a:ea typeface="Segoe UI"/>
                 <a:cs typeface="Segoe UI"/>
               </a:rPr>
-              <a:t>Нет данных о розетке или часах? Ответ сохраняет «неизвестно».</a:t>
+              <a:t>Облачный ответ модели по найденным POI проверен.</a:t>
             </a:r>
           </a:p>
         </p:txBody>
@@ -13973,7 +13973,7 @@
     </p:spTree>
     <p:extLst>
       <p:ext uri="{BB962C8B-B14F-4D97-AF65-F5344CB8AC3E}">
-        <p14:creationId xmlns:p14="http://schemas.microsoft.com/office/powerpoint/2010/main" val="192112801"/>
+        <p14:creationId xmlns:p14="http://schemas.microsoft.com/office/powerpoint/2010/main" val="1877615585"/>
       </p:ext>
     </p:extLst>
   </p:cSld>
@@ -14001,10 +14001,10 @@
       </p:grpSpPr>
       <p:sp>
         <p:nvSpPr>
-          <p:cNvPr id="16" name="45 минут у Mega Silk Way">
+          <p:cNvPr id="8" name="Кофе за 45 минут с возвращением">
             <a:extLst xmlns:a="http://schemas.openxmlformats.org/drawingml/2006/main">
               <a:ext uri="{FF2B5EF4-FFF2-40B4-BE49-F238E27FC236}">
-                <a16:creationId xmlns:a16="http://schemas.microsoft.com/office/drawing/2014/main" id="{C3790935-80CD-48B6-8D8A-1E87C4A4A8EB}"/>
+                <a16:creationId xmlns:a16="http://schemas.microsoft.com/office/drawing/2014/main" id="{ECD6651B-E48E-4C1D-9720-3BD74CF2DCAA}"/>
               </a:ext>
             </a:extLst>
           </p:cNvPr>
@@ -14157,17 +14157,17 @@
                 <a:ea typeface="Segoe UI"/>
                 <a:cs typeface="Segoe UI"/>
               </a:rPr>
-              <a:t>45 минут у Mega Silk Way</a:t>
+              <a:t>Кофе за 45 минут с возвращением</a:t>
             </a:r>
           </a:p>
         </p:txBody>
       </p:sp>
       <p:sp>
         <p:nvSpPr>
-          <p:cNvPr id="2" name="Демонстрационный сценарий 1">
+          <p:cNvPr id="2" name="Подлинный снимок финального браузер">
             <a:extLst xmlns:a="http://schemas.openxmlformats.org/drawingml/2006/main">
               <a:ext uri="{FF2B5EF4-FFF2-40B4-BE49-F238E27FC236}">
-                <a16:creationId xmlns:a16="http://schemas.microsoft.com/office/drawing/2014/main" id="{241619ED-40AC-4589-83DA-72E08486295E}"/>
+                <a16:creationId xmlns:a16="http://schemas.microsoft.com/office/drawing/2014/main" id="{B057DA72-A629-4095-BEC2-C5324A05E37D}"/>
               </a:ext>
             </a:extLst>
           </p:cNvPr>
@@ -14320,7 +14320,7 @@
                 <a:ea typeface="Segoe UI"/>
                 <a:cs typeface="Segoe UI"/>
               </a:rPr>
-              <a:t>Демонстрационный сценарий 1</a:t>
+              <a:t>Подлинный снимок финального браузерного прогона</a:t>
             </a:r>
           </a:p>
         </p:txBody>
@@ -14330,7 +14330,7 @@
           <p:cNvPr id="3" name="">
             <a:extLst xmlns:a="http://schemas.openxmlformats.org/drawingml/2006/main">
               <a:ext uri="{FF2B5EF4-FFF2-40B4-BE49-F238E27FC236}">
-                <a16:creationId xmlns:a16="http://schemas.microsoft.com/office/drawing/2014/main" id="{F65882C9-954A-43F8-B859-EF5E6E9CB4C8}"/>
+                <a16:creationId xmlns:a16="http://schemas.microsoft.com/office/drawing/2014/main" id="{E2950F7E-4ADA-4738-A6A2-04FC319388AE}"/>
               </a:ext>
             </a:extLst>
           </p:cNvPr>
@@ -14370,7 +14370,7 @@
           <p:cNvPr id="4" name="ASCENSION">
             <a:extLst xmlns:a="http://schemas.openxmlformats.org/drawingml/2006/main">
               <a:ext uri="{FF2B5EF4-FFF2-40B4-BE49-F238E27FC236}">
-                <a16:creationId xmlns:a16="http://schemas.microsoft.com/office/drawing/2014/main" id="{18E479FF-5443-4D72-AE94-75C43B4F54A2}"/>
+                <a16:creationId xmlns:a16="http://schemas.microsoft.com/office/drawing/2014/main" id="{B9E45C33-B03F-44DE-A48A-7258ED1C1E2B}"/>
               </a:ext>
             </a:extLst>
           </p:cNvPr>
@@ -14533,7 +14533,7 @@
           <p:cNvPr id="5" name="05">
             <a:extLst xmlns:a="http://schemas.openxmlformats.org/drawingml/2006/main">
               <a:ext uri="{FF2B5EF4-FFF2-40B4-BE49-F238E27FC236}">
-                <a16:creationId xmlns:a16="http://schemas.microsoft.com/office/drawing/2014/main" id="{69E8D0FA-C4F5-4FDB-B7C7-C23A6BE3C6A2}"/>
+                <a16:creationId xmlns:a16="http://schemas.microsoft.com/office/drawing/2014/main" id="{542F20EA-DAA4-499A-AB0A-31E8C32738FF}"/>
               </a:ext>
             </a:extLst>
           </p:cNvPr>
@@ -14691,12 +14691,41 @@
           </a:p>
         </p:txBody>
       </p:sp>
-      <p:sp>
-        <p:nvSpPr>
+      <p:pic>
+        <p:nvPicPr>
           <p:cNvPr id="6" name="">
             <a:extLst xmlns:a="http://schemas.openxmlformats.org/drawingml/2006/main">
               <a:ext uri="{FF2B5EF4-FFF2-40B4-BE49-F238E27FC236}">
-                <a16:creationId xmlns:a16="http://schemas.microsoft.com/office/drawing/2014/main" id="{8556B377-AC71-4396-B2D4-01053FAAB87C}"/>
+                <a16:creationId xmlns:a16="http://schemas.microsoft.com/office/drawing/2014/main" id="{0BD62E1D-A5B4-48E7-A3E1-9E6B04F3298E}"/>
+              </a:ext>
+            </a:extLst>
+          </p:cNvPr>
+          <p:cNvPicPr>
+            <a:picLocks xmlns:a="http://schemas.openxmlformats.org/drawingml/2006/main" noChangeAspect="1"/>
+          </p:cNvPicPr>
+          <p:nvPr/>
+        </p:nvPicPr>
+        <p:blipFill>
+          <a:blip xmlns:r="http://schemas.openxmlformats.org/officeDocument/2006/relationships" xmlns:a="http://schemas.openxmlformats.org/drawingml/2006/main" r:embed="R8050b6cbaf5144eb"/>
+          <a:srcRect xmlns:a="http://schemas.openxmlformats.org/drawingml/2006/main" l="3000" t="3500" r="3500" b="53000"/>
+          <a:stretch xmlns:a="http://schemas.openxmlformats.org/drawingml/2006/main"/>
+        </p:blipFill>
+        <p:spPr>
+          <a:xfrm xmlns:a="http://schemas.openxmlformats.org/drawingml/2006/main">
+            <a:off x="609600" y="2276475"/>
+            <a:ext cx="10972800" cy="3000375"/>
+          </a:xfrm>
+          <a:prstGeom xmlns:a="http://schemas.openxmlformats.org/drawingml/2006/main" prst="rect">
+            <a:avLst/>
+          </a:prstGeom>
+        </p:spPr>
+      </p:pic>
+      <p:sp>
+        <p:nvSpPr>
+          <p:cNvPr id="7" name="Gasteria и Starbucks — около 31 мин">
+            <a:extLst xmlns:a="http://schemas.openxmlformats.org/drawingml/2006/main">
+              <a:ext uri="{FF2B5EF4-FFF2-40B4-BE49-F238E27FC236}">
+                <a16:creationId xmlns:a16="http://schemas.microsoft.com/office/drawing/2014/main" id="{81670489-C9DB-48C0-B0E2-5E70CD518FBD}"/>
               </a:ext>
             </a:extLst>
           </p:cNvPr>
@@ -14707,39 +14736,8 @@
         </p:nvSpPr>
         <p:spPr>
           <a:xfrm xmlns:a="http://schemas.openxmlformats.org/drawingml/2006/main">
-            <a:off x="609600" y="2419350"/>
-            <a:ext cx="5191125" cy="2419350"/>
-          </a:xfrm>
-          <a:prstGeom xmlns:a="http://schemas.openxmlformats.org/drawingml/2006/main" prst="rect">
-            <a:avLst/>
-          </a:prstGeom>
-          <a:solidFill xmlns:a="http://schemas.openxmlformats.org/drawingml/2006/main">
-            <a:srgbClr val="CDE4DB"/>
-          </a:solidFill>
-          <a:ln xmlns:a="http://schemas.openxmlformats.org/drawingml/2006/main" w="0">
-            <a:noFill/>
-            <a:prstDash val="solid"/>
-          </a:ln>
-        </p:spPr>
-      </p:sp>
-      <p:sp>
-        <p:nvSpPr>
-          <p:cNvPr id="7" name="«Я у Mega. У меня всего&#10;45 минут, в">
-            <a:extLst xmlns:a="http://schemas.openxmlformats.org/drawingml/2006/main">
-              <a:ext uri="{FF2B5EF4-FFF2-40B4-BE49-F238E27FC236}">
-                <a16:creationId xmlns:a16="http://schemas.microsoft.com/office/drawing/2014/main" id="{946A5385-0C07-46F5-9DF0-5446209E836B}"/>
-              </a:ext>
-            </a:extLst>
-          </p:cNvPr>
-          <p:cNvSpPr>
-            <a:spLocks xmlns:a="http://schemas.openxmlformats.org/drawingml/2006/main" noGrp="1"/>
-          </p:cNvSpPr>
-          <p:nvPr/>
-        </p:nvSpPr>
-        <p:spPr>
-          <a:xfrm xmlns:a="http://schemas.openxmlformats.org/drawingml/2006/main">
-            <a:off x="857250" y="2695575"/>
-            <a:ext cx="4686300" cy="1657350"/>
+            <a:off x="609600" y="5410200"/>
+            <a:ext cx="10858500" cy="685800"/>
           </a:xfrm>
           <a:prstGeom xmlns:a="http://schemas.openxmlformats.org/drawingml/2006/main" prst="rect">
             <a:avLst/>
@@ -14756,9 +14754,9 @@
           </a:bodyPr>
           <a:lstStyle xmlns:a="http://schemas.openxmlformats.org/drawingml/2006/main">
             <a:defPPr algn="l">
-              <a:defRPr sz="2625" b="1" i="0">
-                <a:solidFill>
-                  <a:srgbClr val="153D3B"/>
+              <a:defRPr sz="1725" b="0" i="0">
+                <a:solidFill>
+                  <a:srgbClr val="52716B"/>
                 </a:solidFill>
                 <a:latin typeface="Segoe UI"/>
                 <a:ea typeface="Segoe UI"/>
@@ -14766,9 +14764,9 @@
               </a:defRPr>
             </a:defPPr>
             <a:lvl1pPr algn="l">
-              <a:defRPr sz="2625" b="1" i="0">
-                <a:solidFill>
-                  <a:srgbClr val="153D3B"/>
+              <a:defRPr sz="1725" b="0" i="0">
+                <a:solidFill>
+                  <a:srgbClr val="52716B"/>
                 </a:solidFill>
                 <a:latin typeface="Segoe UI"/>
                 <a:ea typeface="Segoe UI"/>
@@ -14776,9 +14774,9 @@
               </a:defRPr>
             </a:lvl1pPr>
             <a:lvl2pPr algn="l">
-              <a:defRPr sz="2625" b="1" i="0">
-                <a:solidFill>
-                  <a:srgbClr val="153D3B"/>
+              <a:defRPr sz="1725" b="0" i="0">
+                <a:solidFill>
+                  <a:srgbClr val="52716B"/>
                 </a:solidFill>
                 <a:latin typeface="Segoe UI"/>
                 <a:ea typeface="Segoe UI"/>
@@ -14786,9 +14784,9 @@
               </a:defRPr>
             </a:lvl2pPr>
             <a:lvl3pPr algn="l">
-              <a:defRPr sz="2625" b="1" i="0">
-                <a:solidFill>
-                  <a:srgbClr val="153D3B"/>
+              <a:defRPr sz="1725" b="0" i="0">
+                <a:solidFill>
+                  <a:srgbClr val="52716B"/>
                 </a:solidFill>
                 <a:latin typeface="Segoe UI"/>
                 <a:ea typeface="Segoe UI"/>
@@ -14796,9 +14794,9 @@
               </a:defRPr>
             </a:lvl3pPr>
             <a:lvl4pPr algn="l">
-              <a:defRPr sz="2625" b="1" i="0">
-                <a:solidFill>
-                  <a:srgbClr val="153D3B"/>
+              <a:defRPr sz="1725" b="0" i="0">
+                <a:solidFill>
+                  <a:srgbClr val="52716B"/>
                 </a:solidFill>
                 <a:latin typeface="Segoe UI"/>
                 <a:ea typeface="Segoe UI"/>
@@ -14806,9 +14804,9 @@
               </a:defRPr>
             </a:lvl4pPr>
             <a:lvl5pPr algn="l">
-              <a:defRPr sz="2625" b="1" i="0">
-                <a:solidFill>
-                  <a:srgbClr val="153D3B"/>
+              <a:defRPr sz="1725" b="0" i="0">
+                <a:solidFill>
+                  <a:srgbClr val="52716B"/>
                 </a:solidFill>
                 <a:latin typeface="Segoe UI"/>
                 <a:ea typeface="Segoe UI"/>
@@ -14816,9 +14814,9 @@
               </a:defRPr>
             </a:lvl5pPr>
             <a:lvl6pPr algn="l">
-              <a:defRPr sz="2625" b="1" i="0">
-                <a:solidFill>
-                  <a:srgbClr val="153D3B"/>
+              <a:defRPr sz="1725" b="0" i="0">
+                <a:solidFill>
+                  <a:srgbClr val="52716B"/>
                 </a:solidFill>
                 <a:latin typeface="Segoe UI"/>
                 <a:ea typeface="Segoe UI"/>
@@ -14826,9 +14824,9 @@
               </a:defRPr>
             </a:lvl6pPr>
             <a:lvl7pPr algn="l">
-              <a:defRPr sz="2625" b="1" i="0">
-                <a:solidFill>
-                  <a:srgbClr val="153D3B"/>
+              <a:defRPr sz="1725" b="0" i="0">
+                <a:solidFill>
+                  <a:srgbClr val="52716B"/>
                 </a:solidFill>
                 <a:latin typeface="Segoe UI"/>
                 <a:ea typeface="Segoe UI"/>
@@ -14836,9 +14834,9 @@
               </a:defRPr>
             </a:lvl7pPr>
             <a:lvl8pPr algn="l">
-              <a:defRPr sz="2625" b="1" i="0">
-                <a:solidFill>
-                  <a:srgbClr val="153D3B"/>
+              <a:defRPr sz="1725" b="0" i="0">
+                <a:solidFill>
+                  <a:srgbClr val="52716B"/>
                 </a:solidFill>
                 <a:latin typeface="Segoe UI"/>
                 <a:ea typeface="Segoe UI"/>
@@ -14846,9 +14844,9 @@
               </a:defRPr>
             </a:lvl8pPr>
             <a:lvl9pPr algn="l">
-              <a:defRPr sz="2625" b="1" i="0">
-                <a:solidFill>
-                  <a:srgbClr val="153D3B"/>
+              <a:defRPr sz="1725" b="0" i="0">
+                <a:solidFill>
+                  <a:srgbClr val="52716B"/>
                 </a:solidFill>
                 <a:latin typeface="Segoe UI"/>
                 <a:ea typeface="Segoe UI"/>
@@ -14862,9 +14860,9 @@
                 <a:spcPct val="105000"/>
               </a:lnSpc>
               <a:buNone/>
-              <a:defRPr sz="2625" b="1" i="0">
-                <a:solidFill>
-                  <a:srgbClr val="153D3B"/>
+              <a:defRPr sz="1725" b="0" i="0">
+                <a:solidFill>
+                  <a:srgbClr val="52716B"/>
                 </a:solidFill>
                 <a:latin typeface="Segoe UI"/>
                 <a:ea typeface="Segoe UI"/>
@@ -14872,15 +14870,15 @@
               </a:defRPr>
             </a:pPr>
             <a:r>
-              <a:rPr sz="2625" b="1" i="0">
-                <a:solidFill>
-                  <a:srgbClr val="153D3B"/>
+              <a:rPr sz="1725" b="0" i="0">
+                <a:solidFill>
+                  <a:srgbClr val="52716B"/>
                 </a:solidFill>
                 <a:latin typeface="Segoe UI"/>
                 <a:ea typeface="Segoe UI"/>
                 <a:cs typeface="Segoe UI"/>
               </a:rPr>
-              <a:t>«Я у Mega. У меня всего</a:t>
+              <a:t>Gasteria и Starbucks — около 31 минуты. «Лепим и варим» — около 33.</a:t>
             </a:r>
           </a:p>
           <a:p xmlns:a="http://schemas.openxmlformats.org/drawingml/2006/main">
@@ -14889,9 +14887,9 @@
                 <a:spcPct val="105000"/>
               </a:lnSpc>
               <a:buNone/>
-              <a:defRPr sz="2625" b="1" i="0">
-                <a:solidFill>
-                  <a:srgbClr val="153D3B"/>
+              <a:defRPr sz="1725" b="0" i="0">
+                <a:solidFill>
+                  <a:srgbClr val="52716B"/>
                 </a:solidFill>
                 <a:latin typeface="Segoe UI"/>
                 <a:ea typeface="Segoe UI"/>
@@ -14899,977 +14897,15 @@
               </a:defRPr>
             </a:pPr>
             <a:r>
-              <a:rPr sz="2625" b="1" i="0">
-                <a:solidFill>
-                  <a:srgbClr val="153D3B"/>
+              <a:rPr sz="1725" b="0" i="0">
+                <a:solidFill>
+                  <a:srgbClr val="52716B"/>
                 </a:solidFill>
                 <a:latin typeface="Segoe UI"/>
                 <a:ea typeface="Segoe UI"/>
                 <a:cs typeface="Segoe UI"/>
               </a:rPr>
-              <a:t>45 минут, включая</a:t>
-            </a:r>
-          </a:p>
-          <a:p xmlns:a="http://schemas.openxmlformats.org/drawingml/2006/main">
-            <a:pPr algn="l">
-              <a:lnSpc>
-                <a:spcPct val="105000"/>
-              </a:lnSpc>
-              <a:buNone/>
-              <a:defRPr sz="2625" b="1" i="0">
-                <a:solidFill>
-                  <a:srgbClr val="153D3B"/>
-                </a:solidFill>
-                <a:latin typeface="Segoe UI"/>
-                <a:ea typeface="Segoe UI"/>
-                <a:cs typeface="Segoe UI"/>
-              </a:defRPr>
-            </a:pPr>
-            <a:r>
-              <a:rPr sz="2625" b="1" i="0">
-                <a:solidFill>
-                  <a:srgbClr val="153D3B"/>
-                </a:solidFill>
-                <a:latin typeface="Segoe UI"/>
-                <a:ea typeface="Segoe UI"/>
-                <a:cs typeface="Segoe UI"/>
-              </a:rPr>
-              <a:t>возвращение сюда»</a:t>
-            </a:r>
-          </a:p>
-        </p:txBody>
-      </p:sp>
-      <p:sp>
-        <p:nvSpPr>
-          <p:cNvPr id="8" name="Что проверяем">
-            <a:extLst xmlns:a="http://schemas.openxmlformats.org/drawingml/2006/main">
-              <a:ext uri="{FF2B5EF4-FFF2-40B4-BE49-F238E27FC236}">
-                <a16:creationId xmlns:a16="http://schemas.microsoft.com/office/drawing/2014/main" id="{9EAB0D1E-B541-490D-8714-9E3AD3C398ED}"/>
-              </a:ext>
-            </a:extLst>
-          </p:cNvPr>
-          <p:cNvSpPr>
-            <a:spLocks xmlns:a="http://schemas.openxmlformats.org/drawingml/2006/main" noGrp="1"/>
-          </p:cNvSpPr>
-          <p:nvPr/>
-        </p:nvSpPr>
-        <p:spPr>
-          <a:xfrm xmlns:a="http://schemas.openxmlformats.org/drawingml/2006/main">
-            <a:off x="6448425" y="2419350"/>
-            <a:ext cx="4667250" cy="428625"/>
-          </a:xfrm>
-          <a:prstGeom xmlns:a="http://schemas.openxmlformats.org/drawingml/2006/main" prst="rect">
-            <a:avLst/>
-          </a:prstGeom>
-          <a:noFill xmlns:a="http://schemas.openxmlformats.org/drawingml/2006/main"/>
-          <a:ln xmlns:a="http://schemas.openxmlformats.org/drawingml/2006/main" w="0">
-            <a:noFill/>
-            <a:prstDash val="solid"/>
-          </a:ln>
-        </p:spPr>
-        <p:txBody>
-          <a:bodyPr xmlns:a="http://schemas.openxmlformats.org/drawingml/2006/main" wrap="square" lIns="0" tIns="0" rIns="0" bIns="0" anchor="t">
-            <a:noAutofit/>
-          </a:bodyPr>
-          <a:lstStyle xmlns:a="http://schemas.openxmlformats.org/drawingml/2006/main">
-            <a:defPPr algn="l">
-              <a:defRPr sz="2175" b="1" i="0">
-                <a:solidFill>
-                  <a:srgbClr val="153D3B"/>
-                </a:solidFill>
-                <a:latin typeface="Segoe UI"/>
-                <a:ea typeface="Segoe UI"/>
-                <a:cs typeface="Segoe UI"/>
-              </a:defRPr>
-            </a:defPPr>
-            <a:lvl1pPr algn="l">
-              <a:defRPr sz="2175" b="1" i="0">
-                <a:solidFill>
-                  <a:srgbClr val="153D3B"/>
-                </a:solidFill>
-                <a:latin typeface="Segoe UI"/>
-                <a:ea typeface="Segoe UI"/>
-                <a:cs typeface="Segoe UI"/>
-              </a:defRPr>
-            </a:lvl1pPr>
-            <a:lvl2pPr algn="l">
-              <a:defRPr sz="2175" b="1" i="0">
-                <a:solidFill>
-                  <a:srgbClr val="153D3B"/>
-                </a:solidFill>
-                <a:latin typeface="Segoe UI"/>
-                <a:ea typeface="Segoe UI"/>
-                <a:cs typeface="Segoe UI"/>
-              </a:defRPr>
-            </a:lvl2pPr>
-            <a:lvl3pPr algn="l">
-              <a:defRPr sz="2175" b="1" i="0">
-                <a:solidFill>
-                  <a:srgbClr val="153D3B"/>
-                </a:solidFill>
-                <a:latin typeface="Segoe UI"/>
-                <a:ea typeface="Segoe UI"/>
-                <a:cs typeface="Segoe UI"/>
-              </a:defRPr>
-            </a:lvl3pPr>
-            <a:lvl4pPr algn="l">
-              <a:defRPr sz="2175" b="1" i="0">
-                <a:solidFill>
-                  <a:srgbClr val="153D3B"/>
-                </a:solidFill>
-                <a:latin typeface="Segoe UI"/>
-                <a:ea typeface="Segoe UI"/>
-                <a:cs typeface="Segoe UI"/>
-              </a:defRPr>
-            </a:lvl4pPr>
-            <a:lvl5pPr algn="l">
-              <a:defRPr sz="2175" b="1" i="0">
-                <a:solidFill>
-                  <a:srgbClr val="153D3B"/>
-                </a:solidFill>
-                <a:latin typeface="Segoe UI"/>
-                <a:ea typeface="Segoe UI"/>
-                <a:cs typeface="Segoe UI"/>
-              </a:defRPr>
-            </a:lvl5pPr>
-            <a:lvl6pPr algn="l">
-              <a:defRPr sz="2175" b="1" i="0">
-                <a:solidFill>
-                  <a:srgbClr val="153D3B"/>
-                </a:solidFill>
-                <a:latin typeface="Segoe UI"/>
-                <a:ea typeface="Segoe UI"/>
-                <a:cs typeface="Segoe UI"/>
-              </a:defRPr>
-            </a:lvl6pPr>
-            <a:lvl7pPr algn="l">
-              <a:defRPr sz="2175" b="1" i="0">
-                <a:solidFill>
-                  <a:srgbClr val="153D3B"/>
-                </a:solidFill>
-                <a:latin typeface="Segoe UI"/>
-                <a:ea typeface="Segoe UI"/>
-                <a:cs typeface="Segoe UI"/>
-              </a:defRPr>
-            </a:lvl7pPr>
-            <a:lvl8pPr algn="l">
-              <a:defRPr sz="2175" b="1" i="0">
-                <a:solidFill>
-                  <a:srgbClr val="153D3B"/>
-                </a:solidFill>
-                <a:latin typeface="Segoe UI"/>
-                <a:ea typeface="Segoe UI"/>
-                <a:cs typeface="Segoe UI"/>
-              </a:defRPr>
-            </a:lvl8pPr>
-            <a:lvl9pPr algn="l">
-              <a:defRPr sz="2175" b="1" i="0">
-                <a:solidFill>
-                  <a:srgbClr val="153D3B"/>
-                </a:solidFill>
-                <a:latin typeface="Segoe UI"/>
-                <a:ea typeface="Segoe UI"/>
-                <a:cs typeface="Segoe UI"/>
-              </a:defRPr>
-            </a:lvl9pPr>
-          </a:lstStyle>
-          <a:p xmlns:a="http://schemas.openxmlformats.org/drawingml/2006/main">
-            <a:pPr algn="l">
-              <a:lnSpc>
-                <a:spcPct val="105000"/>
-              </a:lnSpc>
-              <a:buNone/>
-              <a:defRPr sz="2175" b="1" i="0">
-                <a:solidFill>
-                  <a:srgbClr val="153D3B"/>
-                </a:solidFill>
-                <a:latin typeface="Segoe UI"/>
-                <a:ea typeface="Segoe UI"/>
-                <a:cs typeface="Segoe UI"/>
-              </a:defRPr>
-            </a:pPr>
-            <a:r>
-              <a:rPr sz="2175" b="1" i="0">
-                <a:solidFill>
-                  <a:srgbClr val="153D3B"/>
-                </a:solidFill>
-                <a:latin typeface="Segoe UI"/>
-                <a:ea typeface="Segoe UI"/>
-                <a:cs typeface="Segoe UI"/>
-              </a:rPr>
-              <a:t>Что проверяем</a:t>
-            </a:r>
-          </a:p>
-        </p:txBody>
-      </p:sp>
-      <p:sp>
-        <p:nvSpPr>
-          <p:cNvPr id="9" name="">
-            <a:extLst xmlns:a="http://schemas.openxmlformats.org/drawingml/2006/main">
-              <a:ext uri="{FF2B5EF4-FFF2-40B4-BE49-F238E27FC236}">
-                <a16:creationId xmlns:a16="http://schemas.microsoft.com/office/drawing/2014/main" id="{4C548587-9C3A-4510-A113-BE833996C9F4}"/>
-              </a:ext>
-            </a:extLst>
-          </p:cNvPr>
-          <p:cNvSpPr>
-            <a:spLocks xmlns:a="http://schemas.openxmlformats.org/drawingml/2006/main" noGrp="1"/>
-          </p:cNvSpPr>
-          <p:nvPr/>
-        </p:nvSpPr>
-        <p:spPr>
-          <a:xfrm xmlns:a="http://schemas.openxmlformats.org/drawingml/2006/main">
-            <a:off x="6496050" y="3124200"/>
-            <a:ext cx="114300" cy="114300"/>
-          </a:xfrm>
-          <a:prstGeom xmlns:a="http://schemas.openxmlformats.org/drawingml/2006/main" prst="ellipse">
-            <a:avLst/>
-          </a:prstGeom>
-          <a:solidFill xmlns:a="http://schemas.openxmlformats.org/drawingml/2006/main">
-            <a:srgbClr val="1D8B82"/>
-          </a:solidFill>
-          <a:ln xmlns:a="http://schemas.openxmlformats.org/drawingml/2006/main" w="0">
-            <a:noFill/>
-            <a:prstDash val="solid"/>
-          </a:ln>
-        </p:spPr>
-      </p:sp>
-      <p:sp>
-        <p:nvSpPr>
-          <p:cNvPr id="10" name="Место из базы с исходной ссылкой">
-            <a:extLst xmlns:a="http://schemas.openxmlformats.org/drawingml/2006/main">
-              <a:ext uri="{FF2B5EF4-FFF2-40B4-BE49-F238E27FC236}">
-                <a16:creationId xmlns:a16="http://schemas.microsoft.com/office/drawing/2014/main" id="{05882A39-79C9-4DB7-B3C2-A2774D3F9774}"/>
-              </a:ext>
-            </a:extLst>
-          </p:cNvPr>
-          <p:cNvSpPr>
-            <a:spLocks xmlns:a="http://schemas.openxmlformats.org/drawingml/2006/main" noGrp="1"/>
-          </p:cNvSpPr>
-          <p:nvPr/>
-        </p:nvSpPr>
-        <p:spPr>
-          <a:xfrm xmlns:a="http://schemas.openxmlformats.org/drawingml/2006/main">
-            <a:off x="6781800" y="2971800"/>
-            <a:ext cx="4610100" cy="590550"/>
-          </a:xfrm>
-          <a:prstGeom xmlns:a="http://schemas.openxmlformats.org/drawingml/2006/main" prst="rect">
-            <a:avLst/>
-          </a:prstGeom>
-          <a:noFill xmlns:a="http://schemas.openxmlformats.org/drawingml/2006/main"/>
-          <a:ln xmlns:a="http://schemas.openxmlformats.org/drawingml/2006/main" w="0">
-            <a:noFill/>
-            <a:prstDash val="solid"/>
-          </a:ln>
-        </p:spPr>
-        <p:txBody>
-          <a:bodyPr xmlns:a="http://schemas.openxmlformats.org/drawingml/2006/main" wrap="square" lIns="0" tIns="0" rIns="0" bIns="0" anchor="t">
-            <a:noAutofit/>
-          </a:bodyPr>
-          <a:lstStyle xmlns:a="http://schemas.openxmlformats.org/drawingml/2006/main">
-            <a:defPPr algn="l">
-              <a:defRPr sz="1950" b="0" i="0">
-                <a:solidFill>
-                  <a:srgbClr val="153D3B"/>
-                </a:solidFill>
-                <a:latin typeface="Segoe UI"/>
-                <a:ea typeface="Segoe UI"/>
-                <a:cs typeface="Segoe UI"/>
-              </a:defRPr>
-            </a:defPPr>
-            <a:lvl1pPr algn="l">
-              <a:defRPr sz="1950" b="0" i="0">
-                <a:solidFill>
-                  <a:srgbClr val="153D3B"/>
-                </a:solidFill>
-                <a:latin typeface="Segoe UI"/>
-                <a:ea typeface="Segoe UI"/>
-                <a:cs typeface="Segoe UI"/>
-              </a:defRPr>
-            </a:lvl1pPr>
-            <a:lvl2pPr algn="l">
-              <a:defRPr sz="1950" b="0" i="0">
-                <a:solidFill>
-                  <a:srgbClr val="153D3B"/>
-                </a:solidFill>
-                <a:latin typeface="Segoe UI"/>
-                <a:ea typeface="Segoe UI"/>
-                <a:cs typeface="Segoe UI"/>
-              </a:defRPr>
-            </a:lvl2pPr>
-            <a:lvl3pPr algn="l">
-              <a:defRPr sz="1950" b="0" i="0">
-                <a:solidFill>
-                  <a:srgbClr val="153D3B"/>
-                </a:solidFill>
-                <a:latin typeface="Segoe UI"/>
-                <a:ea typeface="Segoe UI"/>
-                <a:cs typeface="Segoe UI"/>
-              </a:defRPr>
-            </a:lvl3pPr>
-            <a:lvl4pPr algn="l">
-              <a:defRPr sz="1950" b="0" i="0">
-                <a:solidFill>
-                  <a:srgbClr val="153D3B"/>
-                </a:solidFill>
-                <a:latin typeface="Segoe UI"/>
-                <a:ea typeface="Segoe UI"/>
-                <a:cs typeface="Segoe UI"/>
-              </a:defRPr>
-            </a:lvl4pPr>
-            <a:lvl5pPr algn="l">
-              <a:defRPr sz="1950" b="0" i="0">
-                <a:solidFill>
-                  <a:srgbClr val="153D3B"/>
-                </a:solidFill>
-                <a:latin typeface="Segoe UI"/>
-                <a:ea typeface="Segoe UI"/>
-                <a:cs typeface="Segoe UI"/>
-              </a:defRPr>
-            </a:lvl5pPr>
-            <a:lvl6pPr algn="l">
-              <a:defRPr sz="1950" b="0" i="0">
-                <a:solidFill>
-                  <a:srgbClr val="153D3B"/>
-                </a:solidFill>
-                <a:latin typeface="Segoe UI"/>
-                <a:ea typeface="Segoe UI"/>
-                <a:cs typeface="Segoe UI"/>
-              </a:defRPr>
-            </a:lvl6pPr>
-            <a:lvl7pPr algn="l">
-              <a:defRPr sz="1950" b="0" i="0">
-                <a:solidFill>
-                  <a:srgbClr val="153D3B"/>
-                </a:solidFill>
-                <a:latin typeface="Segoe UI"/>
-                <a:ea typeface="Segoe UI"/>
-                <a:cs typeface="Segoe UI"/>
-              </a:defRPr>
-            </a:lvl7pPr>
-            <a:lvl8pPr algn="l">
-              <a:defRPr sz="1950" b="0" i="0">
-                <a:solidFill>
-                  <a:srgbClr val="153D3B"/>
-                </a:solidFill>
-                <a:latin typeface="Segoe UI"/>
-                <a:ea typeface="Segoe UI"/>
-                <a:cs typeface="Segoe UI"/>
-              </a:defRPr>
-            </a:lvl8pPr>
-            <a:lvl9pPr algn="l">
-              <a:defRPr sz="1950" b="0" i="0">
-                <a:solidFill>
-                  <a:srgbClr val="153D3B"/>
-                </a:solidFill>
-                <a:latin typeface="Segoe UI"/>
-                <a:ea typeface="Segoe UI"/>
-                <a:cs typeface="Segoe UI"/>
-              </a:defRPr>
-            </a:lvl9pPr>
-          </a:lstStyle>
-          <a:p xmlns:a="http://schemas.openxmlformats.org/drawingml/2006/main">
-            <a:pPr algn="l">
-              <a:lnSpc>
-                <a:spcPct val="105000"/>
-              </a:lnSpc>
-              <a:buNone/>
-              <a:defRPr sz="1950" b="0" i="0">
-                <a:solidFill>
-                  <a:srgbClr val="153D3B"/>
-                </a:solidFill>
-                <a:latin typeface="Segoe UI"/>
-                <a:ea typeface="Segoe UI"/>
-                <a:cs typeface="Segoe UI"/>
-              </a:defRPr>
-            </a:pPr>
-            <a:r>
-              <a:rPr sz="1950" b="0" i="0">
-                <a:solidFill>
-                  <a:srgbClr val="153D3B"/>
-                </a:solidFill>
-                <a:latin typeface="Segoe UI"/>
-                <a:ea typeface="Segoe UI"/>
-                <a:cs typeface="Segoe UI"/>
-              </a:rPr>
-              <a:t>Место из базы с исходной ссылкой</a:t>
-            </a:r>
-          </a:p>
-        </p:txBody>
-      </p:sp>
-      <p:sp>
-        <p:nvSpPr>
-          <p:cNvPr id="11" name="">
-            <a:extLst xmlns:a="http://schemas.openxmlformats.org/drawingml/2006/main">
-              <a:ext uri="{FF2B5EF4-FFF2-40B4-BE49-F238E27FC236}">
-                <a16:creationId xmlns:a16="http://schemas.microsoft.com/office/drawing/2014/main" id="{267B4369-1ABB-4F02-A5EE-2B8963E0457F}"/>
-              </a:ext>
-            </a:extLst>
-          </p:cNvPr>
-          <p:cNvSpPr>
-            <a:spLocks xmlns:a="http://schemas.openxmlformats.org/drawingml/2006/main" noGrp="1"/>
-          </p:cNvSpPr>
-          <p:nvPr/>
-        </p:nvSpPr>
-        <p:spPr>
-          <a:xfrm xmlns:a="http://schemas.openxmlformats.org/drawingml/2006/main">
-            <a:off x="6496050" y="3848100"/>
-            <a:ext cx="114300" cy="114300"/>
-          </a:xfrm>
-          <a:prstGeom xmlns:a="http://schemas.openxmlformats.org/drawingml/2006/main" prst="ellipse">
-            <a:avLst/>
-          </a:prstGeom>
-          <a:solidFill xmlns:a="http://schemas.openxmlformats.org/drawingml/2006/main">
-            <a:srgbClr val="1D8B82"/>
-          </a:solidFill>
-          <a:ln xmlns:a="http://schemas.openxmlformats.org/drawingml/2006/main" w="0">
-            <a:noFill/>
-            <a:prstDash val="solid"/>
-          </a:ln>
-        </p:spPr>
-      </p:sp>
-      <p:sp>
-        <p:nvSpPr>
-          <p:cNvPr id="12" name="Весь бюджет, включая возврат">
-            <a:extLst xmlns:a="http://schemas.openxmlformats.org/drawingml/2006/main">
-              <a:ext uri="{FF2B5EF4-FFF2-40B4-BE49-F238E27FC236}">
-                <a16:creationId xmlns:a16="http://schemas.microsoft.com/office/drawing/2014/main" id="{9CC5221C-7CB4-4A4A-8983-17D3620B953F}"/>
-              </a:ext>
-            </a:extLst>
-          </p:cNvPr>
-          <p:cNvSpPr>
-            <a:spLocks xmlns:a="http://schemas.openxmlformats.org/drawingml/2006/main" noGrp="1"/>
-          </p:cNvSpPr>
-          <p:nvPr/>
-        </p:nvSpPr>
-        <p:spPr>
-          <a:xfrm xmlns:a="http://schemas.openxmlformats.org/drawingml/2006/main">
-            <a:off x="6781800" y="3695700"/>
-            <a:ext cx="4610100" cy="590550"/>
-          </a:xfrm>
-          <a:prstGeom xmlns:a="http://schemas.openxmlformats.org/drawingml/2006/main" prst="rect">
-            <a:avLst/>
-          </a:prstGeom>
-          <a:noFill xmlns:a="http://schemas.openxmlformats.org/drawingml/2006/main"/>
-          <a:ln xmlns:a="http://schemas.openxmlformats.org/drawingml/2006/main" w="0">
-            <a:noFill/>
-            <a:prstDash val="solid"/>
-          </a:ln>
-        </p:spPr>
-        <p:txBody>
-          <a:bodyPr xmlns:a="http://schemas.openxmlformats.org/drawingml/2006/main" wrap="square" lIns="0" tIns="0" rIns="0" bIns="0" anchor="t">
-            <a:noAutofit/>
-          </a:bodyPr>
-          <a:lstStyle xmlns:a="http://schemas.openxmlformats.org/drawingml/2006/main">
-            <a:defPPr algn="l">
-              <a:defRPr sz="1950" b="0" i="0">
-                <a:solidFill>
-                  <a:srgbClr val="153D3B"/>
-                </a:solidFill>
-                <a:latin typeface="Segoe UI"/>
-                <a:ea typeface="Segoe UI"/>
-                <a:cs typeface="Segoe UI"/>
-              </a:defRPr>
-            </a:defPPr>
-            <a:lvl1pPr algn="l">
-              <a:defRPr sz="1950" b="0" i="0">
-                <a:solidFill>
-                  <a:srgbClr val="153D3B"/>
-                </a:solidFill>
-                <a:latin typeface="Segoe UI"/>
-                <a:ea typeface="Segoe UI"/>
-                <a:cs typeface="Segoe UI"/>
-              </a:defRPr>
-            </a:lvl1pPr>
-            <a:lvl2pPr algn="l">
-              <a:defRPr sz="1950" b="0" i="0">
-                <a:solidFill>
-                  <a:srgbClr val="153D3B"/>
-                </a:solidFill>
-                <a:latin typeface="Segoe UI"/>
-                <a:ea typeface="Segoe UI"/>
-                <a:cs typeface="Segoe UI"/>
-              </a:defRPr>
-            </a:lvl2pPr>
-            <a:lvl3pPr algn="l">
-              <a:defRPr sz="1950" b="0" i="0">
-                <a:solidFill>
-                  <a:srgbClr val="153D3B"/>
-                </a:solidFill>
-                <a:latin typeface="Segoe UI"/>
-                <a:ea typeface="Segoe UI"/>
-                <a:cs typeface="Segoe UI"/>
-              </a:defRPr>
-            </a:lvl3pPr>
-            <a:lvl4pPr algn="l">
-              <a:defRPr sz="1950" b="0" i="0">
-                <a:solidFill>
-                  <a:srgbClr val="153D3B"/>
-                </a:solidFill>
-                <a:latin typeface="Segoe UI"/>
-                <a:ea typeface="Segoe UI"/>
-                <a:cs typeface="Segoe UI"/>
-              </a:defRPr>
-            </a:lvl4pPr>
-            <a:lvl5pPr algn="l">
-              <a:defRPr sz="1950" b="0" i="0">
-                <a:solidFill>
-                  <a:srgbClr val="153D3B"/>
-                </a:solidFill>
-                <a:latin typeface="Segoe UI"/>
-                <a:ea typeface="Segoe UI"/>
-                <a:cs typeface="Segoe UI"/>
-              </a:defRPr>
-            </a:lvl5pPr>
-            <a:lvl6pPr algn="l">
-              <a:defRPr sz="1950" b="0" i="0">
-                <a:solidFill>
-                  <a:srgbClr val="153D3B"/>
-                </a:solidFill>
-                <a:latin typeface="Segoe UI"/>
-                <a:ea typeface="Segoe UI"/>
-                <a:cs typeface="Segoe UI"/>
-              </a:defRPr>
-            </a:lvl6pPr>
-            <a:lvl7pPr algn="l">
-              <a:defRPr sz="1950" b="0" i="0">
-                <a:solidFill>
-                  <a:srgbClr val="153D3B"/>
-                </a:solidFill>
-                <a:latin typeface="Segoe UI"/>
-                <a:ea typeface="Segoe UI"/>
-                <a:cs typeface="Segoe UI"/>
-              </a:defRPr>
-            </a:lvl7pPr>
-            <a:lvl8pPr algn="l">
-              <a:defRPr sz="1950" b="0" i="0">
-                <a:solidFill>
-                  <a:srgbClr val="153D3B"/>
-                </a:solidFill>
-                <a:latin typeface="Segoe UI"/>
-                <a:ea typeface="Segoe UI"/>
-                <a:cs typeface="Segoe UI"/>
-              </a:defRPr>
-            </a:lvl8pPr>
-            <a:lvl9pPr algn="l">
-              <a:defRPr sz="1950" b="0" i="0">
-                <a:solidFill>
-                  <a:srgbClr val="153D3B"/>
-                </a:solidFill>
-                <a:latin typeface="Segoe UI"/>
-                <a:ea typeface="Segoe UI"/>
-                <a:cs typeface="Segoe UI"/>
-              </a:defRPr>
-            </a:lvl9pPr>
-          </a:lstStyle>
-          <a:p xmlns:a="http://schemas.openxmlformats.org/drawingml/2006/main">
-            <a:pPr algn="l">
-              <a:lnSpc>
-                <a:spcPct val="105000"/>
-              </a:lnSpc>
-              <a:buNone/>
-              <a:defRPr sz="1950" b="0" i="0">
-                <a:solidFill>
-                  <a:srgbClr val="153D3B"/>
-                </a:solidFill>
-                <a:latin typeface="Segoe UI"/>
-                <a:ea typeface="Segoe UI"/>
-                <a:cs typeface="Segoe UI"/>
-              </a:defRPr>
-            </a:pPr>
-            <a:r>
-              <a:rPr sz="1950" b="0" i="0">
-                <a:solidFill>
-                  <a:srgbClr val="153D3B"/>
-                </a:solidFill>
-                <a:latin typeface="Segoe UI"/>
-                <a:ea typeface="Segoe UI"/>
-                <a:cs typeface="Segoe UI"/>
-              </a:rPr>
-              <a:t>Весь бюджет, включая возврат</a:t>
-            </a:r>
-          </a:p>
-        </p:txBody>
-      </p:sp>
-      <p:sp>
-        <p:nvSpPr>
-          <p:cNvPr id="13" name="">
-            <a:extLst xmlns:a="http://schemas.openxmlformats.org/drawingml/2006/main">
-              <a:ext uri="{FF2B5EF4-FFF2-40B4-BE49-F238E27FC236}">
-                <a16:creationId xmlns:a16="http://schemas.microsoft.com/office/drawing/2014/main" id="{D1CD1D4C-BFC9-467D-B74A-10FE671512B0}"/>
-              </a:ext>
-            </a:extLst>
-          </p:cNvPr>
-          <p:cNvSpPr>
-            <a:spLocks xmlns:a="http://schemas.openxmlformats.org/drawingml/2006/main" noGrp="1"/>
-          </p:cNvSpPr>
-          <p:nvPr/>
-        </p:nvSpPr>
-        <p:spPr>
-          <a:xfrm xmlns:a="http://schemas.openxmlformats.org/drawingml/2006/main">
-            <a:off x="6496050" y="4572000"/>
-            <a:ext cx="114300" cy="114300"/>
-          </a:xfrm>
-          <a:prstGeom xmlns:a="http://schemas.openxmlformats.org/drawingml/2006/main" prst="ellipse">
-            <a:avLst/>
-          </a:prstGeom>
-          <a:solidFill xmlns:a="http://schemas.openxmlformats.org/drawingml/2006/main">
-            <a:srgbClr val="1D8B82"/>
-          </a:solidFill>
-          <a:ln xmlns:a="http://schemas.openxmlformats.org/drawingml/2006/main" w="0">
-            <a:noFill/>
-            <a:prstDash val="solid"/>
-          </a:ln>
-        </p:spPr>
-      </p:sp>
-      <p:sp>
-        <p:nvSpPr>
-          <p:cNvPr id="14" name="Почему подходит и что делать там">
-            <a:extLst xmlns:a="http://schemas.openxmlformats.org/drawingml/2006/main">
-              <a:ext uri="{FF2B5EF4-FFF2-40B4-BE49-F238E27FC236}">
-                <a16:creationId xmlns:a16="http://schemas.microsoft.com/office/drawing/2014/main" id="{1421D68F-7355-4135-B3AE-5796CDEA277D}"/>
-              </a:ext>
-            </a:extLst>
-          </p:cNvPr>
-          <p:cNvSpPr>
-            <a:spLocks xmlns:a="http://schemas.openxmlformats.org/drawingml/2006/main" noGrp="1"/>
-          </p:cNvSpPr>
-          <p:nvPr/>
-        </p:nvSpPr>
-        <p:spPr>
-          <a:xfrm xmlns:a="http://schemas.openxmlformats.org/drawingml/2006/main">
-            <a:off x="6781800" y="4419600"/>
-            <a:ext cx="4610100" cy="590550"/>
-          </a:xfrm>
-          <a:prstGeom xmlns:a="http://schemas.openxmlformats.org/drawingml/2006/main" prst="rect">
-            <a:avLst/>
-          </a:prstGeom>
-          <a:noFill xmlns:a="http://schemas.openxmlformats.org/drawingml/2006/main"/>
-          <a:ln xmlns:a="http://schemas.openxmlformats.org/drawingml/2006/main" w="0">
-            <a:noFill/>
-            <a:prstDash val="solid"/>
-          </a:ln>
-        </p:spPr>
-        <p:txBody>
-          <a:bodyPr xmlns:a="http://schemas.openxmlformats.org/drawingml/2006/main" wrap="square" lIns="0" tIns="0" rIns="0" bIns="0" anchor="t">
-            <a:noAutofit/>
-          </a:bodyPr>
-          <a:lstStyle xmlns:a="http://schemas.openxmlformats.org/drawingml/2006/main">
-            <a:defPPr algn="l">
-              <a:defRPr sz="1950" b="0" i="0">
-                <a:solidFill>
-                  <a:srgbClr val="153D3B"/>
-                </a:solidFill>
-                <a:latin typeface="Segoe UI"/>
-                <a:ea typeface="Segoe UI"/>
-                <a:cs typeface="Segoe UI"/>
-              </a:defRPr>
-            </a:defPPr>
-            <a:lvl1pPr algn="l">
-              <a:defRPr sz="1950" b="0" i="0">
-                <a:solidFill>
-                  <a:srgbClr val="153D3B"/>
-                </a:solidFill>
-                <a:latin typeface="Segoe UI"/>
-                <a:ea typeface="Segoe UI"/>
-                <a:cs typeface="Segoe UI"/>
-              </a:defRPr>
-            </a:lvl1pPr>
-            <a:lvl2pPr algn="l">
-              <a:defRPr sz="1950" b="0" i="0">
-                <a:solidFill>
-                  <a:srgbClr val="153D3B"/>
-                </a:solidFill>
-                <a:latin typeface="Segoe UI"/>
-                <a:ea typeface="Segoe UI"/>
-                <a:cs typeface="Segoe UI"/>
-              </a:defRPr>
-            </a:lvl2pPr>
-            <a:lvl3pPr algn="l">
-              <a:defRPr sz="1950" b="0" i="0">
-                <a:solidFill>
-                  <a:srgbClr val="153D3B"/>
-                </a:solidFill>
-                <a:latin typeface="Segoe UI"/>
-                <a:ea typeface="Segoe UI"/>
-                <a:cs typeface="Segoe UI"/>
-              </a:defRPr>
-            </a:lvl3pPr>
-            <a:lvl4pPr algn="l">
-              <a:defRPr sz="1950" b="0" i="0">
-                <a:solidFill>
-                  <a:srgbClr val="153D3B"/>
-                </a:solidFill>
-                <a:latin typeface="Segoe UI"/>
-                <a:ea typeface="Segoe UI"/>
-                <a:cs typeface="Segoe UI"/>
-              </a:defRPr>
-            </a:lvl4pPr>
-            <a:lvl5pPr algn="l">
-              <a:defRPr sz="1950" b="0" i="0">
-                <a:solidFill>
-                  <a:srgbClr val="153D3B"/>
-                </a:solidFill>
-                <a:latin typeface="Segoe UI"/>
-                <a:ea typeface="Segoe UI"/>
-                <a:cs typeface="Segoe UI"/>
-              </a:defRPr>
-            </a:lvl5pPr>
-            <a:lvl6pPr algn="l">
-              <a:defRPr sz="1950" b="0" i="0">
-                <a:solidFill>
-                  <a:srgbClr val="153D3B"/>
-                </a:solidFill>
-                <a:latin typeface="Segoe UI"/>
-                <a:ea typeface="Segoe UI"/>
-                <a:cs typeface="Segoe UI"/>
-              </a:defRPr>
-            </a:lvl6pPr>
-            <a:lvl7pPr algn="l">
-              <a:defRPr sz="1950" b="0" i="0">
-                <a:solidFill>
-                  <a:srgbClr val="153D3B"/>
-                </a:solidFill>
-                <a:latin typeface="Segoe UI"/>
-                <a:ea typeface="Segoe UI"/>
-                <a:cs typeface="Segoe UI"/>
-              </a:defRPr>
-            </a:lvl7pPr>
-            <a:lvl8pPr algn="l">
-              <a:defRPr sz="1950" b="0" i="0">
-                <a:solidFill>
-                  <a:srgbClr val="153D3B"/>
-                </a:solidFill>
-                <a:latin typeface="Segoe UI"/>
-                <a:ea typeface="Segoe UI"/>
-                <a:cs typeface="Segoe UI"/>
-              </a:defRPr>
-            </a:lvl8pPr>
-            <a:lvl9pPr algn="l">
-              <a:defRPr sz="1950" b="0" i="0">
-                <a:solidFill>
-                  <a:srgbClr val="153D3B"/>
-                </a:solidFill>
-                <a:latin typeface="Segoe UI"/>
-                <a:ea typeface="Segoe UI"/>
-                <a:cs typeface="Segoe UI"/>
-              </a:defRPr>
-            </a:lvl9pPr>
-          </a:lstStyle>
-          <a:p xmlns:a="http://schemas.openxmlformats.org/drawingml/2006/main">
-            <a:pPr algn="l">
-              <a:lnSpc>
-                <a:spcPct val="105000"/>
-              </a:lnSpc>
-              <a:buNone/>
-              <a:defRPr sz="1950" b="0" i="0">
-                <a:solidFill>
-                  <a:srgbClr val="153D3B"/>
-                </a:solidFill>
-                <a:latin typeface="Segoe UI"/>
-                <a:ea typeface="Segoe UI"/>
-                <a:cs typeface="Segoe UI"/>
-              </a:defRPr>
-            </a:pPr>
-            <a:r>
-              <a:rPr sz="1950" b="0" i="0">
-                <a:solidFill>
-                  <a:srgbClr val="153D3B"/>
-                </a:solidFill>
-                <a:latin typeface="Segoe UI"/>
-                <a:ea typeface="Segoe UI"/>
-                <a:cs typeface="Segoe UI"/>
-              </a:rPr>
-              <a:t>Почему подходит и что делать там</a:t>
-            </a:r>
-          </a:p>
-        </p:txBody>
-      </p:sp>
-      <p:sp>
-        <p:nvSpPr>
-          <p:cNvPr id="15" name="Если подходящего варианта нет, сист">
-            <a:extLst xmlns:a="http://schemas.openxmlformats.org/drawingml/2006/main">
-              <a:ext uri="{FF2B5EF4-FFF2-40B4-BE49-F238E27FC236}">
-                <a16:creationId xmlns:a16="http://schemas.microsoft.com/office/drawing/2014/main" id="{3844A4CA-1B11-4A76-BB60-1DA0530A7904}"/>
-              </a:ext>
-            </a:extLst>
-          </p:cNvPr>
-          <p:cNvSpPr>
-            <a:spLocks xmlns:a="http://schemas.openxmlformats.org/drawingml/2006/main" noGrp="1"/>
-          </p:cNvSpPr>
-          <p:nvPr/>
-        </p:nvSpPr>
-        <p:spPr>
-          <a:xfrm xmlns:a="http://schemas.openxmlformats.org/drawingml/2006/main">
-            <a:off x="609600" y="5267325"/>
-            <a:ext cx="10668000" cy="742950"/>
-          </a:xfrm>
-          <a:prstGeom xmlns:a="http://schemas.openxmlformats.org/drawingml/2006/main" prst="rect">
-            <a:avLst/>
-          </a:prstGeom>
-          <a:noFill xmlns:a="http://schemas.openxmlformats.org/drawingml/2006/main"/>
-          <a:ln xmlns:a="http://schemas.openxmlformats.org/drawingml/2006/main" w="0">
-            <a:noFill/>
-            <a:prstDash val="solid"/>
-          </a:ln>
-        </p:spPr>
-        <p:txBody>
-          <a:bodyPr xmlns:a="http://schemas.openxmlformats.org/drawingml/2006/main" wrap="square" lIns="0" tIns="0" rIns="0" bIns="0" anchor="t">
-            <a:noAutofit/>
-          </a:bodyPr>
-          <a:lstStyle xmlns:a="http://schemas.openxmlformats.org/drawingml/2006/main">
-            <a:defPPr algn="l">
-              <a:defRPr sz="2175" b="0" i="0">
-                <a:solidFill>
-                  <a:srgbClr val="52716B"/>
-                </a:solidFill>
-                <a:latin typeface="Segoe UI"/>
-                <a:ea typeface="Segoe UI"/>
-                <a:cs typeface="Segoe UI"/>
-              </a:defRPr>
-            </a:defPPr>
-            <a:lvl1pPr algn="l">
-              <a:defRPr sz="2175" b="0" i="0">
-                <a:solidFill>
-                  <a:srgbClr val="52716B"/>
-                </a:solidFill>
-                <a:latin typeface="Segoe UI"/>
-                <a:ea typeface="Segoe UI"/>
-                <a:cs typeface="Segoe UI"/>
-              </a:defRPr>
-            </a:lvl1pPr>
-            <a:lvl2pPr algn="l">
-              <a:defRPr sz="2175" b="0" i="0">
-                <a:solidFill>
-                  <a:srgbClr val="52716B"/>
-                </a:solidFill>
-                <a:latin typeface="Segoe UI"/>
-                <a:ea typeface="Segoe UI"/>
-                <a:cs typeface="Segoe UI"/>
-              </a:defRPr>
-            </a:lvl2pPr>
-            <a:lvl3pPr algn="l">
-              <a:defRPr sz="2175" b="0" i="0">
-                <a:solidFill>
-                  <a:srgbClr val="52716B"/>
-                </a:solidFill>
-                <a:latin typeface="Segoe UI"/>
-                <a:ea typeface="Segoe UI"/>
-                <a:cs typeface="Segoe UI"/>
-              </a:defRPr>
-            </a:lvl3pPr>
-            <a:lvl4pPr algn="l">
-              <a:defRPr sz="2175" b="0" i="0">
-                <a:solidFill>
-                  <a:srgbClr val="52716B"/>
-                </a:solidFill>
-                <a:latin typeface="Segoe UI"/>
-                <a:ea typeface="Segoe UI"/>
-                <a:cs typeface="Segoe UI"/>
-              </a:defRPr>
-            </a:lvl4pPr>
-            <a:lvl5pPr algn="l">
-              <a:defRPr sz="2175" b="0" i="0">
-                <a:solidFill>
-                  <a:srgbClr val="52716B"/>
-                </a:solidFill>
-                <a:latin typeface="Segoe UI"/>
-                <a:ea typeface="Segoe UI"/>
-                <a:cs typeface="Segoe UI"/>
-              </a:defRPr>
-            </a:lvl5pPr>
-            <a:lvl6pPr algn="l">
-              <a:defRPr sz="2175" b="0" i="0">
-                <a:solidFill>
-                  <a:srgbClr val="52716B"/>
-                </a:solidFill>
-                <a:latin typeface="Segoe UI"/>
-                <a:ea typeface="Segoe UI"/>
-                <a:cs typeface="Segoe UI"/>
-              </a:defRPr>
-            </a:lvl6pPr>
-            <a:lvl7pPr algn="l">
-              <a:defRPr sz="2175" b="0" i="0">
-                <a:solidFill>
-                  <a:srgbClr val="52716B"/>
-                </a:solidFill>
-                <a:latin typeface="Segoe UI"/>
-                <a:ea typeface="Segoe UI"/>
-                <a:cs typeface="Segoe UI"/>
-              </a:defRPr>
-            </a:lvl7pPr>
-            <a:lvl8pPr algn="l">
-              <a:defRPr sz="2175" b="0" i="0">
-                <a:solidFill>
-                  <a:srgbClr val="52716B"/>
-                </a:solidFill>
-                <a:latin typeface="Segoe UI"/>
-                <a:ea typeface="Segoe UI"/>
-                <a:cs typeface="Segoe UI"/>
-              </a:defRPr>
-            </a:lvl8pPr>
-            <a:lvl9pPr algn="l">
-              <a:defRPr sz="2175" b="0" i="0">
-                <a:solidFill>
-                  <a:srgbClr val="52716B"/>
-                </a:solidFill>
-                <a:latin typeface="Segoe UI"/>
-                <a:ea typeface="Segoe UI"/>
-                <a:cs typeface="Segoe UI"/>
-              </a:defRPr>
-            </a:lvl9pPr>
-          </a:lstStyle>
-          <a:p xmlns:a="http://schemas.openxmlformats.org/drawingml/2006/main">
-            <a:pPr algn="l">
-              <a:lnSpc>
-                <a:spcPct val="105000"/>
-              </a:lnSpc>
-              <a:buNone/>
-              <a:defRPr sz="2175" b="0" i="0">
-                <a:solidFill>
-                  <a:srgbClr val="52716B"/>
-                </a:solidFill>
-                <a:latin typeface="Segoe UI"/>
-                <a:ea typeface="Segoe UI"/>
-                <a:cs typeface="Segoe UI"/>
-              </a:defRPr>
-            </a:pPr>
-            <a:r>
-              <a:rPr sz="2175" b="0" i="0">
-                <a:solidFill>
-                  <a:srgbClr val="52716B"/>
-                </a:solidFill>
-                <a:latin typeface="Segoe UI"/>
-                <a:ea typeface="Segoe UI"/>
-                <a:cs typeface="Segoe UI"/>
-              </a:rPr>
-              <a:t>Если подходящего варианта нет, система объясняет причину</a:t>
-            </a:r>
-          </a:p>
-          <a:p xmlns:a="http://schemas.openxmlformats.org/drawingml/2006/main">
-            <a:pPr algn="l">
-              <a:lnSpc>
-                <a:spcPct val="105000"/>
-              </a:lnSpc>
-              <a:buNone/>
-              <a:defRPr sz="2175" b="0" i="0">
-                <a:solidFill>
-                  <a:srgbClr val="52716B"/>
-                </a:solidFill>
-                <a:latin typeface="Segoe UI"/>
-                <a:ea typeface="Segoe UI"/>
-                <a:cs typeface="Segoe UI"/>
-              </a:defRPr>
-            </a:pPr>
-            <a:r>
-              <a:rPr sz="2175" b="0" i="0">
-                <a:solidFill>
-                  <a:srgbClr val="52716B"/>
-                </a:solidFill>
-                <a:latin typeface="Segoe UI"/>
-                <a:ea typeface="Segoe UI"/>
-                <a:cs typeface="Segoe UI"/>
-              </a:rPr>
-              <a:t>и предлагает изменить время или ограничения.</a:t>
+              <a:t>Время оценено по расстоянию, без построения пешеходного маршрута.</a:t>
             </a:r>
           </a:p>
         </p:txBody>
@@ -15877,7 +14913,7 @@
     </p:spTree>
     <p:extLst>
       <p:ext uri="{BB962C8B-B14F-4D97-AF65-F5344CB8AC3E}">
-        <p14:creationId xmlns:p14="http://schemas.microsoft.com/office/powerpoint/2010/main" val="86228210"/>
+        <p14:creationId xmlns:p14="http://schemas.microsoft.com/office/powerpoint/2010/main" val="710531182"/>
       </p:ext>
     </p:extLst>
   </p:cSld>
@@ -15905,10 +14941,10 @@
       </p:grpSpPr>
       <p:sp>
         <p:nvSpPr>
-          <p:cNvPr id="14" name="С ребёнком, не дальше 10 минут">
+          <p:cNvPr id="15" name="С ребёнком, не дальше 10 минут">
             <a:extLst xmlns:a="http://schemas.openxmlformats.org/drawingml/2006/main">
               <a:ext uri="{FF2B5EF4-FFF2-40B4-BE49-F238E27FC236}">
-                <a16:creationId xmlns:a16="http://schemas.microsoft.com/office/drawing/2014/main" id="{C1519A52-F680-469E-9952-8180D1BD8594}"/>
+                <a16:creationId xmlns:a16="http://schemas.microsoft.com/office/drawing/2014/main" id="{B723BD15-47C2-47B1-B6A6-C7399F029964}"/>
               </a:ext>
             </a:extLst>
           </p:cNvPr>
@@ -16068,10 +15104,10 @@
       </p:sp>
       <p:sp>
         <p:nvSpPr>
-          <p:cNvPr id="2" name="Демонстрационный сценарий 2">
+          <p:cNvPr id="2" name="Общее окно для визита и возвращения">
             <a:extLst xmlns:a="http://schemas.openxmlformats.org/drawingml/2006/main">
               <a:ext uri="{FF2B5EF4-FFF2-40B4-BE49-F238E27FC236}">
-                <a16:creationId xmlns:a16="http://schemas.microsoft.com/office/drawing/2014/main" id="{0A12F0C7-F8EF-4272-ABBF-4EBDB8F00F3F}"/>
+                <a16:creationId xmlns:a16="http://schemas.microsoft.com/office/drawing/2014/main" id="{73F05147-789C-479B-9CC1-F8E342CF460A}"/>
               </a:ext>
             </a:extLst>
           </p:cNvPr>
@@ -16224,7 +15260,7 @@
                 <a:ea typeface="Segoe UI"/>
                 <a:cs typeface="Segoe UI"/>
               </a:rPr>
-              <a:t>Демонстрационный сценарий 2</a:t>
+              <a:t>Общее окно для визита и возвращения — 60 минут</a:t>
             </a:r>
           </a:p>
         </p:txBody>
@@ -16234,7 +15270,7 @@
           <p:cNvPr id="3" name="">
             <a:extLst xmlns:a="http://schemas.openxmlformats.org/drawingml/2006/main">
               <a:ext uri="{FF2B5EF4-FFF2-40B4-BE49-F238E27FC236}">
-                <a16:creationId xmlns:a16="http://schemas.microsoft.com/office/drawing/2014/main" id="{4060AADD-71E4-4361-8D6E-7B34C7D00431}"/>
+                <a16:creationId xmlns:a16="http://schemas.microsoft.com/office/drawing/2014/main" id="{968E80F8-FA02-48FF-BAD8-676266392B5D}"/>
               </a:ext>
             </a:extLst>
           </p:cNvPr>
@@ -16274,7 +15310,7 @@
           <p:cNvPr id="4" name="ASCENSION">
             <a:extLst xmlns:a="http://schemas.openxmlformats.org/drawingml/2006/main">
               <a:ext uri="{FF2B5EF4-FFF2-40B4-BE49-F238E27FC236}">
-                <a16:creationId xmlns:a16="http://schemas.microsoft.com/office/drawing/2014/main" id="{A895C76C-C267-4E0A-86CC-22DA64708EE7}"/>
+                <a16:creationId xmlns:a16="http://schemas.microsoft.com/office/drawing/2014/main" id="{A46DD7CD-F87C-4CDB-AC52-07057C60F2B1}"/>
               </a:ext>
             </a:extLst>
           </p:cNvPr>
@@ -16437,7 +15473,7 @@
           <p:cNvPr id="5" name="06">
             <a:extLst xmlns:a="http://schemas.openxmlformats.org/drawingml/2006/main">
               <a:ext uri="{FF2B5EF4-FFF2-40B4-BE49-F238E27FC236}">
-                <a16:creationId xmlns:a16="http://schemas.microsoft.com/office/drawing/2014/main" id="{F3573E64-9F8A-4B31-82BA-A5E1577607C5}"/>
+                <a16:creationId xmlns:a16="http://schemas.microsoft.com/office/drawing/2014/main" id="{3E204531-9EC4-4FDA-B7EB-DAC7052A9177}"/>
               </a:ext>
             </a:extLst>
           </p:cNvPr>
@@ -16600,7 +15636,7 @@
           <p:cNvPr id="6" name="10">
             <a:extLst xmlns:a="http://schemas.openxmlformats.org/drawingml/2006/main">
               <a:ext uri="{FF2B5EF4-FFF2-40B4-BE49-F238E27FC236}">
-                <a16:creationId xmlns:a16="http://schemas.microsoft.com/office/drawing/2014/main" id="{1B45134A-A637-4AEF-AA84-F761CD697232}"/>
+                <a16:creationId xmlns:a16="http://schemas.microsoft.com/office/drawing/2014/main" id="{6013D266-A692-4378-BCAF-93A51009F9E2}"/>
               </a:ext>
             </a:extLst>
           </p:cNvPr>
@@ -16763,7 +15799,7 @@
           <p:cNvPr id="7" name="минут пешком до места">
             <a:extLst xmlns:a="http://schemas.openxmlformats.org/drawingml/2006/main">
               <a:ext uri="{FF2B5EF4-FFF2-40B4-BE49-F238E27FC236}">
-                <a16:creationId xmlns:a16="http://schemas.microsoft.com/office/drawing/2014/main" id="{93AC6F36-E81E-4BD4-AC03-BBA731B39707}"/>
+                <a16:creationId xmlns:a16="http://schemas.microsoft.com/office/drawing/2014/main" id="{FB72A7EA-703A-4C50-8201-00996F9176F1}"/>
               </a:ext>
             </a:extLst>
           </p:cNvPr>
@@ -16923,10 +15959,200 @@
       </p:sp>
       <p:sp>
         <p:nvSpPr>
-          <p:cNvPr id="8" name="Жёсткое условие">
+          <p:cNvPr id="8" name="«Сквер»: 40 из 60 минут&#10;10 + 15 + 1">
             <a:extLst xmlns:a="http://schemas.openxmlformats.org/drawingml/2006/main">
               <a:ext uri="{FF2B5EF4-FFF2-40B4-BE49-F238E27FC236}">
-                <a16:creationId xmlns:a16="http://schemas.microsoft.com/office/drawing/2014/main" id="{9A3C0F96-F5E2-465C-92A0-11555EA6D9B9}"/>
+                <a16:creationId xmlns:a16="http://schemas.microsoft.com/office/drawing/2014/main" id="{6F35B403-DE2B-47F2-B906-28F442D3277E}"/>
+              </a:ext>
+            </a:extLst>
+          </p:cNvPr>
+          <p:cNvSpPr>
+            <a:spLocks xmlns:a="http://schemas.openxmlformats.org/drawingml/2006/main" noGrp="1"/>
+          </p:cNvSpPr>
+          <p:nvPr/>
+        </p:nvSpPr>
+        <p:spPr>
+          <a:xfrm xmlns:a="http://schemas.openxmlformats.org/drawingml/2006/main">
+            <a:off x="609600" y="5305425"/>
+            <a:ext cx="4143375" cy="714375"/>
+          </a:xfrm>
+          <a:prstGeom xmlns:a="http://schemas.openxmlformats.org/drawingml/2006/main" prst="rect">
+            <a:avLst/>
+          </a:prstGeom>
+          <a:noFill xmlns:a="http://schemas.openxmlformats.org/drawingml/2006/main"/>
+          <a:ln xmlns:a="http://schemas.openxmlformats.org/drawingml/2006/main" w="0">
+            <a:noFill/>
+            <a:prstDash val="solid"/>
+          </a:ln>
+        </p:spPr>
+        <p:txBody>
+          <a:bodyPr xmlns:a="http://schemas.openxmlformats.org/drawingml/2006/main" wrap="square" lIns="0" tIns="0" rIns="0" bIns="0" anchor="t">
+            <a:noAutofit/>
+          </a:bodyPr>
+          <a:lstStyle xmlns:a="http://schemas.openxmlformats.org/drawingml/2006/main">
+            <a:defPPr algn="l">
+              <a:defRPr sz="1800" b="1" i="0">
+                <a:solidFill>
+                  <a:srgbClr val="1D8B82"/>
+                </a:solidFill>
+                <a:latin typeface="Segoe UI"/>
+                <a:ea typeface="Segoe UI"/>
+                <a:cs typeface="Segoe UI"/>
+              </a:defRPr>
+            </a:defPPr>
+            <a:lvl1pPr algn="l">
+              <a:defRPr sz="1800" b="1" i="0">
+                <a:solidFill>
+                  <a:srgbClr val="1D8B82"/>
+                </a:solidFill>
+                <a:latin typeface="Segoe UI"/>
+                <a:ea typeface="Segoe UI"/>
+                <a:cs typeface="Segoe UI"/>
+              </a:defRPr>
+            </a:lvl1pPr>
+            <a:lvl2pPr algn="l">
+              <a:defRPr sz="1800" b="1" i="0">
+                <a:solidFill>
+                  <a:srgbClr val="1D8B82"/>
+                </a:solidFill>
+                <a:latin typeface="Segoe UI"/>
+                <a:ea typeface="Segoe UI"/>
+                <a:cs typeface="Segoe UI"/>
+              </a:defRPr>
+            </a:lvl2pPr>
+            <a:lvl3pPr algn="l">
+              <a:defRPr sz="1800" b="1" i="0">
+                <a:solidFill>
+                  <a:srgbClr val="1D8B82"/>
+                </a:solidFill>
+                <a:latin typeface="Segoe UI"/>
+                <a:ea typeface="Segoe UI"/>
+                <a:cs typeface="Segoe UI"/>
+              </a:defRPr>
+            </a:lvl3pPr>
+            <a:lvl4pPr algn="l">
+              <a:defRPr sz="1800" b="1" i="0">
+                <a:solidFill>
+                  <a:srgbClr val="1D8B82"/>
+                </a:solidFill>
+                <a:latin typeface="Segoe UI"/>
+                <a:ea typeface="Segoe UI"/>
+                <a:cs typeface="Segoe UI"/>
+              </a:defRPr>
+            </a:lvl4pPr>
+            <a:lvl5pPr algn="l">
+              <a:defRPr sz="1800" b="1" i="0">
+                <a:solidFill>
+                  <a:srgbClr val="1D8B82"/>
+                </a:solidFill>
+                <a:latin typeface="Segoe UI"/>
+                <a:ea typeface="Segoe UI"/>
+                <a:cs typeface="Segoe UI"/>
+              </a:defRPr>
+            </a:lvl5pPr>
+            <a:lvl6pPr algn="l">
+              <a:defRPr sz="1800" b="1" i="0">
+                <a:solidFill>
+                  <a:srgbClr val="1D8B82"/>
+                </a:solidFill>
+                <a:latin typeface="Segoe UI"/>
+                <a:ea typeface="Segoe UI"/>
+                <a:cs typeface="Segoe UI"/>
+              </a:defRPr>
+            </a:lvl6pPr>
+            <a:lvl7pPr algn="l">
+              <a:defRPr sz="1800" b="1" i="0">
+                <a:solidFill>
+                  <a:srgbClr val="1D8B82"/>
+                </a:solidFill>
+                <a:latin typeface="Segoe UI"/>
+                <a:ea typeface="Segoe UI"/>
+                <a:cs typeface="Segoe UI"/>
+              </a:defRPr>
+            </a:lvl7pPr>
+            <a:lvl8pPr algn="l">
+              <a:defRPr sz="1800" b="1" i="0">
+                <a:solidFill>
+                  <a:srgbClr val="1D8B82"/>
+                </a:solidFill>
+                <a:latin typeface="Segoe UI"/>
+                <a:ea typeface="Segoe UI"/>
+                <a:cs typeface="Segoe UI"/>
+              </a:defRPr>
+            </a:lvl8pPr>
+            <a:lvl9pPr algn="l">
+              <a:defRPr sz="1800" b="1" i="0">
+                <a:solidFill>
+                  <a:srgbClr val="1D8B82"/>
+                </a:solidFill>
+                <a:latin typeface="Segoe UI"/>
+                <a:ea typeface="Segoe UI"/>
+                <a:cs typeface="Segoe UI"/>
+              </a:defRPr>
+            </a:lvl9pPr>
+          </a:lstStyle>
+          <a:p xmlns:a="http://schemas.openxmlformats.org/drawingml/2006/main">
+            <a:pPr algn="l">
+              <a:lnSpc>
+                <a:spcPct val="105000"/>
+              </a:lnSpc>
+              <a:buNone/>
+              <a:defRPr sz="1800" b="1" i="0">
+                <a:solidFill>
+                  <a:srgbClr val="1D8B82"/>
+                </a:solidFill>
+                <a:latin typeface="Segoe UI"/>
+                <a:ea typeface="Segoe UI"/>
+                <a:cs typeface="Segoe UI"/>
+              </a:defRPr>
+            </a:pPr>
+            <a:r>
+              <a:rPr sz="1800" b="1" i="0">
+                <a:solidFill>
+                  <a:srgbClr val="1D8B82"/>
+                </a:solidFill>
+                <a:latin typeface="Segoe UI"/>
+                <a:ea typeface="Segoe UI"/>
+                <a:cs typeface="Segoe UI"/>
+              </a:rPr>
+              <a:t>«Сквер»: 40 из 60 минут</a:t>
+            </a:r>
+          </a:p>
+          <a:p xmlns:a="http://schemas.openxmlformats.org/drawingml/2006/main">
+            <a:pPr algn="l">
+              <a:lnSpc>
+                <a:spcPct val="105000"/>
+              </a:lnSpc>
+              <a:buNone/>
+              <a:defRPr sz="1800" b="1" i="0">
+                <a:solidFill>
+                  <a:srgbClr val="1D8B82"/>
+                </a:solidFill>
+                <a:latin typeface="Segoe UI"/>
+                <a:ea typeface="Segoe UI"/>
+                <a:cs typeface="Segoe UI"/>
+              </a:defRPr>
+            </a:pPr>
+            <a:r>
+              <a:rPr sz="1800" b="1" i="0">
+                <a:solidFill>
+                  <a:srgbClr val="1D8B82"/>
+                </a:solidFill>
+                <a:latin typeface="Segoe UI"/>
+                <a:ea typeface="Segoe UI"/>
+                <a:cs typeface="Segoe UI"/>
+              </a:rPr>
+              <a:t>10 + 15 + 10 + 5</a:t>
+            </a:r>
+          </a:p>
+        </p:txBody>
+      </p:sp>
+      <p:sp>
+        <p:nvSpPr>
+          <p:cNvPr id="9" name="Жёсткое условие">
+            <a:extLst xmlns:a="http://schemas.openxmlformats.org/drawingml/2006/main">
+              <a:ext uri="{FF2B5EF4-FFF2-40B4-BE49-F238E27FC236}">
+                <a16:creationId xmlns:a16="http://schemas.microsoft.com/office/drawing/2014/main" id="{817A82D4-E5E8-4A65-AB72-5BE50B2687A2}"/>
               </a:ext>
             </a:extLst>
           </p:cNvPr>
@@ -17086,10 +16312,10 @@
       </p:sp>
       <p:sp>
         <p:nvSpPr>
-          <p:cNvPr id="9" name="Каждый кандидат укладывается&#10;в зада">
+          <p:cNvPr id="10" name="Каждый кандидат укладывается&#10;в зада">
             <a:extLst xmlns:a="http://schemas.openxmlformats.org/drawingml/2006/main">
               <a:ext uri="{FF2B5EF4-FFF2-40B4-BE49-F238E27FC236}">
-                <a16:creationId xmlns:a16="http://schemas.microsoft.com/office/drawing/2014/main" id="{D9BCD55F-4B68-41B6-8A1E-A29A13BCCDE4}"/>
+                <a16:creationId xmlns:a16="http://schemas.microsoft.com/office/drawing/2014/main" id="{3CA610DC-AEED-4884-B61F-2C532579B912}"/>
               </a:ext>
             </a:extLst>
           </p:cNvPr>
@@ -17276,10 +16502,10 @@
       </p:sp>
       <p:sp>
         <p:nvSpPr>
-          <p:cNvPr id="10" name="Общий бюджет">
+          <p:cNvPr id="11" name="Общий бюджет">
             <a:extLst xmlns:a="http://schemas.openxmlformats.org/drawingml/2006/main">
               <a:ext uri="{FF2B5EF4-FFF2-40B4-BE49-F238E27FC236}">
-                <a16:creationId xmlns:a16="http://schemas.microsoft.com/office/drawing/2014/main" id="{3687BD7B-4B03-4790-A5F9-149C8605C88F}"/>
+                <a16:creationId xmlns:a16="http://schemas.microsoft.com/office/drawing/2014/main" id="{C3A95116-EBFD-4291-8036-F39889E57479}"/>
               </a:ext>
             </a:extLst>
           </p:cNvPr>
@@ -17439,10 +16665,10 @@
       </p:sp>
       <p:sp>
         <p:nvSpPr>
-          <p:cNvPr id="11" name="Визит, возврат и резерв&#10;тоже должны">
+          <p:cNvPr id="12" name="Визит, возврат и резерв&#10;тоже должны">
             <a:extLst xmlns:a="http://schemas.openxmlformats.org/drawingml/2006/main">
               <a:ext uri="{FF2B5EF4-FFF2-40B4-BE49-F238E27FC236}">
-                <a16:creationId xmlns:a16="http://schemas.microsoft.com/office/drawing/2014/main" id="{E6497D62-D0AC-499E-9FC8-9419D333C1AF}"/>
+                <a16:creationId xmlns:a16="http://schemas.microsoft.com/office/drawing/2014/main" id="{E7E69EF4-1A36-4402-8055-FFC02B7E300D}"/>
               </a:ext>
             </a:extLst>
           </p:cNvPr>
@@ -17629,10 +16855,10 @@
       </p:sp>
       <p:sp>
         <p:nvSpPr>
-          <p:cNvPr id="12" name="Неизвестные свойства">
+          <p:cNvPr id="13" name="Неизвестные свойства">
             <a:extLst xmlns:a="http://schemas.openxmlformats.org/drawingml/2006/main">
               <a:ext uri="{FF2B5EF4-FFF2-40B4-BE49-F238E27FC236}">
-                <a16:creationId xmlns:a16="http://schemas.microsoft.com/office/drawing/2014/main" id="{D4E47FB0-6C82-46C0-BF70-AA6AC4353456}"/>
+                <a16:creationId xmlns:a16="http://schemas.microsoft.com/office/drawing/2014/main" id="{4811DC60-2166-4A8B-9852-07547248CFEC}"/>
               </a:ext>
             </a:extLst>
           </p:cNvPr>
@@ -17792,10 +17018,10 @@
       </p:sp>
       <p:sp>
         <p:nvSpPr>
-          <p:cNvPr id="13" name="Возраст, доступность и удобства&#10;нел">
+          <p:cNvPr id="14" name="Возраст, доступность и удобства&#10;нел">
             <a:extLst xmlns:a="http://schemas.openxmlformats.org/drawingml/2006/main">
               <a:ext uri="{FF2B5EF4-FFF2-40B4-BE49-F238E27FC236}">
-                <a16:creationId xmlns:a16="http://schemas.microsoft.com/office/drawing/2014/main" id="{1ABF72D1-BCAA-4D03-9BA1-B50ABBDF9B66}"/>
+                <a16:creationId xmlns:a16="http://schemas.microsoft.com/office/drawing/2014/main" id="{0D118D8D-BC8A-4B80-AB53-0CF14AB800ED}"/>
               </a:ext>
             </a:extLst>
           </p:cNvPr>
@@ -17983,7 +17209,7 @@
     </p:spTree>
     <p:extLst>
       <p:ext uri="{BB962C8B-B14F-4D97-AF65-F5344CB8AC3E}">
-        <p14:creationId xmlns:p14="http://schemas.microsoft.com/office/powerpoint/2010/main" val="418901805"/>
+        <p14:creationId xmlns:p14="http://schemas.microsoft.com/office/powerpoint/2010/main" val="943183610"/>
       </p:ext>
     </p:extLst>
   </p:cSld>
@@ -18014,7 +17240,7 @@
           <p:cNvPr id="12" name="Кофе поздно. Розетка неизвестна">
             <a:extLst xmlns:a="http://schemas.openxmlformats.org/drawingml/2006/main">
               <a:ext uri="{FF2B5EF4-FFF2-40B4-BE49-F238E27FC236}">
-                <a16:creationId xmlns:a16="http://schemas.microsoft.com/office/drawing/2014/main" id="{1BCAA310-A536-44F8-B13E-053D78F04F48}"/>
+                <a16:creationId xmlns:a16="http://schemas.microsoft.com/office/drawing/2014/main" id="{14A1F8F5-7CF9-4F27-9043-50AF37443451}"/>
               </a:ext>
             </a:extLst>
           </p:cNvPr>
@@ -18177,7 +17403,7 @@
           <p:cNvPr id="2" name="Демонстрационный сценарий 3">
             <a:extLst xmlns:a="http://schemas.openxmlformats.org/drawingml/2006/main">
               <a:ext uri="{FF2B5EF4-FFF2-40B4-BE49-F238E27FC236}">
-                <a16:creationId xmlns:a16="http://schemas.microsoft.com/office/drawing/2014/main" id="{F78F981B-CDD9-4717-B0AC-508CC89C7392}"/>
+                <a16:creationId xmlns:a16="http://schemas.microsoft.com/office/drawing/2014/main" id="{2DF9A0E0-B689-4FCA-AFEB-9F0FDD860522}"/>
               </a:ext>
             </a:extLst>
           </p:cNvPr>
@@ -18340,7 +17566,7 @@
           <p:cNvPr id="3" name="">
             <a:extLst xmlns:a="http://schemas.openxmlformats.org/drawingml/2006/main">
               <a:ext uri="{FF2B5EF4-FFF2-40B4-BE49-F238E27FC236}">
-                <a16:creationId xmlns:a16="http://schemas.microsoft.com/office/drawing/2014/main" id="{190AD148-3332-4C1B-B5C0-4383938988B2}"/>
+                <a16:creationId xmlns:a16="http://schemas.microsoft.com/office/drawing/2014/main" id="{91402531-F3F0-46B3-AC02-4A8F7BAA0BB2}"/>
               </a:ext>
             </a:extLst>
           </p:cNvPr>
@@ -18380,7 +17606,7 @@
           <p:cNvPr id="4" name="ASCENSION">
             <a:extLst xmlns:a="http://schemas.openxmlformats.org/drawingml/2006/main">
               <a:ext uri="{FF2B5EF4-FFF2-40B4-BE49-F238E27FC236}">
-                <a16:creationId xmlns:a16="http://schemas.microsoft.com/office/drawing/2014/main" id="{CED6DE7B-2130-4F50-B3D4-9A9809D54196}"/>
+                <a16:creationId xmlns:a16="http://schemas.microsoft.com/office/drawing/2014/main" id="{4B4A0D48-2A14-45B0-8191-0A01A25B81F6}"/>
               </a:ext>
             </a:extLst>
           </p:cNvPr>
@@ -18543,7 +17769,7 @@
           <p:cNvPr id="5" name="07">
             <a:extLst xmlns:a="http://schemas.openxmlformats.org/drawingml/2006/main">
               <a:ext uri="{FF2B5EF4-FFF2-40B4-BE49-F238E27FC236}">
-                <a16:creationId xmlns:a16="http://schemas.microsoft.com/office/drawing/2014/main" id="{75CB51B1-C3D0-4B03-A803-94DFEEFE4657}"/>
+                <a16:creationId xmlns:a16="http://schemas.microsoft.com/office/drawing/2014/main" id="{391CAFCC-B832-4DC8-A3C4-2F4283EAE3DD}"/>
               </a:ext>
             </a:extLst>
           </p:cNvPr>
@@ -18706,7 +17932,7 @@
           <p:cNvPr id="6" name="Запрос">
             <a:extLst xmlns:a="http://schemas.openxmlformats.org/drawingml/2006/main">
               <a:ext uri="{FF2B5EF4-FFF2-40B4-BE49-F238E27FC236}">
-                <a16:creationId xmlns:a16="http://schemas.microsoft.com/office/drawing/2014/main" id="{D65A0BD8-51BD-4DA7-97A0-BD26F06B9FA5}"/>
+                <a16:creationId xmlns:a16="http://schemas.microsoft.com/office/drawing/2014/main" id="{419A8840-D69F-4C08-B06E-32444CD38D33}"/>
               </a:ext>
             </a:extLst>
           </p:cNvPr>
@@ -18869,7 +18095,7 @@
           <p:cNvPr id="7" name="«Кафе с розеткой&#10;поздно вечером, ря">
             <a:extLst xmlns:a="http://schemas.openxmlformats.org/drawingml/2006/main">
               <a:ext uri="{FF2B5EF4-FFF2-40B4-BE49-F238E27FC236}">
-                <a16:creationId xmlns:a16="http://schemas.microsoft.com/office/drawing/2014/main" id="{B57BD8CF-7DB5-45C4-8442-EEB2F1F89790}"/>
+                <a16:creationId xmlns:a16="http://schemas.microsoft.com/office/drawing/2014/main" id="{0E831932-60F1-4EBE-B1DD-DB8BAF54F83C}"/>
               </a:ext>
             </a:extLst>
           </p:cNvPr>
@@ -19059,7 +18285,7 @@
           <p:cNvPr id="8" name="">
             <a:extLst xmlns:a="http://schemas.openxmlformats.org/drawingml/2006/main">
               <a:ext uri="{FF2B5EF4-FFF2-40B4-BE49-F238E27FC236}">
-                <a16:creationId xmlns:a16="http://schemas.microsoft.com/office/drawing/2014/main" id="{7BAAF7C0-432B-4A75-B1AC-A2D62CDB7354}"/>
+                <a16:creationId xmlns:a16="http://schemas.microsoft.com/office/drawing/2014/main" id="{BA8C6818-A3CE-472C-B63F-C57BDF2ECCDF}"/>
               </a:ext>
             </a:extLst>
           </p:cNvPr>
@@ -19099,7 +18325,7 @@
           <p:cNvPr id="9" name="Честный тип ответа">
             <a:extLst xmlns:a="http://schemas.openxmlformats.org/drawingml/2006/main">
               <a:ext uri="{FF2B5EF4-FFF2-40B4-BE49-F238E27FC236}">
-                <a16:creationId xmlns:a16="http://schemas.microsoft.com/office/drawing/2014/main" id="{C9BCEA79-D123-4D31-965E-10BF183249F9}"/>
+                <a16:creationId xmlns:a16="http://schemas.microsoft.com/office/drawing/2014/main" id="{43FA6854-5D81-46D5-AFAE-ED013AE16B14}"/>
               </a:ext>
             </a:extLst>
           </p:cNvPr>
@@ -19262,7 +18488,7 @@
           <p:cNvPr id="10" name="«Нет подтверждённых вариантов&#10;с роз">
             <a:extLst xmlns:a="http://schemas.openxmlformats.org/drawingml/2006/main">
               <a:ext uri="{FF2B5EF4-FFF2-40B4-BE49-F238E27FC236}">
-                <a16:creationId xmlns:a16="http://schemas.microsoft.com/office/drawing/2014/main" id="{8BD261AE-ED39-49A8-B639-74956C17BA3E}"/>
+                <a16:creationId xmlns:a16="http://schemas.microsoft.com/office/drawing/2014/main" id="{16017EC5-A990-49AD-B549-C36E358D5EC7}"/>
               </a:ext>
             </a:extLst>
           </p:cNvPr>
@@ -19479,7 +18705,7 @@
           <p:cNvPr id="11" name="Отсутствующий тег сохраняет статус ">
             <a:extLst xmlns:a="http://schemas.openxmlformats.org/drawingml/2006/main">
               <a:ext uri="{FF2B5EF4-FFF2-40B4-BE49-F238E27FC236}">
-                <a16:creationId xmlns:a16="http://schemas.microsoft.com/office/drawing/2014/main" id="{2FB0FF13-10DA-4B7E-97A8-8603B26610A0}"/>
+                <a16:creationId xmlns:a16="http://schemas.microsoft.com/office/drawing/2014/main" id="{83634E52-43C2-4583-8A35-B3A6A3ABB187}"/>
               </a:ext>
             </a:extLst>
           </p:cNvPr>
@@ -19667,7 +18893,7 @@
     </p:spTree>
     <p:extLst>
       <p:ext uri="{BB962C8B-B14F-4D97-AF65-F5344CB8AC3E}">
-        <p14:creationId xmlns:p14="http://schemas.microsoft.com/office/powerpoint/2010/main" val="1783559406"/>
+        <p14:creationId xmlns:p14="http://schemas.microsoft.com/office/powerpoint/2010/main" val="782206329"/>
       </p:ext>
     </p:extLst>
   </p:cSld>
@@ -19695,10 +18921,10 @@
       </p:grpSpPr>
       <p:sp>
         <p:nvSpPr>
-          <p:cNvPr id="18" name="Границы доверия">
+          <p:cNvPr id="18" name="Проверки и границы доверия">
             <a:extLst xmlns:a="http://schemas.openxmlformats.org/drawingml/2006/main">
               <a:ext uri="{FF2B5EF4-FFF2-40B4-BE49-F238E27FC236}">
-                <a16:creationId xmlns:a16="http://schemas.microsoft.com/office/drawing/2014/main" id="{BAA11771-0F5F-439C-A849-3D09BB05CECD}"/>
+                <a16:creationId xmlns:a16="http://schemas.microsoft.com/office/drawing/2014/main" id="{38F7EAE5-E6BF-468B-94C8-7D49B12BD796}"/>
               </a:ext>
             </a:extLst>
           </p:cNvPr>
@@ -19851,17 +19077,17 @@
                 <a:ea typeface="Segoe UI"/>
                 <a:cs typeface="Segoe UI"/>
               </a:rPr>
-              <a:t>Границы доверия</a:t>
+              <a:t>Проверки и границы доверия</a:t>
             </a:r>
           </a:p>
         </p:txBody>
       </p:sp>
       <p:sp>
         <p:nvSpPr>
-          <p:cNvPr id="2" name="Проектные требования к данным, врем">
+          <p:cNvPr id="2" name="23 из 23 автотестов пройдено. Облач">
             <a:extLst xmlns:a="http://schemas.openxmlformats.org/drawingml/2006/main">
               <a:ext uri="{FF2B5EF4-FFF2-40B4-BE49-F238E27FC236}">
-                <a16:creationId xmlns:a16="http://schemas.microsoft.com/office/drawing/2014/main" id="{797183F4-D838-4347-B3E0-CC287C9B1A3E}"/>
+                <a16:creationId xmlns:a16="http://schemas.microsoft.com/office/drawing/2014/main" id="{20B3EC57-7E61-48FE-95F8-A64DEE687E16}"/>
               </a:ext>
             </a:extLst>
           </p:cNvPr>
@@ -20014,7 +19240,7 @@
                 <a:ea typeface="Segoe UI"/>
                 <a:cs typeface="Segoe UI"/>
               </a:rPr>
-              <a:t>Проектные требования к данным, времени и приватности</a:t>
+              <a:t>23 из 23 автотестов пройдено. Облачный ответ модели проверен</a:t>
             </a:r>
           </a:p>
         </p:txBody>
@@ -20024,7 +19250,7 @@
           <p:cNvPr id="3" name="">
             <a:extLst xmlns:a="http://schemas.openxmlformats.org/drawingml/2006/main">
               <a:ext uri="{FF2B5EF4-FFF2-40B4-BE49-F238E27FC236}">
-                <a16:creationId xmlns:a16="http://schemas.microsoft.com/office/drawing/2014/main" id="{D490C611-9642-45E6-84E1-014FFE40CDAE}"/>
+                <a16:creationId xmlns:a16="http://schemas.microsoft.com/office/drawing/2014/main" id="{0A8C98F6-DC53-4DB0-B489-D4B93EB368F1}"/>
               </a:ext>
             </a:extLst>
           </p:cNvPr>
@@ -20064,7 +19290,7 @@
           <p:cNvPr id="4" name="ASCENSION">
             <a:extLst xmlns:a="http://schemas.openxmlformats.org/drawingml/2006/main">
               <a:ext uri="{FF2B5EF4-FFF2-40B4-BE49-F238E27FC236}">
-                <a16:creationId xmlns:a16="http://schemas.microsoft.com/office/drawing/2014/main" id="{11A430A5-9E60-45DB-A3F2-4F46178DE026}"/>
+                <a16:creationId xmlns:a16="http://schemas.microsoft.com/office/drawing/2014/main" id="{B64E3C84-8B45-4FA7-9660-32CA431C3DF0}"/>
               </a:ext>
             </a:extLst>
           </p:cNvPr>
@@ -20227,7 +19453,7 @@
           <p:cNvPr id="5" name="08">
             <a:extLst xmlns:a="http://schemas.openxmlformats.org/drawingml/2006/main">
               <a:ext uri="{FF2B5EF4-FFF2-40B4-BE49-F238E27FC236}">
-                <a16:creationId xmlns:a16="http://schemas.microsoft.com/office/drawing/2014/main" id="{7FD57151-7623-476B-8DDA-8A21D9C4EA61}"/>
+                <a16:creationId xmlns:a16="http://schemas.microsoft.com/office/drawing/2014/main" id="{14FE6769-8F61-42CA-94FE-F6BCBA74FD26}"/>
               </a:ext>
             </a:extLst>
           </p:cNvPr>
@@ -20390,7 +19616,7 @@
           <p:cNvPr id="6" name="Данные">
             <a:extLst xmlns:a="http://schemas.openxmlformats.org/drawingml/2006/main">
               <a:ext uri="{FF2B5EF4-FFF2-40B4-BE49-F238E27FC236}">
-                <a16:creationId xmlns:a16="http://schemas.microsoft.com/office/drawing/2014/main" id="{DAE25BE1-79D9-4739-B45B-5388A0A63A5C}"/>
+                <a16:creationId xmlns:a16="http://schemas.microsoft.com/office/drawing/2014/main" id="{02B89FE7-791C-42B3-828C-E5F704D3B241}"/>
               </a:ext>
             </a:extLst>
           </p:cNvPr>
@@ -20553,7 +19779,7 @@
           <p:cNvPr id="7" name="">
             <a:extLst xmlns:a="http://schemas.openxmlformats.org/drawingml/2006/main">
               <a:ext uri="{FF2B5EF4-FFF2-40B4-BE49-F238E27FC236}">
-                <a16:creationId xmlns:a16="http://schemas.microsoft.com/office/drawing/2014/main" id="{FAB34651-D7AB-4E3A-9BEB-3862DF48CB4E}"/>
+                <a16:creationId xmlns:a16="http://schemas.microsoft.com/office/drawing/2014/main" id="{F5FA3CD8-0314-4FED-910D-52D41AAEC17B}"/>
               </a:ext>
             </a:extLst>
           </p:cNvPr>
@@ -20593,7 +19819,7 @@
           <p:cNvPr id="8" name="OSM может быть неполным&#10;или устарев">
             <a:extLst xmlns:a="http://schemas.openxmlformats.org/drawingml/2006/main">
               <a:ext uri="{FF2B5EF4-FFF2-40B4-BE49-F238E27FC236}">
-                <a16:creationId xmlns:a16="http://schemas.microsoft.com/office/drawing/2014/main" id="{0963E50D-9EA5-4E3E-965B-203D31C263EE}"/>
+                <a16:creationId xmlns:a16="http://schemas.microsoft.com/office/drawing/2014/main" id="{6A266B69-B32C-496F-ADBD-3E8E18091E8F}"/>
               </a:ext>
             </a:extLst>
           </p:cNvPr>
@@ -20783,7 +20009,7 @@
           <p:cNvPr id="9" name="Источник и неизвестные&#10;поля рядом с">
             <a:extLst xmlns:a="http://schemas.openxmlformats.org/drawingml/2006/main">
               <a:ext uri="{FF2B5EF4-FFF2-40B4-BE49-F238E27FC236}">
-                <a16:creationId xmlns:a16="http://schemas.microsoft.com/office/drawing/2014/main" id="{C4B3BEF5-200A-42B7-9B15-5B8D2B2A6CE5}"/>
+                <a16:creationId xmlns:a16="http://schemas.microsoft.com/office/drawing/2014/main" id="{7E5D9F0D-A1D9-4D70-995F-C2BCC177532F}"/>
               </a:ext>
             </a:extLst>
           </p:cNvPr>
@@ -20973,7 +20199,7 @@
           <p:cNvPr id="10" name="Время">
             <a:extLst xmlns:a="http://schemas.openxmlformats.org/drawingml/2006/main">
               <a:ext uri="{FF2B5EF4-FFF2-40B4-BE49-F238E27FC236}">
-                <a16:creationId xmlns:a16="http://schemas.microsoft.com/office/drawing/2014/main" id="{F9F4203D-75C9-4209-A4AB-3C78297B0CC9}"/>
+                <a16:creationId xmlns:a16="http://schemas.microsoft.com/office/drawing/2014/main" id="{E1B79A5E-FCE9-4FA2-A279-D6884AA1B331}"/>
               </a:ext>
             </a:extLst>
           </p:cNvPr>
@@ -21136,7 +20362,7 @@
           <p:cNvPr id="11" name="">
             <a:extLst xmlns:a="http://schemas.openxmlformats.org/drawingml/2006/main">
               <a:ext uri="{FF2B5EF4-FFF2-40B4-BE49-F238E27FC236}">
-                <a16:creationId xmlns:a16="http://schemas.microsoft.com/office/drawing/2014/main" id="{238B2864-1E75-4BD8-B5B2-D8E9B2091951}"/>
+                <a16:creationId xmlns:a16="http://schemas.microsoft.com/office/drawing/2014/main" id="{D436ED09-CAE6-4275-BAC0-18980945F5AB}"/>
               </a:ext>
             </a:extLst>
           </p:cNvPr>
@@ -21173,10 +20399,10 @@
       </p:sp>
       <p:sp>
         <p:nvSpPr>
-          <p:cNvPr id="12" name="Погода, переходы и темп&#10;меняют длит">
+          <p:cNvPr id="12" name="Оценка по расстоянию&#10;без пешего мар">
             <a:extLst xmlns:a="http://schemas.openxmlformats.org/drawingml/2006/main">
               <a:ext uri="{FF2B5EF4-FFF2-40B4-BE49-F238E27FC236}">
-                <a16:creationId xmlns:a16="http://schemas.microsoft.com/office/drawing/2014/main" id="{A58C333A-DDA0-4E81-BA71-4406B0450F7C}"/>
+                <a16:creationId xmlns:a16="http://schemas.microsoft.com/office/drawing/2014/main" id="{BDA5CCB8-876F-44E3-9F92-311FAE02D5F4}"/>
               </a:ext>
             </a:extLst>
           </p:cNvPr>
@@ -21329,7 +20555,7 @@
                 <a:ea typeface="Segoe UI"/>
                 <a:cs typeface="Segoe UI"/>
               </a:rPr>
-              <a:t>Погода, переходы и темп</a:t>
+              <a:t>Оценка по расстоянию</a:t>
             </a:r>
           </a:p>
           <a:p xmlns:a="http://schemas.openxmlformats.org/drawingml/2006/main">
@@ -21356,7 +20582,7 @@
                 <a:ea typeface="Segoe UI"/>
                 <a:cs typeface="Segoe UI"/>
               </a:rPr>
-              <a:t>меняют длительность</a:t>
+              <a:t>без пешего маршрута</a:t>
             </a:r>
           </a:p>
         </p:txBody>
@@ -21366,7 +20592,7 @@
           <p:cNvPr id="13" name="Допущения, резерв&#10;и понятный отказ">
             <a:extLst xmlns:a="http://schemas.openxmlformats.org/drawingml/2006/main">
               <a:ext uri="{FF2B5EF4-FFF2-40B4-BE49-F238E27FC236}">
-                <a16:creationId xmlns:a16="http://schemas.microsoft.com/office/drawing/2014/main" id="{D315D717-8A1E-4490-9F4B-A209EF5CD96A}"/>
+                <a16:creationId xmlns:a16="http://schemas.microsoft.com/office/drawing/2014/main" id="{4D6A3815-2B75-4833-88CB-7CF968688B77}"/>
               </a:ext>
             </a:extLst>
           </p:cNvPr>
@@ -21556,7 +20782,7 @@
           <p:cNvPr id="14" name="Локация">
             <a:extLst xmlns:a="http://schemas.openxmlformats.org/drawingml/2006/main">
               <a:ext uri="{FF2B5EF4-FFF2-40B4-BE49-F238E27FC236}">
-                <a16:creationId xmlns:a16="http://schemas.microsoft.com/office/drawing/2014/main" id="{6D4A5240-5C01-4E3C-8061-CE49EE7F1A88}"/>
+                <a16:creationId xmlns:a16="http://schemas.microsoft.com/office/drawing/2014/main" id="{D9367636-CF5A-4C2F-B69B-FDEAF46C5A5B}"/>
               </a:ext>
             </a:extLst>
           </p:cNvPr>
@@ -21719,7 +20945,7 @@
           <p:cNvPr id="15" name="">
             <a:extLst xmlns:a="http://schemas.openxmlformats.org/drawingml/2006/main">
               <a:ext uri="{FF2B5EF4-FFF2-40B4-BE49-F238E27FC236}">
-                <a16:creationId xmlns:a16="http://schemas.microsoft.com/office/drawing/2014/main" id="{E871303D-F5D9-4965-9AF1-4A6F5E71DBC9}"/>
+                <a16:creationId xmlns:a16="http://schemas.microsoft.com/office/drawing/2014/main" id="{EB94654B-8F3F-42BB-8412-69AF27E45BB6}"/>
               </a:ext>
             </a:extLst>
           </p:cNvPr>
@@ -21759,7 +20985,7 @@
           <p:cNvPr id="16" name="Координаты раскрывают&#10;местоположени">
             <a:extLst xmlns:a="http://schemas.openxmlformats.org/drawingml/2006/main">
               <a:ext uri="{FF2B5EF4-FFF2-40B4-BE49-F238E27FC236}">
-                <a16:creationId xmlns:a16="http://schemas.microsoft.com/office/drawing/2014/main" id="{0459FF5B-79F3-4FD2-B942-46948DFECEDB}"/>
+                <a16:creationId xmlns:a16="http://schemas.microsoft.com/office/drawing/2014/main" id="{F91F680E-BAB2-46D9-91F3-53845E7D170A}"/>
               </a:ext>
             </a:extLst>
           </p:cNvPr>
@@ -21946,10 +21172,10 @@
       </p:sp>
       <p:sp>
         <p:nvSpPr>
-          <p:cNvPr id="17" name="Ручной выбор точки&#10;и минимум хранен">
+          <p:cNvPr id="17" name="Проектная мера:&#10;минимум хранения">
             <a:extLst xmlns:a="http://schemas.openxmlformats.org/drawingml/2006/main">
               <a:ext uri="{FF2B5EF4-FFF2-40B4-BE49-F238E27FC236}">
-                <a16:creationId xmlns:a16="http://schemas.microsoft.com/office/drawing/2014/main" id="{BAB23C30-C7BE-45DA-BD68-DAAFA15CAD14}"/>
+                <a16:creationId xmlns:a16="http://schemas.microsoft.com/office/drawing/2014/main" id="{B35A0FE6-2F20-4C94-BE20-033704C0FE2D}"/>
               </a:ext>
             </a:extLst>
           </p:cNvPr>
@@ -22102,7 +21328,7 @@
                 <a:ea typeface="Segoe UI"/>
                 <a:cs typeface="Segoe UI"/>
               </a:rPr>
-              <a:t>Ручной выбор точки</a:t>
+              <a:t>Проектная мера:</a:t>
             </a:r>
           </a:p>
           <a:p xmlns:a="http://schemas.openxmlformats.org/drawingml/2006/main">
@@ -22129,7 +21355,7 @@
                 <a:ea typeface="Segoe UI"/>
                 <a:cs typeface="Segoe UI"/>
               </a:rPr>
-              <a:t>и минимум хранения</a:t>
+              <a:t>минимум хранения</a:t>
             </a:r>
           </a:p>
         </p:txBody>
@@ -22137,7 +21363,7 @@
     </p:spTree>
     <p:extLst>
       <p:ext uri="{BB962C8B-B14F-4D97-AF65-F5344CB8AC3E}">
-        <p14:creationId xmlns:p14="http://schemas.microsoft.com/office/powerpoint/2010/main" val="883034251"/>
+        <p14:creationId xmlns:p14="http://schemas.microsoft.com/office/powerpoint/2010/main" val="998019675"/>
       </p:ext>
     </p:extLst>
   </p:cSld>
@@ -22165,10 +21391,10 @@
       </p:grpSpPr>
       <p:sp>
         <p:nvSpPr>
-          <p:cNvPr id="19" name="Сначала Астана и короткие прогулки">
+          <p:cNvPr id="21" name="Сначала Астана и короткие прогулки">
             <a:extLst xmlns:a="http://schemas.openxmlformats.org/drawingml/2006/main">
               <a:ext uri="{FF2B5EF4-FFF2-40B4-BE49-F238E27FC236}">
-                <a16:creationId xmlns:a16="http://schemas.microsoft.com/office/drawing/2014/main" id="{447B0577-4097-4CFE-B1F0-2403ABF841A0}"/>
+                <a16:creationId xmlns:a16="http://schemas.microsoft.com/office/drawing/2014/main" id="{D5F7D6E7-F4ED-49C6-808F-4231E08F1D64}"/>
               </a:ext>
             </a:extLst>
           </p:cNvPr>
@@ -22331,7 +21557,7 @@
           <p:cNvPr id="2" name="Ценность продукта: понятный выбор в">
             <a:extLst xmlns:a="http://schemas.openxmlformats.org/drawingml/2006/main">
               <a:ext uri="{FF2B5EF4-FFF2-40B4-BE49-F238E27FC236}">
-                <a16:creationId xmlns:a16="http://schemas.microsoft.com/office/drawing/2014/main" id="{C246C765-8946-479E-910F-EC3356AA566E}"/>
+                <a16:creationId xmlns:a16="http://schemas.microsoft.com/office/drawing/2014/main" id="{091EFF00-1AB5-4210-962D-1F45EDCCC6DF}"/>
               </a:ext>
             </a:extLst>
           </p:cNvPr>
@@ -22494,7 +21720,7 @@
           <p:cNvPr id="3" name="">
             <a:extLst xmlns:a="http://schemas.openxmlformats.org/drawingml/2006/main">
               <a:ext uri="{FF2B5EF4-FFF2-40B4-BE49-F238E27FC236}">
-                <a16:creationId xmlns:a16="http://schemas.microsoft.com/office/drawing/2014/main" id="{9E52E24B-E019-463C-9A7E-7FCE8E6E25DE}"/>
+                <a16:creationId xmlns:a16="http://schemas.microsoft.com/office/drawing/2014/main" id="{E934A5D7-D583-4891-8CEA-E009B6A33389}"/>
               </a:ext>
             </a:extLst>
           </p:cNvPr>
@@ -22534,7 +21760,7 @@
           <p:cNvPr id="4" name="ASCENSION">
             <a:extLst xmlns:a="http://schemas.openxmlformats.org/drawingml/2006/main">
               <a:ext uri="{FF2B5EF4-FFF2-40B4-BE49-F238E27FC236}">
-                <a16:creationId xmlns:a16="http://schemas.microsoft.com/office/drawing/2014/main" id="{E2C79274-68D2-4152-B186-6FFFE966B457}"/>
+                <a16:creationId xmlns:a16="http://schemas.microsoft.com/office/drawing/2014/main" id="{8A4478DC-E3DD-4E48-B16C-87C1AF7BA1E5}"/>
               </a:ext>
             </a:extLst>
           </p:cNvPr>
@@ -22697,7 +21923,7 @@
           <p:cNvPr id="5" name="09">
             <a:extLst xmlns:a="http://schemas.openxmlformats.org/drawingml/2006/main">
               <a:ext uri="{FF2B5EF4-FFF2-40B4-BE49-F238E27FC236}">
-                <a16:creationId xmlns:a16="http://schemas.microsoft.com/office/drawing/2014/main" id="{732133A1-235D-4299-9F67-1861401D0393}"/>
+                <a16:creationId xmlns:a16="http://schemas.microsoft.com/office/drawing/2014/main" id="{832F7FDC-2B4E-422A-A7B4-C94456DC8B46}"/>
               </a:ext>
             </a:extLst>
           </p:cNvPr>
@@ -22860,7 +22086,7 @@
           <p:cNvPr id="6" name="Для кого">
             <a:extLst xmlns:a="http://schemas.openxmlformats.org/drawingml/2006/main">
               <a:ext uri="{FF2B5EF4-FFF2-40B4-BE49-F238E27FC236}">
-                <a16:creationId xmlns:a16="http://schemas.microsoft.com/office/drawing/2014/main" id="{4897E7E9-5CD5-44E5-979E-5894D5B275E8}"/>
+                <a16:creationId xmlns:a16="http://schemas.microsoft.com/office/drawing/2014/main" id="{E846EC30-364D-4275-8003-C598BA96A0F5}"/>
               </a:ext>
             </a:extLst>
           </p:cNvPr>
@@ -23023,7 +22249,7 @@
           <p:cNvPr id="7" name="Жители и гости города&#10;между делами">
             <a:extLst xmlns:a="http://schemas.openxmlformats.org/drawingml/2006/main">
               <a:ext uri="{FF2B5EF4-FFF2-40B4-BE49-F238E27FC236}">
-                <a16:creationId xmlns:a16="http://schemas.microsoft.com/office/drawing/2014/main" id="{64FB9145-883D-42DF-88D0-ACC14A279664}"/>
+                <a16:creationId xmlns:a16="http://schemas.microsoft.com/office/drawing/2014/main" id="{E5B026C5-2E2B-4300-AA5C-AF05E32C23BA}"/>
               </a:ext>
             </a:extLst>
           </p:cNvPr>
@@ -23213,7 +22439,7 @@
           <p:cNvPr id="8" name="Первая география">
             <a:extLst xmlns:a="http://schemas.openxmlformats.org/drawingml/2006/main">
               <a:ext uri="{FF2B5EF4-FFF2-40B4-BE49-F238E27FC236}">
-                <a16:creationId xmlns:a16="http://schemas.microsoft.com/office/drawing/2014/main" id="{2318BB72-3AEE-489F-B9D0-5DBDE2EABE4A}"/>
+                <a16:creationId xmlns:a16="http://schemas.microsoft.com/office/drawing/2014/main" id="{89918903-9247-47B3-9E20-0ECC7BEE2A2D}"/>
               </a:ext>
             </a:extLst>
           </p:cNvPr>
@@ -23376,7 +22602,7 @@
           <p:cNvPr id="9" name="EXPO, Mega и центр Астаны">
             <a:extLst xmlns:a="http://schemas.openxmlformats.org/drawingml/2006/main">
               <a:ext uri="{FF2B5EF4-FFF2-40B4-BE49-F238E27FC236}">
-                <a16:creationId xmlns:a16="http://schemas.microsoft.com/office/drawing/2014/main" id="{134A3C34-6845-4C05-AD7F-27AEA8BF4E4D}"/>
+                <a16:creationId xmlns:a16="http://schemas.microsoft.com/office/drawing/2014/main" id="{D0178C86-D582-4CC6-9B70-4DD45F54E104}"/>
               </a:ext>
             </a:extLst>
           </p:cNvPr>
@@ -23539,7 +22765,7 @@
           <p:cNvPr id="10" name="">
             <a:extLst xmlns:a="http://schemas.openxmlformats.org/drawingml/2006/main">
               <a:ext uri="{FF2B5EF4-FFF2-40B4-BE49-F238E27FC236}">
-                <a16:creationId xmlns:a16="http://schemas.microsoft.com/office/drawing/2014/main" id="{31B56170-6831-401F-962D-F0B3DE6DF748}"/>
+                <a16:creationId xmlns:a16="http://schemas.microsoft.com/office/drawing/2014/main" id="{F76CEF4F-1F91-4B08-BE20-AF576D29D8FA}"/>
               </a:ext>
             </a:extLst>
           </p:cNvPr>
@@ -23570,7 +22796,7 @@
           <p:cNvPr id="11" name="Демо">
             <a:extLst xmlns:a="http://schemas.openxmlformats.org/drawingml/2006/main">
               <a:ext uri="{FF2B5EF4-FFF2-40B4-BE49-F238E27FC236}">
-                <a16:creationId xmlns:a16="http://schemas.microsoft.com/office/drawing/2014/main" id="{E862070D-2FC4-48AF-AC54-87A0F9DC5E57}"/>
+                <a16:creationId xmlns:a16="http://schemas.microsoft.com/office/drawing/2014/main" id="{A9646107-97E4-40AC-93E3-B150F70AF835}"/>
               </a:ext>
             </a:extLst>
           </p:cNvPr>
@@ -23733,7 +22959,7 @@
           <p:cNvPr id="12" name="Три сценария и проверка&#10;каждой реко">
             <a:extLst xmlns:a="http://schemas.openxmlformats.org/drawingml/2006/main">
               <a:ext uri="{FF2B5EF4-FFF2-40B4-BE49-F238E27FC236}">
-                <a16:creationId xmlns:a16="http://schemas.microsoft.com/office/drawing/2014/main" id="{5D1CB68F-6FBE-4A09-84C9-82C572D52E2B}"/>
+                <a16:creationId xmlns:a16="http://schemas.microsoft.com/office/drawing/2014/main" id="{362B859F-17F0-4FBF-B574-57E3178DB008}"/>
               </a:ext>
             </a:extLst>
           </p:cNvPr>
@@ -23923,7 +23149,7 @@
           <p:cNvPr id="13" name="">
             <a:extLst xmlns:a="http://schemas.openxmlformats.org/drawingml/2006/main">
               <a:ext uri="{FF2B5EF4-FFF2-40B4-BE49-F238E27FC236}">
-                <a16:creationId xmlns:a16="http://schemas.microsoft.com/office/drawing/2014/main" id="{1EA4C3F9-5DC1-446F-B84F-01E8993F38AC}"/>
+                <a16:creationId xmlns:a16="http://schemas.microsoft.com/office/drawing/2014/main" id="{AB48F712-B19B-4CA3-B0DA-EC003529D9DF}"/>
               </a:ext>
             </a:extLst>
           </p:cNvPr>
@@ -23954,7 +23180,7 @@
           <p:cNvPr id="14" name="Качество">
             <a:extLst xmlns:a="http://schemas.openxmlformats.org/drawingml/2006/main">
               <a:ext uri="{FF2B5EF4-FFF2-40B4-BE49-F238E27FC236}">
-                <a16:creationId xmlns:a16="http://schemas.microsoft.com/office/drawing/2014/main" id="{749C7D9C-827A-465A-92E0-B6A2A5E6CD6D}"/>
+                <a16:creationId xmlns:a16="http://schemas.microsoft.com/office/drawing/2014/main" id="{89F279E6-F753-4769-BFA6-BF217197ABAD}"/>
               </a:ext>
             </a:extLst>
           </p:cNvPr>
@@ -24117,7 +23343,7 @@
           <p:cNvPr id="15" name="Больше проверенных полей&#10;и точнее п">
             <a:extLst xmlns:a="http://schemas.openxmlformats.org/drawingml/2006/main">
               <a:ext uri="{FF2B5EF4-FFF2-40B4-BE49-F238E27FC236}">
-                <a16:creationId xmlns:a16="http://schemas.microsoft.com/office/drawing/2014/main" id="{6CD98CC5-B65F-49A9-A80B-48B15782AA1D}"/>
+                <a16:creationId xmlns:a16="http://schemas.microsoft.com/office/drawing/2014/main" id="{7B5FBB2F-A9F9-4D52-8CAB-374F7CF3F680}"/>
               </a:ext>
             </a:extLst>
           </p:cNvPr>
@@ -24307,7 +23533,7 @@
           <p:cNvPr id="16" name="">
             <a:extLst xmlns:a="http://schemas.openxmlformats.org/drawingml/2006/main">
               <a:ext uri="{FF2B5EF4-FFF2-40B4-BE49-F238E27FC236}">
-                <a16:creationId xmlns:a16="http://schemas.microsoft.com/office/drawing/2014/main" id="{132AFC1E-75A9-414A-BA1D-84544387276D}"/>
+                <a16:creationId xmlns:a16="http://schemas.microsoft.com/office/drawing/2014/main" id="{D0A01C02-9E67-4BDF-A62E-E0AC493C9EA4}"/>
               </a:ext>
             </a:extLst>
           </p:cNvPr>
@@ -24338,7 +23564,7 @@
           <p:cNvPr id="17" name="Пилот">
             <a:extLst xmlns:a="http://schemas.openxmlformats.org/drawingml/2006/main">
               <a:ext uri="{FF2B5EF4-FFF2-40B4-BE49-F238E27FC236}">
-                <a16:creationId xmlns:a16="http://schemas.microsoft.com/office/drawing/2014/main" id="{4A576FC8-F5D9-4355-95B5-B28271E664BF}"/>
+                <a16:creationId xmlns:a16="http://schemas.microsoft.com/office/drawing/2014/main" id="{6AFFDC72-458D-4C7B-AC00-6C7FBF8DD726}"/>
               </a:ext>
             </a:extLst>
           </p:cNvPr>
@@ -24501,7 +23727,7 @@
           <p:cNvPr id="18" name="Проверка спроса с кампусами&#10;и места">
             <a:extLst xmlns:a="http://schemas.openxmlformats.org/drawingml/2006/main">
               <a:ext uri="{FF2B5EF4-FFF2-40B4-BE49-F238E27FC236}">
-                <a16:creationId xmlns:a16="http://schemas.microsoft.com/office/drawing/2014/main" id="{4758938D-06E8-4EB7-A92A-061937658201}"/>
+                <a16:creationId xmlns:a16="http://schemas.microsoft.com/office/drawing/2014/main" id="{B62838C2-76A2-4942-ABC9-062E93D907F1}"/>
               </a:ext>
             </a:extLst>
           </p:cNvPr>
@@ -24686,10 +23912,336 @@
           </a:p>
         </p:txBody>
       </p:sp>
+      <p:sp>
+        <p:nvSpPr>
+          <p:cNvPr id="19" name="Репозиторий: github.com/Azalytical/">
+            <a:extLst xmlns:a="http://schemas.openxmlformats.org/drawingml/2006/main">
+              <a:ext uri="{FF2B5EF4-FFF2-40B4-BE49-F238E27FC236}">
+                <a16:creationId xmlns:a16="http://schemas.microsoft.com/office/drawing/2014/main" id="{29BACC1B-FBF5-4000-9397-E4C4D8902CA9}"/>
+              </a:ext>
+            </a:extLst>
+          </p:cNvPr>
+          <p:cNvSpPr>
+            <a:spLocks xmlns:a="http://schemas.openxmlformats.org/drawingml/2006/main" noGrp="1"/>
+          </p:cNvSpPr>
+          <p:nvPr/>
+        </p:nvSpPr>
+        <p:spPr>
+          <a:xfrm xmlns:a="http://schemas.openxmlformats.org/drawingml/2006/main">
+            <a:off x="609600" y="5715000"/>
+            <a:ext cx="5429250" cy="228600"/>
+          </a:xfrm>
+          <a:prstGeom xmlns:a="http://schemas.openxmlformats.org/drawingml/2006/main" prst="rect">
+            <a:avLst/>
+          </a:prstGeom>
+          <a:noFill xmlns:a="http://schemas.openxmlformats.org/drawingml/2006/main"/>
+          <a:ln xmlns:a="http://schemas.openxmlformats.org/drawingml/2006/main" w="0">
+            <a:noFill/>
+            <a:prstDash val="solid"/>
+          </a:ln>
+        </p:spPr>
+        <p:txBody>
+          <a:bodyPr xmlns:a="http://schemas.openxmlformats.org/drawingml/2006/main" wrap="square" lIns="0" tIns="0" rIns="0" bIns="0" anchor="t">
+            <a:noAutofit/>
+          </a:bodyPr>
+          <a:lstStyle xmlns:a="http://schemas.openxmlformats.org/drawingml/2006/main">
+            <a:defPPr algn="l">
+              <a:defRPr sz="1275" b="0" i="0">
+                <a:solidFill>
+                  <a:srgbClr val="52716B"/>
+                </a:solidFill>
+                <a:latin typeface="Segoe UI"/>
+                <a:ea typeface="Segoe UI"/>
+                <a:cs typeface="Segoe UI"/>
+              </a:defRPr>
+            </a:defPPr>
+            <a:lvl1pPr algn="l">
+              <a:defRPr sz="1275" b="0" i="0">
+                <a:solidFill>
+                  <a:srgbClr val="52716B"/>
+                </a:solidFill>
+                <a:latin typeface="Segoe UI"/>
+                <a:ea typeface="Segoe UI"/>
+                <a:cs typeface="Segoe UI"/>
+              </a:defRPr>
+            </a:lvl1pPr>
+            <a:lvl2pPr algn="l">
+              <a:defRPr sz="1275" b="0" i="0">
+                <a:solidFill>
+                  <a:srgbClr val="52716B"/>
+                </a:solidFill>
+                <a:latin typeface="Segoe UI"/>
+                <a:ea typeface="Segoe UI"/>
+                <a:cs typeface="Segoe UI"/>
+              </a:defRPr>
+            </a:lvl2pPr>
+            <a:lvl3pPr algn="l">
+              <a:defRPr sz="1275" b="0" i="0">
+                <a:solidFill>
+                  <a:srgbClr val="52716B"/>
+                </a:solidFill>
+                <a:latin typeface="Segoe UI"/>
+                <a:ea typeface="Segoe UI"/>
+                <a:cs typeface="Segoe UI"/>
+              </a:defRPr>
+            </a:lvl3pPr>
+            <a:lvl4pPr algn="l">
+              <a:defRPr sz="1275" b="0" i="0">
+                <a:solidFill>
+                  <a:srgbClr val="52716B"/>
+                </a:solidFill>
+                <a:latin typeface="Segoe UI"/>
+                <a:ea typeface="Segoe UI"/>
+                <a:cs typeface="Segoe UI"/>
+              </a:defRPr>
+            </a:lvl4pPr>
+            <a:lvl5pPr algn="l">
+              <a:defRPr sz="1275" b="0" i="0">
+                <a:solidFill>
+                  <a:srgbClr val="52716B"/>
+                </a:solidFill>
+                <a:latin typeface="Segoe UI"/>
+                <a:ea typeface="Segoe UI"/>
+                <a:cs typeface="Segoe UI"/>
+              </a:defRPr>
+            </a:lvl5pPr>
+            <a:lvl6pPr algn="l">
+              <a:defRPr sz="1275" b="0" i="0">
+                <a:solidFill>
+                  <a:srgbClr val="52716B"/>
+                </a:solidFill>
+                <a:latin typeface="Segoe UI"/>
+                <a:ea typeface="Segoe UI"/>
+                <a:cs typeface="Segoe UI"/>
+              </a:defRPr>
+            </a:lvl6pPr>
+            <a:lvl7pPr algn="l">
+              <a:defRPr sz="1275" b="0" i="0">
+                <a:solidFill>
+                  <a:srgbClr val="52716B"/>
+                </a:solidFill>
+                <a:latin typeface="Segoe UI"/>
+                <a:ea typeface="Segoe UI"/>
+                <a:cs typeface="Segoe UI"/>
+              </a:defRPr>
+            </a:lvl7pPr>
+            <a:lvl8pPr algn="l">
+              <a:defRPr sz="1275" b="0" i="0">
+                <a:solidFill>
+                  <a:srgbClr val="52716B"/>
+                </a:solidFill>
+                <a:latin typeface="Segoe UI"/>
+                <a:ea typeface="Segoe UI"/>
+                <a:cs typeface="Segoe UI"/>
+              </a:defRPr>
+            </a:lvl8pPr>
+            <a:lvl9pPr algn="l">
+              <a:defRPr sz="1275" b="0" i="0">
+                <a:solidFill>
+                  <a:srgbClr val="52716B"/>
+                </a:solidFill>
+                <a:latin typeface="Segoe UI"/>
+                <a:ea typeface="Segoe UI"/>
+                <a:cs typeface="Segoe UI"/>
+              </a:defRPr>
+            </a:lvl9pPr>
+          </a:lstStyle>
+          <a:p xmlns:a="http://schemas.openxmlformats.org/drawingml/2006/main">
+            <a:pPr algn="l">
+              <a:lnSpc>
+                <a:spcPct val="105000"/>
+              </a:lnSpc>
+              <a:buNone/>
+              <a:defRPr sz="1275" b="0" i="0">
+                <a:solidFill>
+                  <a:srgbClr val="52716B"/>
+                </a:solidFill>
+                <a:latin typeface="Segoe UI"/>
+                <a:ea typeface="Segoe UI"/>
+                <a:cs typeface="Segoe UI"/>
+              </a:defRPr>
+            </a:pPr>
+            <a:r>
+              <a:rPr sz="1275" b="0" i="0">
+                <a:solidFill>
+                  <a:srgbClr val="52716B"/>
+                </a:solidFill>
+                <a:latin typeface="Segoe UI"/>
+                <a:ea typeface="Segoe UI"/>
+                <a:cs typeface="Segoe UI"/>
+              </a:rPr>
+              <a:t>Репозиторий: github.com/Azalytical/ascension-smartwalk</a:t>
+            </a:r>
+          </a:p>
+        </p:txBody>
+      </p:sp>
+      <p:sp>
+        <p:nvSpPr>
+          <p:cNvPr id="20" name="Демо: ascension-smartwalk-astana.az">
+            <a:extLst xmlns:a="http://schemas.openxmlformats.org/drawingml/2006/main">
+              <a:ext uri="{FF2B5EF4-FFF2-40B4-BE49-F238E27FC236}">
+                <a16:creationId xmlns:a16="http://schemas.microsoft.com/office/drawing/2014/main" id="{EBD39212-0C60-42E7-9CFA-DB6BAF7124C6}"/>
+              </a:ext>
+            </a:extLst>
+          </p:cNvPr>
+          <p:cNvSpPr>
+            <a:spLocks xmlns:a="http://schemas.openxmlformats.org/drawingml/2006/main" noGrp="1"/>
+          </p:cNvSpPr>
+          <p:nvPr/>
+        </p:nvSpPr>
+        <p:spPr>
+          <a:xfrm xmlns:a="http://schemas.openxmlformats.org/drawingml/2006/main">
+            <a:off x="609600" y="5972175"/>
+            <a:ext cx="10668000" cy="228600"/>
+          </a:xfrm>
+          <a:prstGeom xmlns:a="http://schemas.openxmlformats.org/drawingml/2006/main" prst="rect">
+            <a:avLst/>
+          </a:prstGeom>
+          <a:noFill xmlns:a="http://schemas.openxmlformats.org/drawingml/2006/main"/>
+          <a:ln xmlns:a="http://schemas.openxmlformats.org/drawingml/2006/main" w="0">
+            <a:noFill/>
+            <a:prstDash val="solid"/>
+          </a:ln>
+        </p:spPr>
+        <p:txBody>
+          <a:bodyPr xmlns:a="http://schemas.openxmlformats.org/drawingml/2006/main" wrap="square" lIns="0" tIns="0" rIns="0" bIns="0" anchor="t">
+            <a:noAutofit/>
+          </a:bodyPr>
+          <a:lstStyle xmlns:a="http://schemas.openxmlformats.org/drawingml/2006/main">
+            <a:defPPr algn="l">
+              <a:defRPr sz="1275" b="0" i="0">
+                <a:solidFill>
+                  <a:srgbClr val="52716B"/>
+                </a:solidFill>
+                <a:latin typeface="Segoe UI"/>
+                <a:ea typeface="Segoe UI"/>
+                <a:cs typeface="Segoe UI"/>
+              </a:defRPr>
+            </a:defPPr>
+            <a:lvl1pPr algn="l">
+              <a:defRPr sz="1275" b="0" i="0">
+                <a:solidFill>
+                  <a:srgbClr val="52716B"/>
+                </a:solidFill>
+                <a:latin typeface="Segoe UI"/>
+                <a:ea typeface="Segoe UI"/>
+                <a:cs typeface="Segoe UI"/>
+              </a:defRPr>
+            </a:lvl1pPr>
+            <a:lvl2pPr algn="l">
+              <a:defRPr sz="1275" b="0" i="0">
+                <a:solidFill>
+                  <a:srgbClr val="52716B"/>
+                </a:solidFill>
+                <a:latin typeface="Segoe UI"/>
+                <a:ea typeface="Segoe UI"/>
+                <a:cs typeface="Segoe UI"/>
+              </a:defRPr>
+            </a:lvl2pPr>
+            <a:lvl3pPr algn="l">
+              <a:defRPr sz="1275" b="0" i="0">
+                <a:solidFill>
+                  <a:srgbClr val="52716B"/>
+                </a:solidFill>
+                <a:latin typeface="Segoe UI"/>
+                <a:ea typeface="Segoe UI"/>
+                <a:cs typeface="Segoe UI"/>
+              </a:defRPr>
+            </a:lvl3pPr>
+            <a:lvl4pPr algn="l">
+              <a:defRPr sz="1275" b="0" i="0">
+                <a:solidFill>
+                  <a:srgbClr val="52716B"/>
+                </a:solidFill>
+                <a:latin typeface="Segoe UI"/>
+                <a:ea typeface="Segoe UI"/>
+                <a:cs typeface="Segoe UI"/>
+              </a:defRPr>
+            </a:lvl4pPr>
+            <a:lvl5pPr algn="l">
+              <a:defRPr sz="1275" b="0" i="0">
+                <a:solidFill>
+                  <a:srgbClr val="52716B"/>
+                </a:solidFill>
+                <a:latin typeface="Segoe UI"/>
+                <a:ea typeface="Segoe UI"/>
+                <a:cs typeface="Segoe UI"/>
+              </a:defRPr>
+            </a:lvl5pPr>
+            <a:lvl6pPr algn="l">
+              <a:defRPr sz="1275" b="0" i="0">
+                <a:solidFill>
+                  <a:srgbClr val="52716B"/>
+                </a:solidFill>
+                <a:latin typeface="Segoe UI"/>
+                <a:ea typeface="Segoe UI"/>
+                <a:cs typeface="Segoe UI"/>
+              </a:defRPr>
+            </a:lvl6pPr>
+            <a:lvl7pPr algn="l">
+              <a:defRPr sz="1275" b="0" i="0">
+                <a:solidFill>
+                  <a:srgbClr val="52716B"/>
+                </a:solidFill>
+                <a:latin typeface="Segoe UI"/>
+                <a:ea typeface="Segoe UI"/>
+                <a:cs typeface="Segoe UI"/>
+              </a:defRPr>
+            </a:lvl7pPr>
+            <a:lvl8pPr algn="l">
+              <a:defRPr sz="1275" b="0" i="0">
+                <a:solidFill>
+                  <a:srgbClr val="52716B"/>
+                </a:solidFill>
+                <a:latin typeface="Segoe UI"/>
+                <a:ea typeface="Segoe UI"/>
+                <a:cs typeface="Segoe UI"/>
+              </a:defRPr>
+            </a:lvl8pPr>
+            <a:lvl9pPr algn="l">
+              <a:defRPr sz="1275" b="0" i="0">
+                <a:solidFill>
+                  <a:srgbClr val="52716B"/>
+                </a:solidFill>
+                <a:latin typeface="Segoe UI"/>
+                <a:ea typeface="Segoe UI"/>
+                <a:cs typeface="Segoe UI"/>
+              </a:defRPr>
+            </a:lvl9pPr>
+          </a:lstStyle>
+          <a:p xmlns:a="http://schemas.openxmlformats.org/drawingml/2006/main">
+            <a:pPr algn="l">
+              <a:lnSpc>
+                <a:spcPct val="105000"/>
+              </a:lnSpc>
+              <a:buNone/>
+              <a:defRPr sz="1275" b="0" i="0">
+                <a:solidFill>
+                  <a:srgbClr val="52716B"/>
+                </a:solidFill>
+                <a:latin typeface="Segoe UI"/>
+                <a:ea typeface="Segoe UI"/>
+                <a:cs typeface="Segoe UI"/>
+              </a:defRPr>
+            </a:pPr>
+            <a:r>
+              <a:rPr sz="1275" b="0" i="0">
+                <a:solidFill>
+                  <a:srgbClr val="52716B"/>
+                </a:solidFill>
+                <a:latin typeface="Segoe UI"/>
+                <a:ea typeface="Segoe UI"/>
+                <a:cs typeface="Segoe UI"/>
+              </a:rPr>
+              <a:t>Демо: ascension-smartwalk-astana.azamatbreach.chatgpt.site</a:t>
+            </a:r>
+          </a:p>
+        </p:txBody>
+      </p:sp>
     </p:spTree>
     <p:extLst>
       <p:ext uri="{BB962C8B-B14F-4D97-AF65-F5344CB8AC3E}">
-        <p14:creationId xmlns:p14="http://schemas.microsoft.com/office/powerpoint/2010/main" val="944420812"/>
+        <p14:creationId xmlns:p14="http://schemas.microsoft.com/office/powerpoint/2010/main" val="1417498754"/>
       </p:ext>
     </p:extLst>
   </p:cSld>

</xml_diff>

<commit_message>
Switch demo link and materials to the Gemini deployment
Demo is now https://ascension-smartwalk.azamatbreach.workers.dev (Cloudflare
Workers, gemini-3.8-flash verified live). Slide 9, speaker notes, PDFs,
START-HERE and README no longer claim OpenAI/gpt-4.1-mini or chatgpt.site.
The deploy check is recorded in docs/runtime-verification.json.

Co-Authored-By: Claude Opus 5.5 (1M context) <noreply@anthropic.com>
Claude-Session: https://claude.ai/code/session_011TdGd5wn114yhfr9iJ7nhE
</commit_message>
<xml_diff>
--- a/deliverables/ascension-smartwalk-presentation.pptx
+++ b/deliverables/ascension-smartwalk-presentation.pptx
@@ -660,7 +660,7 @@
           <a:lstStyle xmlns:a="http://schemas.openxmlformats.org/drawingml/2006/main"/>
           <a:p xmlns:a="http://schemas.openxmlformats.org/drawingml/2006/main">
             <a:r>
-              <a:t>1:55-2:45. Итог data-чата: 930 канонических POI, 933 исходных OSM-объекта полностью сохранены в sourceRecords/osmIds/provenance, raw 1480. Из пяти кандидатных пар три подтверждены и объединены: MEGA, CoffeeStories, Ататюрк. CoffeeLike подтверждён как две разные точки по прямому комментарию OSM-маппера. ШашлычОк неоднозначен, объекты разных зданий оставлены раздельно. Абсолютное отсутствие дублей не заявляется. Категории: 318 кафе, 176 ресторанов, 34 парка, 8 музеев, 1 именованная площадка. Покрытие: EXPO/Mega 52, левый центр 226, исторический центр 256. Снимок данных 19.10.2026 11:22 UTC. Поиск лексический, без embeddings. Vanilla JS, Node API, Cloudflare Worker/OpenAI Responses/gpt-4.1-mini. Основная команда подтвердила реальный облачный POST 200 с generation.mode=llm, моделью gpt-4.1-mini и корпусом 930 POI. Это подтверждает проверенный вызов, а не безошибочность всех будущих ответов. Источник данных https://www.openstreetmap.org/copyright. Правила атрибуции https://osmfoundation.org/wiki/Attribution_Guidelines.</a:t>
+              <a:t>1:55-2:45. Итог data-чата: 930 канонических POI, 933 исходных OSM-объекта полностью сохранены в sourceRecords/osmIds/provenance, raw 1480. Из пяти кандидатных пар три подтверждены и объединены: MEGA, CoffeeStories, Ататюрк. CoffeeLike подтверждён как две разные точки по прямому комментарию OSM-маппера. ШашлычОк неоднозначен, объекты разных зданий оставлены раздельно. Абсолютное отсутствие дублей не заявляется. Категории: 318 кафе, 176 ресторанов, 34 парка, 8 музеев, 1 именованная площадка. Покрытие: EXPO/Mega 52, левый центр 226, исторический центр 256. Снимок данных 19.10.2026 11:22 UTC. Поиск лексический, без embeddings. Vanilla JS, Node API, Cloudflare Worker/Gemini API/gemini-3.8-flash (резерв: OpenAI). Реальный облачный POST подтверждён 200 с generation.mode=llm, моделью gemini-3.8-flash и корпусом 930 POI. Это подтверждает проверенный вызов, а не безошибочность всех будущих ответов. Источник данных https://www.openstreetmap.org/copyright. Правила атрибуции https://osmfoundation.org/wiki/Attribution_Guidelines.</a:t>
             </a:r>
           </a:p>
         </p:txBody>
@@ -1010,7 +1010,7 @@
           <a:lstStyle xmlns:a="http://schemas.openxmlformats.org/drawingml/2006/main"/>
           <a:p xmlns:a="http://schemas.openxmlformats.org/drawingml/2006/main">
             <a:r>
-              <a:t>5:35-6:20. Бизнес-гипотеза: полезный сервис для жителей и гостей с коротким свободным окном. Возможные партнёры: кампусы и места размещения гостей, договорённости не заявляются. Улучшить качество полей и времени пути, провести пилот. Не заявлять выручку, пользователей или измеренную длительность маршрутов. URL работает без логина по подтверждению основной команды: https://ascension-smartwalk-astana.azamatbreach.chatgpt.site . Облачный POST 200 с generation.mode=llm подтверждён. Исходный код опубликован: https://github.com/Azalytical/ascension-smartwalk, публичная структура с src/tests/data/docs/deliverables и README проверена через GitHub 19.10.2026. На защите использовать фактический прогон или его подлинную запись.</a:t>
+              <a:t>5:35-6:20. Бизнес-гипотеза: полезный сервис для жителей и гостей с коротким свободным окном. Возможные партнёры: кампусы и места размещения гостей, договорённости не заявляются. Улучшить качество полей и времени пути, провести пилот. Не заявлять выручку, пользователей или измеренную длительность маршрутов. URL работает без логина по подтверждению основной команды: https://ascension-smartwalk.azamatbreach.workers.dev . Облачный POST 200 с generation.mode=llm подтверждён. Исходный код опубликован: https://github.com/Azalytical/ascension-smartwalk, публичная структура с src/tests/data/docs/deliverables и README проверена через GitHub 19.10.2026. На защите использовать фактический прогон или его подлинную запись.</a:t>
             </a:r>
           </a:p>
         </p:txBody>
@@ -24233,7 +24233,7 @@
                 <a:ea typeface="Segoe UI"/>
                 <a:cs typeface="Segoe UI"/>
               </a:rPr>
-              <a:t>Демо: ascension-smartwalk-astana.azamatbreach.chatgpt.site</a:t>
+              <a:t>Демо: ascension-smartwalk.azamatbreach.workers.dev</a:t>
             </a:r>
           </a:p>
         </p:txBody>

</xml_diff>